<commit_message>
Drop classification footer, move page number to header, save deck tooling as a repo skill
- Remove the 'Restricted - مقيد' footer from every slide and the orphan footer dash
  from the content layout; lift the agenda title clear of the first card.
- Place the slide number at the left end of the title row on content slides and
  sub-dividers instead of the bottom-left corner.
- Add .claude/skills/qudratak-deck with the reusable python-pptx helper library,
  the full report build script, the 22-slide base template, icons/logos, and the
  approved layout conventions so future decks reuse them.
- Add docs/presentations/README.md with the Arabic changelog and design decisions.

Co-Authored-By: Claude Fable 5.1 <noreply@anthropic.com>
Claude-Session: https://claude.ai/code/session_01DqbpVeRtGUjuL1kQxRaNtp
</commit_message>
<xml_diff>
--- a/docs/presentations/qudratak-progress-report-jun-aug-2026.pptx
+++ b/docs/presentations/qudratak-progress-report-jun-aug-2026.pptx
@@ -1674,11 +1674,6 @@
               <a:t>الغرض: إطلاع القيادة على المنجز التراكمي مقابل مستهدف العام، وحالة المبادرات القائمة، والنقاط التي تتطلب قراراً أو دعماً.</a:t>
             </a:r>
           </a:p>
-          <a:p>
-            <a:r>
-              <a:t>التصنيف: مقيد – للاستخدام الداخلي.</a:t>
-            </a:r>
-          </a:p>
         </p:txBody>
       </p:sp>
     </p:spTree>
@@ -11069,49 +11064,6 @@
           </a:p>
         </p:txBody>
       </p:sp>
-      <p:cxnSp>
-        <p:nvCxnSpPr>
-          <p:cNvPr id="13" name="Straight Connector 12">
-            <a:extLst>
-              <a:ext uri="{FF2B5EF4-FFF2-40B4-BE49-F238E27FC236}">
-                <a16:creationId xmlns:a16="http://schemas.microsoft.com/office/drawing/2014/main" id="{C3020FC5-0604-4C0D-B7C1-3E6CDC6B3AE1}"/>
-              </a:ext>
-            </a:extLst>
-          </p:cNvPr>
-          <p:cNvCxnSpPr>
-            <a:cxnSpLocks/>
-          </p:cNvCxnSpPr>
-          <p:nvPr userDrawn="1"/>
-        </p:nvCxnSpPr>
-        <p:spPr>
-          <a:xfrm>
-            <a:off x="382635" y="6380480"/>
-            <a:ext cx="212814" cy="0"/>
-          </a:xfrm>
-          <a:prstGeom prst="line">
-            <a:avLst/>
-          </a:prstGeom>
-          <a:ln w="19050" cap="rnd">
-            <a:solidFill>
-              <a:schemeClr val="accent1"/>
-            </a:solidFill>
-          </a:ln>
-        </p:spPr>
-        <p:style>
-          <a:lnRef idx="1">
-            <a:schemeClr val="accent1"/>
-          </a:lnRef>
-          <a:fillRef idx="0">
-            <a:schemeClr val="accent1"/>
-          </a:fillRef>
-          <a:effectRef idx="0">
-            <a:schemeClr val="accent1"/>
-          </a:effectRef>
-          <a:fontRef idx="minor">
-            <a:schemeClr val="tx1"/>
-          </a:fontRef>
-        </p:style>
-      </p:cxnSp>
       <p:sp>
         <p:nvSpPr>
           <p:cNvPr id="22" name="Slide Number Placeholder 6">
@@ -13600,44 +13552,6 @@
           </a:p>
         </p:txBody>
       </p:sp>
-      <p:sp>
-        <p:nvSpPr>
-          <p:cNvPr id="2" name="SecloreFooter">
-            <a:extLst>
-              <a:ext uri="{FF2B5EF4-FFF2-40B4-BE49-F238E27FC236}">
-                <a16:creationId xmlns:a16="http://schemas.microsoft.com/office/drawing/2014/main" id="{2A282A1F-6A46-4227-8D54-376E4514F07E}"/>
-              </a:ext>
-            </a:extLst>
-          </p:cNvPr>
-          <p:cNvSpPr>
-            <a:spLocks noGrp="1"/>
-          </p:cNvSpPr>
-          <p:nvPr>
-            <p:ph type="ftr" sz="quarter" idx="10"/>
-          </p:nvPr>
-        </p:nvSpPr>
-        <p:spPr>
-          <a:xfrm>
-            <a:off x="0" y="5694680"/>
-            <a:ext cx="12192000" cy="649111"/>
-          </a:xfrm>
-        </p:spPr>
-        <p:txBody>
-          <a:bodyPr/>
-          <a:lstStyle/>
-          <a:p>
-            <a:r>
-              <a:rPr lang="en-US"/>
-              <a:t>Restricted - </a:t>
-            </a:r>
-            <a:r>
-              <a:rPr lang="ar-SA"/>
-              <a:t>مقيد</a:t>
-            </a:r>
-            <a:endParaRPr lang="en-US"/>
-          </a:p>
-        </p:txBody>
-      </p:sp>
     </p:spTree>
     <p:extLst>
       <p:ext uri="{BB962C8B-B14F-4D97-AF65-F5344CB8AC3E}">
@@ -13950,44 +13864,6 @@
       </p:sp>
       <p:sp>
         <p:nvSpPr>
-          <p:cNvPr id="3" name="SecloreFooter">
-            <a:extLst>
-              <a:ext uri="{FF2B5EF4-FFF2-40B4-BE49-F238E27FC236}">
-                <a16:creationId xmlns:a16="http://schemas.microsoft.com/office/drawing/2014/main" id="{E1B6FAD4-8A9C-42BF-97AD-94B7D08E3088}"/>
-              </a:ext>
-            </a:extLst>
-          </p:cNvPr>
-          <p:cNvSpPr>
-            <a:spLocks noGrp="1"/>
-          </p:cNvSpPr>
-          <p:nvPr>
-            <p:ph type="ftr" sz="quarter" idx="13"/>
-          </p:nvPr>
-        </p:nvSpPr>
-        <p:spPr>
-          <a:xfrm>
-            <a:off x="0" y="6464616"/>
-            <a:ext cx="12192000" cy="281378"/>
-          </a:xfrm>
-        </p:spPr>
-        <p:txBody>
-          <a:bodyPr/>
-          <a:lstStyle/>
-          <a:p>
-            <a:r>
-              <a:rPr lang="en-US" sz="1200"/>
-              <a:t>Restricted - </a:t>
-            </a:r>
-            <a:r>
-              <a:rPr lang="ar-SA" sz="1200"/>
-              <a:t>مقيد</a:t>
-            </a:r>
-            <a:endParaRPr lang="en-US" sz="1200"/>
-          </a:p>
-        </p:txBody>
-      </p:sp>
-      <p:sp>
-        <p:nvSpPr>
           <p:cNvPr id="9902" name="TextBox 9901"/>
           <p:cNvSpPr txBox="1"/>
           <p:nvPr/>
@@ -14382,15 +14258,15 @@
         </p:nvSpPr>
         <p:spPr>
           <a:xfrm>
-            <a:off x="227420" y="6498731"/>
-            <a:ext cx="467734" cy="206790"/>
-          </a:xfrm>
-        </p:spPr>
-        <p:txBody>
-          <a:bodyPr/>
-          <a:lstStyle/>
-          <a:p>
-            <a:pPr marL="0" marR="0" lvl="0" indent="0" algn="ctr" defTabSz="914400" rtl="0" eaLnBrk="1" fontAlgn="auto" latinLnBrk="0" hangingPunct="1">
+            <a:off x="411480" y="402336"/>
+            <a:ext cx="822960" cy="640080"/>
+          </a:xfrm>
+        </p:spPr>
+        <p:txBody>
+          <a:bodyPr anchor="ctr" lIns="0"/>
+          <a:lstStyle/>
+          <a:p>
+            <a:pPr marL="0" marR="0" lvl="0" indent="0" algn="l" defTabSz="914400" rtl="0" eaLnBrk="1" fontAlgn="auto" latinLnBrk="0" hangingPunct="1">
               <a:lnSpc>
                 <a:spcPct val="100000"/>
               </a:lnSpc>
@@ -14410,21 +14286,12 @@
               <a:defRPr/>
             </a:pPr>
             <a:fld id="{679EF615-E246-4FA6-9E75-123AAEB83405}" type="slidenum">
-              <a:rPr kumimoji="0" lang="en-PH" sz="900" b="0" i="0" u="none" strike="noStrike" kern="0" cap="none" spc="0" normalizeH="0" baseline="0" noProof="0" smtClean="0">
-                <a:ln>
-                  <a:noFill/>
-                </a:ln>
+              <a:rPr kumimoji="0" lang="en-US" sz="1200" b="1" i="0" u="none" strike="noStrike" kern="0" cap="none" spc="0" normalizeH="0" baseline="0" noProof="0" smtClean="0">
                 <a:solidFill>
-                  <a:prstClr val="white">
-                    <a:lumMod val="65000"/>
-                  </a:prstClr>
+                  <a:srgbClr val="2A206A"/>
                 </a:solidFill>
-                <a:effectLst/>
-                <a:uLnTx/>
-                <a:uFillTx/>
                 <a:latin typeface="DiodrumArabic-Semibold"/>
-                <a:cs typeface="Arial"/>
-                <a:sym typeface="Arial"/>
+                <a:cs typeface="DiodrumArabic-Semibold"/>
               </a:rPr>
               <a:pPr marL="0" marR="0" lvl="0" indent="0" algn="ctr" defTabSz="914400" rtl="0" eaLnBrk="1" fontAlgn="auto" latinLnBrk="0" hangingPunct="1">
                 <a:lnSpc>
@@ -14460,102 +14327,6 @@
               <a:uLnTx/>
               <a:uFillTx/>
               <a:latin typeface="DiodrumArabic-Semibold"/>
-              <a:cs typeface="Arial"/>
-              <a:sym typeface="Arial"/>
-            </a:endParaRPr>
-          </a:p>
-        </p:txBody>
-      </p:sp>
-      <p:sp>
-        <p:nvSpPr>
-          <p:cNvPr id="12" name="SecloreFooter">
-            <a:extLst>
-              <a:ext uri="{FF2B5EF4-FFF2-40B4-BE49-F238E27FC236}">
-                <a16:creationId xmlns:a16="http://schemas.microsoft.com/office/drawing/2014/main" id="{3256E98C-32DF-42DD-9307-7E10BBFC8907}"/>
-              </a:ext>
-            </a:extLst>
-          </p:cNvPr>
-          <p:cNvSpPr>
-            <a:spLocks noGrp="1"/>
-          </p:cNvSpPr>
-          <p:nvPr>
-            <p:ph type="ftr" sz="quarter" idx="13"/>
-          </p:nvPr>
-        </p:nvSpPr>
-        <p:spPr>
-          <a:xfrm>
-            <a:off x="0" y="6356352"/>
-            <a:ext cx="12192000" cy="365125"/>
-          </a:xfrm>
-        </p:spPr>
-        <p:txBody>
-          <a:bodyPr/>
-          <a:lstStyle/>
-          <a:p>
-            <a:pPr marL="0" marR="0" lvl="0" indent="0" algn="ctr" defTabSz="914400" rtl="0" eaLnBrk="1" fontAlgn="auto" latinLnBrk="0" hangingPunct="1">
-              <a:lnSpc>
-                <a:spcPct val="100000"/>
-              </a:lnSpc>
-              <a:spcBef>
-                <a:spcPts val="0"/>
-              </a:spcBef>
-              <a:spcAft>
-                <a:spcPts val="0"/>
-              </a:spcAft>
-              <a:buClr>
-                <a:srgbClr val="000000"/>
-              </a:buClr>
-              <a:buSzTx/>
-              <a:buFont typeface="Arial"/>
-              <a:buNone/>
-              <a:tabLst/>
-              <a:defRPr/>
-            </a:pPr>
-            <a:r>
-              <a:rPr kumimoji="0" lang="en-US" sz="1200" b="0" i="0" u="none" strike="noStrike" kern="0" cap="none" spc="0" normalizeH="0" baseline="0" noProof="0">
-                <a:ln>
-                  <a:noFill/>
-                </a:ln>
-                <a:solidFill>
-                  <a:srgbClr val="F0C231"/>
-                </a:solidFill>
-                <a:effectLst/>
-                <a:uLnTx/>
-                <a:uFillTx/>
-                <a:latin typeface="Arial"/>
-                <a:cs typeface="Arial"/>
-                <a:sym typeface="Arial"/>
-              </a:rPr>
-              <a:t>Restricted - </a:t>
-            </a:r>
-            <a:r>
-              <a:rPr kumimoji="0" lang="ar-SA" sz="1200" b="0" i="0" u="none" strike="noStrike" kern="0" cap="none" spc="0" normalizeH="0" baseline="0" noProof="0">
-                <a:ln>
-                  <a:noFill/>
-                </a:ln>
-                <a:solidFill>
-                  <a:srgbClr val="F0C231"/>
-                </a:solidFill>
-                <a:effectLst/>
-                <a:uLnTx/>
-                <a:uFillTx/>
-                <a:latin typeface="Arial"/>
-                <a:cs typeface="Arial"/>
-                <a:sym typeface="Arial"/>
-              </a:rPr>
-              <a:t>مقيد</a:t>
-            </a:r>
-            <a:endParaRPr kumimoji="0" lang="en-US" sz="1200" b="0" i="0" u="none" strike="noStrike" kern="0" cap="none" spc="0" normalizeH="0" baseline="0" noProof="0">
-              <a:ln>
-                <a:noFill/>
-              </a:ln>
-              <a:solidFill>
-                <a:srgbClr val="F0C231"/>
-              </a:solidFill>
-              <a:effectLst/>
-              <a:uLnTx/>
-              <a:uFillTx/>
-              <a:latin typeface="Arial"/>
               <a:cs typeface="Arial"/>
               <a:sym typeface="Arial"/>
             </a:endParaRPr>
@@ -14649,44 +14420,6 @@
       </p:grpSpPr>
       <p:sp>
         <p:nvSpPr>
-          <p:cNvPr id="3" name="SecloreFooter">
-            <a:extLst>
-              <a:ext uri="{FF2B5EF4-FFF2-40B4-BE49-F238E27FC236}">
-                <a16:creationId xmlns:a16="http://schemas.microsoft.com/office/drawing/2014/main" id="{58F27995-F8CF-D37B-0D81-FE8260A14265}"/>
-              </a:ext>
-            </a:extLst>
-          </p:cNvPr>
-          <p:cNvSpPr>
-            <a:spLocks noGrp="1"/>
-          </p:cNvSpPr>
-          <p:nvPr>
-            <p:ph type="ftr" sz="quarter" idx="13"/>
-          </p:nvPr>
-        </p:nvSpPr>
-        <p:spPr>
-          <a:xfrm>
-            <a:off x="0" y="6356352"/>
-            <a:ext cx="12192000" cy="365125"/>
-          </a:xfrm>
-        </p:spPr>
-        <p:txBody>
-          <a:bodyPr/>
-          <a:lstStyle/>
-          <a:p>
-            <a:r>
-              <a:rPr lang="en-US"/>
-              <a:t>Restricted - </a:t>
-            </a:r>
-            <a:r>
-              <a:rPr lang="ar-SA"/>
-              <a:t>مقيد</a:t>
-            </a:r>
-            <a:endParaRPr lang="en-US" dirty="0"/>
-          </a:p>
-        </p:txBody>
-      </p:sp>
-      <p:sp>
-        <p:nvSpPr>
           <p:cNvPr id="2" name="Slide Number Placeholder 1">
             <a:extLst>
               <a:ext uri="{FF2B5EF4-FFF2-40B4-BE49-F238E27FC236}">
@@ -14701,13 +14434,25 @@
             <p:ph type="sldNum" sz="quarter" idx="12"/>
           </p:nvPr>
         </p:nvSpPr>
-        <p:spPr/>
-        <p:txBody>
-          <a:bodyPr/>
-          <a:lstStyle/>
-          <a:p>
+        <p:spPr>
+          <a:xfrm>
+            <a:off x="411480" y="155448"/>
+            <a:ext cx="822960" cy="548640"/>
+          </a:xfrm>
+        </p:spPr>
+        <p:txBody>
+          <a:bodyPr anchor="ctr" lIns="0"/>
+          <a:lstStyle/>
+          <a:p>
+            <a:pPr algn="l"/>
             <a:fld id="{679EF615-E246-4FA6-9E75-123AAEB83405}" type="slidenum">
-              <a:rPr lang="en-PH" smtClean="0"/>
+              <a:rPr lang="en-US" smtClean="0" sz="1200" b="1">
+                <a:solidFill>
+                  <a:srgbClr val="2A206A"/>
+                </a:solidFill>
+                <a:latin typeface="DiodrumArabic-Semibold"/>
+                <a:cs typeface="DiodrumArabic-Semibold"/>
+              </a:rPr>
               <a:pPr/>
               <a:t>10</a:t>
             </a:fld>
@@ -14717,14 +14462,14 @@
       </p:sp>
       <p:sp>
         <p:nvSpPr>
-          <p:cNvPr id="4" name="TextBox 3"/>
+          <p:cNvPr id="3" name="TextBox 2"/>
           <p:cNvSpPr txBox="1"/>
           <p:nvPr/>
         </p:nvSpPr>
         <p:spPr>
           <a:xfrm>
-            <a:off x="411480" y="155448"/>
-            <a:ext cx="11384280" cy="548640"/>
+            <a:off x="1234440" y="155448"/>
+            <a:ext cx="10561320" cy="548640"/>
           </a:xfrm>
           <a:prstGeom prst="rect">
             <a:avLst/>
@@ -14764,7 +14509,7 @@
       </p:sp>
       <p:cxnSp>
         <p:nvCxnSpPr>
-          <p:cNvPr id="5" name="Connector 4"/>
+          <p:cNvPr id="4" name="Connector 3"/>
           <p:cNvCxnSpPr/>
           <p:nvPr/>
         </p:nvCxnSpPr>
@@ -14793,7 +14538,7 @@
       </p:cxnSp>
       <p:sp>
         <p:nvSpPr>
-          <p:cNvPr id="6" name="Rounded Rectangle 5"/>
+          <p:cNvPr id="5" name="Rounded Rectangle 4"/>
           <p:cNvSpPr/>
           <p:nvPr/>
         </p:nvSpPr>
@@ -14837,7 +14582,7 @@
       </p:sp>
       <p:sp>
         <p:nvSpPr>
-          <p:cNvPr id="7" name="TextBox 6"/>
+          <p:cNvPr id="6" name="TextBox 5"/>
           <p:cNvSpPr txBox="1"/>
           <p:nvPr/>
         </p:nvSpPr>
@@ -14878,7 +14623,7 @@
       </p:sp>
       <p:pic>
         <p:nvPicPr>
-          <p:cNvPr id="8" name="Picture 7" descr="mcit_logo.png"/>
+          <p:cNvPr id="7" name="Picture 6" descr="mcit_logo.png"/>
           <p:cNvPicPr>
             <a:picLocks noChangeAspect="1"/>
           </p:cNvPicPr>
@@ -14902,7 +14647,7 @@
       </p:pic>
       <p:sp>
         <p:nvSpPr>
-          <p:cNvPr id="9" name="TextBox 8"/>
+          <p:cNvPr id="8" name="TextBox 7"/>
           <p:cNvSpPr txBox="1"/>
           <p:nvPr/>
         </p:nvSpPr>
@@ -14939,7 +14684,7 @@
       </p:sp>
       <p:sp>
         <p:nvSpPr>
-          <p:cNvPr id="10" name="Rounded Rectangle 9"/>
+          <p:cNvPr id="9" name="Rounded Rectangle 8"/>
           <p:cNvSpPr/>
           <p:nvPr/>
         </p:nvSpPr>
@@ -14977,7 +14722,7 @@
       </p:sp>
       <p:sp>
         <p:nvSpPr>
-          <p:cNvPr id="11" name="Rounded Rectangle 10"/>
+          <p:cNvPr id="10" name="Rounded Rectangle 9"/>
           <p:cNvSpPr/>
           <p:nvPr/>
         </p:nvSpPr>
@@ -15014,7 +14759,7 @@
       </p:sp>
       <p:sp>
         <p:nvSpPr>
-          <p:cNvPr id="12" name="TextBox 11"/>
+          <p:cNvPr id="11" name="TextBox 10"/>
           <p:cNvSpPr txBox="1"/>
           <p:nvPr/>
         </p:nvSpPr>
@@ -15072,7 +14817,7 @@
       </p:sp>
       <p:sp>
         <p:nvSpPr>
-          <p:cNvPr id="13" name="TextBox 12"/>
+          <p:cNvPr id="12" name="TextBox 11"/>
           <p:cNvSpPr txBox="1"/>
           <p:nvPr/>
         </p:nvSpPr>
@@ -15123,7 +14868,7 @@
       </p:sp>
       <p:sp>
         <p:nvSpPr>
-          <p:cNvPr id="14" name="TextBox 13"/>
+          <p:cNvPr id="13" name="TextBox 12"/>
           <p:cNvSpPr txBox="1"/>
           <p:nvPr/>
         </p:nvSpPr>
@@ -15174,7 +14919,7 @@
       </p:sp>
       <p:sp>
         <p:nvSpPr>
-          <p:cNvPr id="15" name="Rounded Rectangle 14"/>
+          <p:cNvPr id="14" name="Rounded Rectangle 13"/>
           <p:cNvSpPr/>
           <p:nvPr/>
         </p:nvSpPr>
@@ -15217,7 +14962,7 @@
       </p:sp>
       <p:sp>
         <p:nvSpPr>
-          <p:cNvPr id="16" name="Oval 15"/>
+          <p:cNvPr id="15" name="Oval 14"/>
           <p:cNvSpPr/>
           <p:nvPr/>
         </p:nvSpPr>
@@ -15246,7 +14991,7 @@
       </p:sp>
       <p:sp>
         <p:nvSpPr>
-          <p:cNvPr id="17" name="Rounded Rectangle 16"/>
+          <p:cNvPr id="16" name="Rounded Rectangle 15"/>
           <p:cNvSpPr/>
           <p:nvPr/>
         </p:nvSpPr>
@@ -15284,7 +15029,7 @@
       </p:sp>
       <p:sp>
         <p:nvSpPr>
-          <p:cNvPr id="18" name="Rounded Rectangle 17"/>
+          <p:cNvPr id="17" name="Rounded Rectangle 16"/>
           <p:cNvSpPr/>
           <p:nvPr/>
         </p:nvSpPr>
@@ -15321,7 +15066,7 @@
       </p:sp>
       <p:sp>
         <p:nvSpPr>
-          <p:cNvPr id="19" name="TextBox 18"/>
+          <p:cNvPr id="18" name="TextBox 17"/>
           <p:cNvSpPr txBox="1"/>
           <p:nvPr/>
         </p:nvSpPr>
@@ -15379,7 +15124,7 @@
       </p:sp>
       <p:sp>
         <p:nvSpPr>
-          <p:cNvPr id="20" name="TextBox 19"/>
+          <p:cNvPr id="19" name="TextBox 18"/>
           <p:cNvSpPr txBox="1"/>
           <p:nvPr/>
         </p:nvSpPr>
@@ -15430,7 +15175,7 @@
       </p:sp>
       <p:sp>
         <p:nvSpPr>
-          <p:cNvPr id="21" name="TextBox 20"/>
+          <p:cNvPr id="20" name="TextBox 19"/>
           <p:cNvSpPr txBox="1"/>
           <p:nvPr/>
         </p:nvSpPr>
@@ -15481,7 +15226,7 @@
       </p:sp>
       <p:sp>
         <p:nvSpPr>
-          <p:cNvPr id="22" name="Rounded Rectangle 21"/>
+          <p:cNvPr id="21" name="Rounded Rectangle 20"/>
           <p:cNvSpPr/>
           <p:nvPr/>
         </p:nvSpPr>
@@ -15524,7 +15269,7 @@
       </p:sp>
       <p:sp>
         <p:nvSpPr>
-          <p:cNvPr id="23" name="Oval 22"/>
+          <p:cNvPr id="22" name="Oval 21"/>
           <p:cNvSpPr/>
           <p:nvPr/>
         </p:nvSpPr>
@@ -15553,7 +15298,7 @@
       </p:sp>
       <p:sp>
         <p:nvSpPr>
-          <p:cNvPr id="24" name="Rounded Rectangle 23"/>
+          <p:cNvPr id="23" name="Rounded Rectangle 22"/>
           <p:cNvSpPr/>
           <p:nvPr/>
         </p:nvSpPr>
@@ -15591,7 +15336,7 @@
       </p:sp>
       <p:sp>
         <p:nvSpPr>
-          <p:cNvPr id="25" name="Rounded Rectangle 24"/>
+          <p:cNvPr id="24" name="Rounded Rectangle 23"/>
           <p:cNvSpPr/>
           <p:nvPr/>
         </p:nvSpPr>
@@ -15628,7 +15373,7 @@
       </p:sp>
       <p:sp>
         <p:nvSpPr>
-          <p:cNvPr id="26" name="TextBox 25"/>
+          <p:cNvPr id="25" name="TextBox 24"/>
           <p:cNvSpPr txBox="1"/>
           <p:nvPr/>
         </p:nvSpPr>
@@ -15686,7 +15431,7 @@
       </p:sp>
       <p:sp>
         <p:nvSpPr>
-          <p:cNvPr id="27" name="TextBox 26"/>
+          <p:cNvPr id="26" name="TextBox 25"/>
           <p:cNvSpPr txBox="1"/>
           <p:nvPr/>
         </p:nvSpPr>
@@ -15737,7 +15482,7 @@
       </p:sp>
       <p:sp>
         <p:nvSpPr>
-          <p:cNvPr id="28" name="TextBox 27"/>
+          <p:cNvPr id="27" name="TextBox 26"/>
           <p:cNvSpPr txBox="1"/>
           <p:nvPr/>
         </p:nvSpPr>
@@ -15788,7 +15533,7 @@
       </p:sp>
       <p:sp>
         <p:nvSpPr>
-          <p:cNvPr id="29" name="Rounded Rectangle 28"/>
+          <p:cNvPr id="28" name="Rounded Rectangle 27"/>
           <p:cNvSpPr/>
           <p:nvPr/>
         </p:nvSpPr>
@@ -15831,7 +15576,7 @@
       </p:sp>
       <p:sp>
         <p:nvSpPr>
-          <p:cNvPr id="30" name="Oval 29"/>
+          <p:cNvPr id="29" name="Oval 28"/>
           <p:cNvSpPr/>
           <p:nvPr/>
         </p:nvSpPr>
@@ -15860,7 +15605,7 @@
       </p:sp>
       <p:sp>
         <p:nvSpPr>
-          <p:cNvPr id="31" name="Rounded Rectangle 30"/>
+          <p:cNvPr id="30" name="Rounded Rectangle 29"/>
           <p:cNvSpPr/>
           <p:nvPr/>
         </p:nvSpPr>
@@ -15891,7 +15636,7 @@
       </p:sp>
       <p:sp>
         <p:nvSpPr>
-          <p:cNvPr id="32" name="TextBox 31"/>
+          <p:cNvPr id="31" name="TextBox 30"/>
           <p:cNvSpPr txBox="1"/>
           <p:nvPr/>
         </p:nvSpPr>
@@ -16307,15 +16052,15 @@
         </p:nvSpPr>
         <p:spPr>
           <a:xfrm>
-            <a:off x="227420" y="6498731"/>
-            <a:ext cx="467734" cy="206790"/>
-          </a:xfrm>
-        </p:spPr>
-        <p:txBody>
-          <a:bodyPr/>
-          <a:lstStyle/>
-          <a:p>
-            <a:pPr marL="0" marR="0" lvl="0" indent="0" algn="ctr" defTabSz="914400" rtl="0" eaLnBrk="1" fontAlgn="auto" latinLnBrk="0" hangingPunct="1">
+            <a:off x="411480" y="402336"/>
+            <a:ext cx="822960" cy="640080"/>
+          </a:xfrm>
+        </p:spPr>
+        <p:txBody>
+          <a:bodyPr anchor="ctr" lIns="0"/>
+          <a:lstStyle/>
+          <a:p>
+            <a:pPr marL="0" marR="0" lvl="0" indent="0" algn="l" defTabSz="914400" rtl="0" eaLnBrk="1" fontAlgn="auto" latinLnBrk="0" hangingPunct="1">
               <a:lnSpc>
                 <a:spcPct val="100000"/>
               </a:lnSpc>
@@ -16335,21 +16080,12 @@
               <a:defRPr/>
             </a:pPr>
             <a:fld id="{679EF615-E246-4FA6-9E75-123AAEB83405}" type="slidenum">
-              <a:rPr kumimoji="0" lang="en-PH" sz="900" b="0" i="0" u="none" strike="noStrike" kern="0" cap="none" spc="0" normalizeH="0" baseline="0" noProof="0" smtClean="0">
-                <a:ln>
-                  <a:noFill/>
-                </a:ln>
+              <a:rPr kumimoji="0" lang="en-US" sz="1200" b="1" i="0" u="none" strike="noStrike" kern="0" cap="none" spc="0" normalizeH="0" baseline="0" noProof="0" smtClean="0">
                 <a:solidFill>
-                  <a:prstClr val="white">
-                    <a:lumMod val="65000"/>
-                  </a:prstClr>
+                  <a:srgbClr val="2A206A"/>
                 </a:solidFill>
-                <a:effectLst/>
-                <a:uLnTx/>
-                <a:uFillTx/>
                 <a:latin typeface="DiodrumArabic-Semibold"/>
-                <a:cs typeface="Arial"/>
-                <a:sym typeface="Arial"/>
+                <a:cs typeface="DiodrumArabic-Semibold"/>
               </a:rPr>
               <a:pPr marL="0" marR="0" lvl="0" indent="0" algn="ctr" defTabSz="914400" rtl="0" eaLnBrk="1" fontAlgn="auto" latinLnBrk="0" hangingPunct="1">
                 <a:lnSpc>
@@ -16385,102 +16121,6 @@
               <a:uLnTx/>
               <a:uFillTx/>
               <a:latin typeface="DiodrumArabic-Semibold"/>
-              <a:cs typeface="Arial"/>
-              <a:sym typeface="Arial"/>
-            </a:endParaRPr>
-          </a:p>
-        </p:txBody>
-      </p:sp>
-      <p:sp>
-        <p:nvSpPr>
-          <p:cNvPr id="12" name="SecloreFooter">
-            <a:extLst>
-              <a:ext uri="{FF2B5EF4-FFF2-40B4-BE49-F238E27FC236}">
-                <a16:creationId xmlns:a16="http://schemas.microsoft.com/office/drawing/2014/main" id="{3256E98C-32DF-42DD-9307-7E10BBFC8907}"/>
-              </a:ext>
-            </a:extLst>
-          </p:cNvPr>
-          <p:cNvSpPr>
-            <a:spLocks noGrp="1"/>
-          </p:cNvSpPr>
-          <p:nvPr>
-            <p:ph type="ftr" sz="quarter" idx="13"/>
-          </p:nvPr>
-        </p:nvSpPr>
-        <p:spPr>
-          <a:xfrm>
-            <a:off x="0" y="6356352"/>
-            <a:ext cx="12192000" cy="365125"/>
-          </a:xfrm>
-        </p:spPr>
-        <p:txBody>
-          <a:bodyPr/>
-          <a:lstStyle/>
-          <a:p>
-            <a:pPr marL="0" marR="0" lvl="0" indent="0" algn="ctr" defTabSz="914400" rtl="0" eaLnBrk="1" fontAlgn="auto" latinLnBrk="0" hangingPunct="1">
-              <a:lnSpc>
-                <a:spcPct val="100000"/>
-              </a:lnSpc>
-              <a:spcBef>
-                <a:spcPts val="0"/>
-              </a:spcBef>
-              <a:spcAft>
-                <a:spcPts val="0"/>
-              </a:spcAft>
-              <a:buClr>
-                <a:srgbClr val="000000"/>
-              </a:buClr>
-              <a:buSzTx/>
-              <a:buFont typeface="Arial"/>
-              <a:buNone/>
-              <a:tabLst/>
-              <a:defRPr/>
-            </a:pPr>
-            <a:r>
-              <a:rPr kumimoji="0" lang="en-US" sz="1200" b="0" i="0" u="none" strike="noStrike" kern="0" cap="none" spc="0" normalizeH="0" baseline="0" noProof="0">
-                <a:ln>
-                  <a:noFill/>
-                </a:ln>
-                <a:solidFill>
-                  <a:srgbClr val="F0C231"/>
-                </a:solidFill>
-                <a:effectLst/>
-                <a:uLnTx/>
-                <a:uFillTx/>
-                <a:latin typeface="Arial"/>
-                <a:cs typeface="Arial"/>
-                <a:sym typeface="Arial"/>
-              </a:rPr>
-              <a:t>Restricted - </a:t>
-            </a:r>
-            <a:r>
-              <a:rPr kumimoji="0" lang="ar-SA" sz="1200" b="0" i="0" u="none" strike="noStrike" kern="0" cap="none" spc="0" normalizeH="0" baseline="0" noProof="0">
-                <a:ln>
-                  <a:noFill/>
-                </a:ln>
-                <a:solidFill>
-                  <a:srgbClr val="F0C231"/>
-                </a:solidFill>
-                <a:effectLst/>
-                <a:uLnTx/>
-                <a:uFillTx/>
-                <a:latin typeface="Arial"/>
-                <a:cs typeface="Arial"/>
-                <a:sym typeface="Arial"/>
-              </a:rPr>
-              <a:t>مقيد</a:t>
-            </a:r>
-            <a:endParaRPr kumimoji="0" lang="en-US" sz="1200" b="0" i="0" u="none" strike="noStrike" kern="0" cap="none" spc="0" normalizeH="0" baseline="0" noProof="0">
-              <a:ln>
-                <a:noFill/>
-              </a:ln>
-              <a:solidFill>
-                <a:srgbClr val="F0C231"/>
-              </a:solidFill>
-              <a:effectLst/>
-              <a:uLnTx/>
-              <a:uFillTx/>
-              <a:latin typeface="Arial"/>
               <a:cs typeface="Arial"/>
               <a:sym typeface="Arial"/>
             </a:endParaRPr>
@@ -16588,13 +16228,25 @@
             <p:ph type="sldNum" sz="quarter" idx="12"/>
           </p:nvPr>
         </p:nvSpPr>
-        <p:spPr/>
-        <p:txBody>
-          <a:bodyPr/>
-          <a:lstStyle/>
-          <a:p>
+        <p:spPr>
+          <a:xfrm>
+            <a:off x="411480" y="155448"/>
+            <a:ext cx="822960" cy="548640"/>
+          </a:xfrm>
+        </p:spPr>
+        <p:txBody>
+          <a:bodyPr anchor="ctr" lIns="0"/>
+          <a:lstStyle/>
+          <a:p>
+            <a:pPr algn="l"/>
             <a:fld id="{679EF615-E246-4FA6-9E75-123AAEB83405}" type="slidenum">
-              <a:rPr lang="en-PH" smtClean="0"/>
+              <a:rPr lang="en-US" smtClean="0" sz="1200" b="1">
+                <a:solidFill>
+                  <a:srgbClr val="2A206A"/>
+                </a:solidFill>
+                <a:latin typeface="DiodrumArabic-Semibold"/>
+                <a:cs typeface="DiodrumArabic-Semibold"/>
+              </a:rPr>
               <a:pPr/>
               <a:t>12</a:t>
             </a:fld>
@@ -16604,52 +16256,14 @@
       </p:sp>
       <p:sp>
         <p:nvSpPr>
-          <p:cNvPr id="8" name="SecloreFooter">
-            <a:extLst>
-              <a:ext uri="{FF2B5EF4-FFF2-40B4-BE49-F238E27FC236}">
-                <a16:creationId xmlns:a16="http://schemas.microsoft.com/office/drawing/2014/main" id="{DD17BC2C-964A-4ACC-A3DE-5525E46160F2}"/>
-              </a:ext>
-            </a:extLst>
-          </p:cNvPr>
-          <p:cNvSpPr>
-            <a:spLocks noGrp="1"/>
-          </p:cNvSpPr>
-          <p:nvPr>
-            <p:ph type="ftr" sz="quarter" idx="13"/>
-          </p:nvPr>
-        </p:nvSpPr>
-        <p:spPr>
-          <a:xfrm>
-            <a:off x="0" y="6356352"/>
-            <a:ext cx="12192000" cy="365125"/>
-          </a:xfrm>
-        </p:spPr>
-        <p:txBody>
-          <a:bodyPr/>
-          <a:lstStyle/>
-          <a:p>
-            <a:r>
-              <a:rPr lang="en-US"/>
-              <a:t>Restricted - </a:t>
-            </a:r>
-            <a:r>
-              <a:rPr lang="ar-SA"/>
-              <a:t>مقيد</a:t>
-            </a:r>
-            <a:endParaRPr lang="en-US"/>
-          </a:p>
-        </p:txBody>
-      </p:sp>
-      <p:sp>
-        <p:nvSpPr>
-          <p:cNvPr id="9" name="TextBox 8"/>
+          <p:cNvPr id="3" name="TextBox 2"/>
           <p:cNvSpPr txBox="1"/>
           <p:nvPr/>
         </p:nvSpPr>
         <p:spPr>
           <a:xfrm>
-            <a:off x="411480" y="155448"/>
-            <a:ext cx="11384280" cy="548640"/>
+            <a:off x="1234440" y="155448"/>
+            <a:ext cx="10561320" cy="548640"/>
           </a:xfrm>
           <a:prstGeom prst="rect">
             <a:avLst/>
@@ -16689,7 +16303,7 @@
       </p:sp>
       <p:cxnSp>
         <p:nvCxnSpPr>
-          <p:cNvPr id="10" name="Connector 9"/>
+          <p:cNvPr id="4" name="Connector 3"/>
           <p:cNvCxnSpPr/>
           <p:nvPr/>
         </p:nvCxnSpPr>
@@ -16718,7 +16332,7 @@
       </p:cxnSp>
       <p:sp>
         <p:nvSpPr>
-          <p:cNvPr id="11" name="Rounded Rectangle 10"/>
+          <p:cNvPr id="5" name="Rounded Rectangle 4"/>
           <p:cNvSpPr/>
           <p:nvPr/>
         </p:nvSpPr>
@@ -16762,7 +16376,7 @@
       </p:sp>
       <p:sp>
         <p:nvSpPr>
-          <p:cNvPr id="12" name="TextBox 11"/>
+          <p:cNvPr id="6" name="TextBox 5"/>
           <p:cNvSpPr txBox="1"/>
           <p:nvPr/>
         </p:nvSpPr>
@@ -16803,7 +16417,7 @@
       </p:sp>
       <p:sp>
         <p:nvSpPr>
-          <p:cNvPr id="13" name="TextBox 12"/>
+          <p:cNvPr id="7" name="TextBox 6"/>
           <p:cNvSpPr txBox="1"/>
           <p:nvPr/>
         </p:nvSpPr>
@@ -16840,7 +16454,7 @@
       </p:sp>
       <p:cxnSp>
         <p:nvCxnSpPr>
-          <p:cNvPr id="14" name="Connector 13"/>
+          <p:cNvPr id="8" name="Connector 7"/>
           <p:cNvCxnSpPr/>
           <p:nvPr/>
         </p:nvCxnSpPr>
@@ -16861,7 +16475,7 @@
       </p:cxnSp>
       <p:sp>
         <p:nvSpPr>
-          <p:cNvPr id="15" name="Oval 14"/>
+          <p:cNvPr id="9" name="Oval 8"/>
           <p:cNvSpPr/>
           <p:nvPr/>
         </p:nvSpPr>
@@ -16892,7 +16506,7 @@
       </p:sp>
       <p:sp>
         <p:nvSpPr>
-          <p:cNvPr id="16" name="TextBox 15"/>
+          <p:cNvPr id="10" name="TextBox 9"/>
           <p:cNvSpPr txBox="1"/>
           <p:nvPr/>
         </p:nvSpPr>
@@ -16929,7 +16543,7 @@
       </p:sp>
       <p:sp>
         <p:nvSpPr>
-          <p:cNvPr id="17" name="TextBox 16"/>
+          <p:cNvPr id="11" name="TextBox 10"/>
           <p:cNvSpPr txBox="1"/>
           <p:nvPr/>
         </p:nvSpPr>
@@ -16970,7 +16584,7 @@
       </p:sp>
       <p:sp>
         <p:nvSpPr>
-          <p:cNvPr id="18" name="Oval 17"/>
+          <p:cNvPr id="12" name="Oval 11"/>
           <p:cNvSpPr/>
           <p:nvPr/>
         </p:nvSpPr>
@@ -17001,7 +16615,7 @@
       </p:sp>
       <p:sp>
         <p:nvSpPr>
-          <p:cNvPr id="19" name="TextBox 18"/>
+          <p:cNvPr id="13" name="TextBox 12"/>
           <p:cNvSpPr txBox="1"/>
           <p:nvPr/>
         </p:nvSpPr>
@@ -17038,7 +16652,7 @@
       </p:sp>
       <p:sp>
         <p:nvSpPr>
-          <p:cNvPr id="20" name="TextBox 19"/>
+          <p:cNvPr id="14" name="TextBox 13"/>
           <p:cNvSpPr txBox="1"/>
           <p:nvPr/>
         </p:nvSpPr>
@@ -17079,7 +16693,7 @@
       </p:sp>
       <p:sp>
         <p:nvSpPr>
-          <p:cNvPr id="21" name="Oval 20"/>
+          <p:cNvPr id="15" name="Oval 14"/>
           <p:cNvSpPr/>
           <p:nvPr/>
         </p:nvSpPr>
@@ -17110,7 +16724,7 @@
       </p:sp>
       <p:sp>
         <p:nvSpPr>
-          <p:cNvPr id="22" name="TextBox 21"/>
+          <p:cNvPr id="16" name="TextBox 15"/>
           <p:cNvSpPr txBox="1"/>
           <p:nvPr/>
         </p:nvSpPr>
@@ -17147,7 +16761,7 @@
       </p:sp>
       <p:sp>
         <p:nvSpPr>
-          <p:cNvPr id="23" name="TextBox 22"/>
+          <p:cNvPr id="17" name="TextBox 16"/>
           <p:cNvSpPr txBox="1"/>
           <p:nvPr/>
         </p:nvSpPr>
@@ -17188,7 +16802,7 @@
       </p:sp>
       <p:sp>
         <p:nvSpPr>
-          <p:cNvPr id="24" name="Oval 23"/>
+          <p:cNvPr id="18" name="Oval 17"/>
           <p:cNvSpPr/>
           <p:nvPr/>
         </p:nvSpPr>
@@ -17219,7 +16833,7 @@
       </p:sp>
       <p:sp>
         <p:nvSpPr>
-          <p:cNvPr id="25" name="TextBox 24"/>
+          <p:cNvPr id="19" name="TextBox 18"/>
           <p:cNvSpPr txBox="1"/>
           <p:nvPr/>
         </p:nvSpPr>
@@ -17256,7 +16870,7 @@
       </p:sp>
       <p:sp>
         <p:nvSpPr>
-          <p:cNvPr id="26" name="TextBox 25"/>
+          <p:cNvPr id="20" name="TextBox 19"/>
           <p:cNvSpPr txBox="1"/>
           <p:nvPr/>
         </p:nvSpPr>
@@ -17297,7 +16911,7 @@
       </p:sp>
       <p:sp>
         <p:nvSpPr>
-          <p:cNvPr id="27" name="Oval 26"/>
+          <p:cNvPr id="21" name="Oval 20"/>
           <p:cNvSpPr/>
           <p:nvPr/>
         </p:nvSpPr>
@@ -17328,7 +16942,7 @@
       </p:sp>
       <p:sp>
         <p:nvSpPr>
-          <p:cNvPr id="28" name="TextBox 27"/>
+          <p:cNvPr id="22" name="TextBox 21"/>
           <p:cNvSpPr txBox="1"/>
           <p:nvPr/>
         </p:nvSpPr>
@@ -17365,7 +16979,7 @@
       </p:sp>
       <p:sp>
         <p:nvSpPr>
-          <p:cNvPr id="29" name="TextBox 28"/>
+          <p:cNvPr id="23" name="TextBox 22"/>
           <p:cNvSpPr txBox="1"/>
           <p:nvPr/>
         </p:nvSpPr>
@@ -17406,7 +17020,7 @@
       </p:sp>
       <p:sp>
         <p:nvSpPr>
-          <p:cNvPr id="30" name="Oval 29"/>
+          <p:cNvPr id="24" name="Oval 23"/>
           <p:cNvSpPr/>
           <p:nvPr/>
         </p:nvSpPr>
@@ -17437,7 +17051,7 @@
       </p:sp>
       <p:sp>
         <p:nvSpPr>
-          <p:cNvPr id="31" name="TextBox 30"/>
+          <p:cNvPr id="25" name="TextBox 24"/>
           <p:cNvSpPr txBox="1"/>
           <p:nvPr/>
         </p:nvSpPr>
@@ -17474,7 +17088,7 @@
       </p:sp>
       <p:sp>
         <p:nvSpPr>
-          <p:cNvPr id="32" name="TextBox 31"/>
+          <p:cNvPr id="26" name="TextBox 25"/>
           <p:cNvSpPr txBox="1"/>
           <p:nvPr/>
         </p:nvSpPr>
@@ -17515,7 +17129,7 @@
       </p:sp>
       <p:sp>
         <p:nvSpPr>
-          <p:cNvPr id="33" name="Oval 32"/>
+          <p:cNvPr id="27" name="Oval 26"/>
           <p:cNvSpPr/>
           <p:nvPr/>
         </p:nvSpPr>
@@ -17546,7 +17160,7 @@
       </p:sp>
       <p:sp>
         <p:nvSpPr>
-          <p:cNvPr id="34" name="TextBox 33"/>
+          <p:cNvPr id="28" name="TextBox 27"/>
           <p:cNvSpPr txBox="1"/>
           <p:nvPr/>
         </p:nvSpPr>
@@ -17583,7 +17197,7 @@
       </p:sp>
       <p:sp>
         <p:nvSpPr>
-          <p:cNvPr id="35" name="TextBox 34"/>
+          <p:cNvPr id="29" name="TextBox 28"/>
           <p:cNvSpPr txBox="1"/>
           <p:nvPr/>
         </p:nvSpPr>
@@ -17624,7 +17238,7 @@
       </p:sp>
       <p:sp>
         <p:nvSpPr>
-          <p:cNvPr id="36" name="Oval 35"/>
+          <p:cNvPr id="30" name="Oval 29"/>
           <p:cNvSpPr/>
           <p:nvPr/>
         </p:nvSpPr>
@@ -17655,7 +17269,7 @@
       </p:sp>
       <p:sp>
         <p:nvSpPr>
-          <p:cNvPr id="37" name="TextBox 36"/>
+          <p:cNvPr id="31" name="TextBox 30"/>
           <p:cNvSpPr txBox="1"/>
           <p:nvPr/>
         </p:nvSpPr>
@@ -17692,7 +17306,7 @@
       </p:sp>
       <p:sp>
         <p:nvSpPr>
-          <p:cNvPr id="38" name="TextBox 37"/>
+          <p:cNvPr id="32" name="TextBox 31"/>
           <p:cNvSpPr txBox="1"/>
           <p:nvPr/>
         </p:nvSpPr>
@@ -17733,7 +17347,7 @@
       </p:sp>
       <p:sp>
         <p:nvSpPr>
-          <p:cNvPr id="39" name="TextBox 38"/>
+          <p:cNvPr id="33" name="TextBox 32"/>
           <p:cNvSpPr txBox="1"/>
           <p:nvPr/>
         </p:nvSpPr>
@@ -17770,7 +17384,7 @@
       </p:sp>
       <p:sp>
         <p:nvSpPr>
-          <p:cNvPr id="40" name="Oval 39"/>
+          <p:cNvPr id="34" name="Oval 33"/>
           <p:cNvSpPr/>
           <p:nvPr/>
         </p:nvSpPr>
@@ -17799,7 +17413,7 @@
       </p:sp>
       <p:sp>
         <p:nvSpPr>
-          <p:cNvPr id="41" name="TextBox 40"/>
+          <p:cNvPr id="35" name="TextBox 34"/>
           <p:cNvSpPr txBox="1"/>
           <p:nvPr/>
         </p:nvSpPr>
@@ -17836,7 +17450,7 @@
       </p:sp>
       <p:sp>
         <p:nvSpPr>
-          <p:cNvPr id="42" name="Oval 41"/>
+          <p:cNvPr id="36" name="Oval 35"/>
           <p:cNvSpPr/>
           <p:nvPr/>
         </p:nvSpPr>
@@ -17865,7 +17479,7 @@
       </p:sp>
       <p:sp>
         <p:nvSpPr>
-          <p:cNvPr id="43" name="TextBox 42"/>
+          <p:cNvPr id="37" name="TextBox 36"/>
           <p:cNvSpPr txBox="1"/>
           <p:nvPr/>
         </p:nvSpPr>
@@ -17902,7 +17516,7 @@
       </p:sp>
       <p:sp>
         <p:nvSpPr>
-          <p:cNvPr id="44" name="Oval 43"/>
+          <p:cNvPr id="38" name="Oval 37"/>
           <p:cNvSpPr/>
           <p:nvPr/>
         </p:nvSpPr>
@@ -17931,7 +17545,7 @@
       </p:sp>
       <p:sp>
         <p:nvSpPr>
-          <p:cNvPr id="45" name="Rounded Rectangle 44"/>
+          <p:cNvPr id="39" name="Rounded Rectangle 38"/>
           <p:cNvSpPr/>
           <p:nvPr/>
         </p:nvSpPr>
@@ -17975,7 +17589,7 @@
       </p:sp>
       <p:sp>
         <p:nvSpPr>
-          <p:cNvPr id="46" name="TextBox 45"/>
+          <p:cNvPr id="40" name="TextBox 39"/>
           <p:cNvSpPr txBox="1"/>
           <p:nvPr/>
         </p:nvSpPr>
@@ -18012,7 +17626,7 @@
       </p:sp>
       <p:sp>
         <p:nvSpPr>
-          <p:cNvPr id="47" name="TextBox 46"/>
+          <p:cNvPr id="41" name="TextBox 40"/>
           <p:cNvSpPr txBox="1"/>
           <p:nvPr/>
         </p:nvSpPr>
@@ -18070,7 +17684,7 @@
       </p:sp>
       <p:sp>
         <p:nvSpPr>
-          <p:cNvPr id="48" name="Rounded Rectangle 47"/>
+          <p:cNvPr id="42" name="Rounded Rectangle 41"/>
           <p:cNvSpPr/>
           <p:nvPr/>
         </p:nvSpPr>
@@ -18113,7 +17727,7 @@
       </p:sp>
       <p:graphicFrame>
         <p:nvGraphicFramePr>
-          <p:cNvPr id="49" name="Table 48"/>
+          <p:cNvPr id="43" name="Table 42"/>
           <p:cNvGraphicFramePr>
             <a:graphicFrameLocks noGrp="1"/>
           </p:cNvGraphicFramePr>
@@ -19085,15 +18699,15 @@
         </p:nvSpPr>
         <p:spPr>
           <a:xfrm>
-            <a:off x="227420" y="6498731"/>
-            <a:ext cx="467734" cy="206790"/>
-          </a:xfrm>
-        </p:spPr>
-        <p:txBody>
-          <a:bodyPr/>
-          <a:lstStyle/>
-          <a:p>
-            <a:pPr marL="0" marR="0" lvl="0" indent="0" algn="ctr" defTabSz="914400" rtl="0" eaLnBrk="1" fontAlgn="auto" latinLnBrk="0" hangingPunct="1">
+            <a:off x="411480" y="402336"/>
+            <a:ext cx="822960" cy="640080"/>
+          </a:xfrm>
+        </p:spPr>
+        <p:txBody>
+          <a:bodyPr anchor="ctr" lIns="0"/>
+          <a:lstStyle/>
+          <a:p>
+            <a:pPr marL="0" marR="0" lvl="0" indent="0" algn="l" defTabSz="914400" rtl="0" eaLnBrk="1" fontAlgn="auto" latinLnBrk="0" hangingPunct="1">
               <a:lnSpc>
                 <a:spcPct val="100000"/>
               </a:lnSpc>
@@ -19113,21 +18727,12 @@
               <a:defRPr/>
             </a:pPr>
             <a:fld id="{679EF615-E246-4FA6-9E75-123AAEB83405}" type="slidenum">
-              <a:rPr kumimoji="0" lang="en-PH" sz="900" b="0" i="0" u="none" strike="noStrike" kern="0" cap="none" spc="0" normalizeH="0" baseline="0" noProof="0" smtClean="0">
-                <a:ln>
-                  <a:noFill/>
-                </a:ln>
+              <a:rPr kumimoji="0" lang="en-US" sz="1200" b="1" i="0" u="none" strike="noStrike" kern="0" cap="none" spc="0" normalizeH="0" baseline="0" noProof="0" smtClean="0">
                 <a:solidFill>
-                  <a:prstClr val="white">
-                    <a:lumMod val="65000"/>
-                  </a:prstClr>
+                  <a:srgbClr val="2A206A"/>
                 </a:solidFill>
-                <a:effectLst/>
-                <a:uLnTx/>
-                <a:uFillTx/>
                 <a:latin typeface="DiodrumArabic-Semibold"/>
-                <a:cs typeface="Arial"/>
-                <a:sym typeface="Arial"/>
+                <a:cs typeface="DiodrumArabic-Semibold"/>
               </a:rPr>
               <a:pPr marL="0" marR="0" lvl="0" indent="0" algn="ctr" defTabSz="914400" rtl="0" eaLnBrk="1" fontAlgn="auto" latinLnBrk="0" hangingPunct="1">
                 <a:lnSpc>
@@ -19163,102 +18768,6 @@
               <a:uLnTx/>
               <a:uFillTx/>
               <a:latin typeface="DiodrumArabic-Semibold"/>
-              <a:cs typeface="Arial"/>
-              <a:sym typeface="Arial"/>
-            </a:endParaRPr>
-          </a:p>
-        </p:txBody>
-      </p:sp>
-      <p:sp>
-        <p:nvSpPr>
-          <p:cNvPr id="12" name="SecloreFooter">
-            <a:extLst>
-              <a:ext uri="{FF2B5EF4-FFF2-40B4-BE49-F238E27FC236}">
-                <a16:creationId xmlns:a16="http://schemas.microsoft.com/office/drawing/2014/main" id="{3256E98C-32DF-42DD-9307-7E10BBFC8907}"/>
-              </a:ext>
-            </a:extLst>
-          </p:cNvPr>
-          <p:cNvSpPr>
-            <a:spLocks noGrp="1"/>
-          </p:cNvSpPr>
-          <p:nvPr>
-            <p:ph type="ftr" sz="quarter" idx="13"/>
-          </p:nvPr>
-        </p:nvSpPr>
-        <p:spPr>
-          <a:xfrm>
-            <a:off x="0" y="6356352"/>
-            <a:ext cx="12192000" cy="365125"/>
-          </a:xfrm>
-        </p:spPr>
-        <p:txBody>
-          <a:bodyPr/>
-          <a:lstStyle/>
-          <a:p>
-            <a:pPr marL="0" marR="0" lvl="0" indent="0" algn="ctr" defTabSz="914400" rtl="0" eaLnBrk="1" fontAlgn="auto" latinLnBrk="0" hangingPunct="1">
-              <a:lnSpc>
-                <a:spcPct val="100000"/>
-              </a:lnSpc>
-              <a:spcBef>
-                <a:spcPts val="0"/>
-              </a:spcBef>
-              <a:spcAft>
-                <a:spcPts val="0"/>
-              </a:spcAft>
-              <a:buClr>
-                <a:srgbClr val="000000"/>
-              </a:buClr>
-              <a:buSzTx/>
-              <a:buFont typeface="Arial"/>
-              <a:buNone/>
-              <a:tabLst/>
-              <a:defRPr/>
-            </a:pPr>
-            <a:r>
-              <a:rPr kumimoji="0" lang="en-US" sz="1200" b="0" i="0" u="none" strike="noStrike" kern="0" cap="none" spc="0" normalizeH="0" baseline="0" noProof="0">
-                <a:ln>
-                  <a:noFill/>
-                </a:ln>
-                <a:solidFill>
-                  <a:srgbClr val="F0C231"/>
-                </a:solidFill>
-                <a:effectLst/>
-                <a:uLnTx/>
-                <a:uFillTx/>
-                <a:latin typeface="Arial"/>
-                <a:cs typeface="Arial"/>
-                <a:sym typeface="Arial"/>
-              </a:rPr>
-              <a:t>Restricted - </a:t>
-            </a:r>
-            <a:r>
-              <a:rPr kumimoji="0" lang="ar-SA" sz="1200" b="0" i="0" u="none" strike="noStrike" kern="0" cap="none" spc="0" normalizeH="0" baseline="0" noProof="0">
-                <a:ln>
-                  <a:noFill/>
-                </a:ln>
-                <a:solidFill>
-                  <a:srgbClr val="F0C231"/>
-                </a:solidFill>
-                <a:effectLst/>
-                <a:uLnTx/>
-                <a:uFillTx/>
-                <a:latin typeface="Arial"/>
-                <a:cs typeface="Arial"/>
-                <a:sym typeface="Arial"/>
-              </a:rPr>
-              <a:t>مقيد</a:t>
-            </a:r>
-            <a:endParaRPr kumimoji="0" lang="en-US" sz="1200" b="0" i="0" u="none" strike="noStrike" kern="0" cap="none" spc="0" normalizeH="0" baseline="0" noProof="0">
-              <a:ln>
-                <a:noFill/>
-              </a:ln>
-              <a:solidFill>
-                <a:srgbClr val="F0C231"/>
-              </a:solidFill>
-              <a:effectLst/>
-              <a:uLnTx/>
-              <a:uFillTx/>
-              <a:latin typeface="Arial"/>
               <a:cs typeface="Arial"/>
               <a:sym typeface="Arial"/>
             </a:endParaRPr>
@@ -19352,44 +18861,6 @@
       </p:grpSpPr>
       <p:sp>
         <p:nvSpPr>
-          <p:cNvPr id="3" name="SecloreFooter">
-            <a:extLst>
-              <a:ext uri="{FF2B5EF4-FFF2-40B4-BE49-F238E27FC236}">
-                <a16:creationId xmlns:a16="http://schemas.microsoft.com/office/drawing/2014/main" id="{58F27995-F8CF-D37B-0D81-FE8260A14265}"/>
-              </a:ext>
-            </a:extLst>
-          </p:cNvPr>
-          <p:cNvSpPr>
-            <a:spLocks noGrp="1"/>
-          </p:cNvSpPr>
-          <p:nvPr>
-            <p:ph type="ftr" sz="quarter" idx="13"/>
-          </p:nvPr>
-        </p:nvSpPr>
-        <p:spPr>
-          <a:xfrm>
-            <a:off x="146304" y="6365496"/>
-            <a:ext cx="12192000" cy="365125"/>
-          </a:xfrm>
-        </p:spPr>
-        <p:txBody>
-          <a:bodyPr/>
-          <a:lstStyle/>
-          <a:p>
-            <a:r>
-              <a:rPr lang="en-US"/>
-              <a:t>Restricted - </a:t>
-            </a:r>
-            <a:r>
-              <a:rPr lang="ar-SA"/>
-              <a:t>مقيد</a:t>
-            </a:r>
-            <a:endParaRPr lang="en-US" dirty="0"/>
-          </a:p>
-        </p:txBody>
-      </p:sp>
-      <p:sp>
-        <p:nvSpPr>
           <p:cNvPr id="2" name="Slide Number Placeholder 1">
             <a:extLst>
               <a:ext uri="{FF2B5EF4-FFF2-40B4-BE49-F238E27FC236}">
@@ -19404,13 +18875,25 @@
             <p:ph type="sldNum" sz="quarter" idx="12"/>
           </p:nvPr>
         </p:nvSpPr>
-        <p:spPr/>
-        <p:txBody>
-          <a:bodyPr/>
-          <a:lstStyle/>
-          <a:p>
+        <p:spPr>
+          <a:xfrm>
+            <a:off x="411480" y="155448"/>
+            <a:ext cx="822960" cy="548640"/>
+          </a:xfrm>
+        </p:spPr>
+        <p:txBody>
+          <a:bodyPr anchor="ctr" lIns="0"/>
+          <a:lstStyle/>
+          <a:p>
+            <a:pPr algn="l"/>
             <a:fld id="{679EF615-E246-4FA6-9E75-123AAEB83405}" type="slidenum">
-              <a:rPr lang="en-PH" smtClean="0"/>
+              <a:rPr lang="en-US" smtClean="0" sz="1200" b="1">
+                <a:solidFill>
+                  <a:srgbClr val="2A206A"/>
+                </a:solidFill>
+                <a:latin typeface="DiodrumArabic-Semibold"/>
+                <a:cs typeface="DiodrumArabic-Semibold"/>
+              </a:rPr>
               <a:pPr/>
               <a:t>14</a:t>
             </a:fld>
@@ -19420,14 +18903,14 @@
       </p:sp>
       <p:sp>
         <p:nvSpPr>
-          <p:cNvPr id="4" name="TextBox 3"/>
+          <p:cNvPr id="3" name="TextBox 2"/>
           <p:cNvSpPr txBox="1"/>
           <p:nvPr/>
         </p:nvSpPr>
         <p:spPr>
           <a:xfrm>
-            <a:off x="411480" y="155448"/>
-            <a:ext cx="11384280" cy="548640"/>
+            <a:off x="1234440" y="155448"/>
+            <a:ext cx="10561320" cy="548640"/>
           </a:xfrm>
           <a:prstGeom prst="rect">
             <a:avLst/>
@@ -19467,7 +18950,7 @@
       </p:sp>
       <p:cxnSp>
         <p:nvCxnSpPr>
-          <p:cNvPr id="5" name="Connector 4"/>
+          <p:cNvPr id="4" name="Connector 3"/>
           <p:cNvCxnSpPr/>
           <p:nvPr/>
         </p:nvCxnSpPr>
@@ -19496,7 +18979,7 @@
       </p:cxnSp>
       <p:sp>
         <p:nvSpPr>
-          <p:cNvPr id="6" name="Rounded Rectangle 5"/>
+          <p:cNvPr id="5" name="Rounded Rectangle 4"/>
           <p:cNvSpPr/>
           <p:nvPr/>
         </p:nvSpPr>
@@ -19540,7 +19023,7 @@
       </p:sp>
       <p:sp>
         <p:nvSpPr>
-          <p:cNvPr id="7" name="TextBox 6"/>
+          <p:cNvPr id="6" name="TextBox 5"/>
           <p:cNvSpPr txBox="1"/>
           <p:nvPr/>
         </p:nvSpPr>
@@ -19581,7 +19064,7 @@
       </p:sp>
       <p:pic>
         <p:nvPicPr>
-          <p:cNvPr id="8" name="Picture 7" descr="image.png"/>
+          <p:cNvPr id="7" name="Picture 6" descr="image.png"/>
           <p:cNvPicPr>
             <a:picLocks noChangeAspect="1"/>
           </p:cNvPicPr>
@@ -19605,7 +19088,7 @@
       </p:pic>
       <p:sp>
         <p:nvSpPr>
-          <p:cNvPr id="9" name="Rounded Rectangle 8"/>
+          <p:cNvPr id="8" name="Rounded Rectangle 7"/>
           <p:cNvSpPr/>
           <p:nvPr/>
         </p:nvSpPr>
@@ -19643,7 +19126,7 @@
       </p:sp>
       <p:sp>
         <p:nvSpPr>
-          <p:cNvPr id="10" name="TextBox 9"/>
+          <p:cNvPr id="9" name="TextBox 8"/>
           <p:cNvSpPr txBox="1"/>
           <p:nvPr/>
         </p:nvSpPr>
@@ -19680,7 +19163,7 @@
       </p:sp>
       <p:cxnSp>
         <p:nvCxnSpPr>
-          <p:cNvPr id="11" name="Connector 10"/>
+          <p:cNvPr id="10" name="Connector 9"/>
           <p:cNvCxnSpPr/>
           <p:nvPr/>
         </p:nvCxnSpPr>
@@ -19701,7 +19184,7 @@
       </p:cxnSp>
       <p:cxnSp>
         <p:nvCxnSpPr>
-          <p:cNvPr id="12" name="Connector 11"/>
+          <p:cNvPr id="11" name="Connector 10"/>
           <p:cNvCxnSpPr/>
           <p:nvPr/>
         </p:nvCxnSpPr>
@@ -19722,7 +19205,7 @@
       </p:cxnSp>
       <p:sp>
         <p:nvSpPr>
-          <p:cNvPr id="13" name="Oval 12"/>
+          <p:cNvPr id="12" name="Oval 11"/>
           <p:cNvSpPr/>
           <p:nvPr/>
         </p:nvSpPr>
@@ -19753,7 +19236,7 @@
       </p:sp>
       <p:sp>
         <p:nvSpPr>
-          <p:cNvPr id="14" name="TextBox 13"/>
+          <p:cNvPr id="13" name="TextBox 12"/>
           <p:cNvSpPr txBox="1"/>
           <p:nvPr/>
         </p:nvSpPr>
@@ -19790,7 +19273,7 @@
       </p:sp>
       <p:sp>
         <p:nvSpPr>
-          <p:cNvPr id="15" name="TextBox 14"/>
+          <p:cNvPr id="14" name="TextBox 13"/>
           <p:cNvSpPr txBox="1"/>
           <p:nvPr/>
         </p:nvSpPr>
@@ -19827,7 +19310,7 @@
       </p:sp>
       <p:sp>
         <p:nvSpPr>
-          <p:cNvPr id="16" name="TextBox 15"/>
+          <p:cNvPr id="15" name="TextBox 14"/>
           <p:cNvSpPr txBox="1"/>
           <p:nvPr/>
         </p:nvSpPr>
@@ -19868,7 +19351,7 @@
       </p:sp>
       <p:sp>
         <p:nvSpPr>
-          <p:cNvPr id="17" name="Oval 16"/>
+          <p:cNvPr id="16" name="Oval 15"/>
           <p:cNvSpPr/>
           <p:nvPr/>
         </p:nvSpPr>
@@ -19899,7 +19382,7 @@
       </p:sp>
       <p:sp>
         <p:nvSpPr>
-          <p:cNvPr id="18" name="TextBox 17"/>
+          <p:cNvPr id="17" name="TextBox 16"/>
           <p:cNvSpPr txBox="1"/>
           <p:nvPr/>
         </p:nvSpPr>
@@ -19936,7 +19419,7 @@
       </p:sp>
       <p:sp>
         <p:nvSpPr>
-          <p:cNvPr id="19" name="TextBox 18"/>
+          <p:cNvPr id="18" name="TextBox 17"/>
           <p:cNvSpPr txBox="1"/>
           <p:nvPr/>
         </p:nvSpPr>
@@ -19973,7 +19456,7 @@
       </p:sp>
       <p:sp>
         <p:nvSpPr>
-          <p:cNvPr id="20" name="TextBox 19"/>
+          <p:cNvPr id="19" name="TextBox 18"/>
           <p:cNvSpPr txBox="1"/>
           <p:nvPr/>
         </p:nvSpPr>
@@ -20014,7 +19497,7 @@
       </p:sp>
       <p:sp>
         <p:nvSpPr>
-          <p:cNvPr id="21" name="Rounded Rectangle 20"/>
+          <p:cNvPr id="20" name="Rounded Rectangle 19"/>
           <p:cNvSpPr/>
           <p:nvPr/>
         </p:nvSpPr>
@@ -20055,7 +19538,7 @@
       </p:sp>
       <p:sp>
         <p:nvSpPr>
-          <p:cNvPr id="22" name="Oval 21"/>
+          <p:cNvPr id="21" name="Oval 20"/>
           <p:cNvSpPr/>
           <p:nvPr/>
         </p:nvSpPr>
@@ -20086,7 +19569,7 @@
       </p:sp>
       <p:sp>
         <p:nvSpPr>
-          <p:cNvPr id="23" name="TextBox 22"/>
+          <p:cNvPr id="22" name="TextBox 21"/>
           <p:cNvSpPr txBox="1"/>
           <p:nvPr/>
         </p:nvSpPr>
@@ -20123,7 +19606,7 @@
       </p:sp>
       <p:sp>
         <p:nvSpPr>
-          <p:cNvPr id="24" name="TextBox 23"/>
+          <p:cNvPr id="23" name="TextBox 22"/>
           <p:cNvSpPr txBox="1"/>
           <p:nvPr/>
         </p:nvSpPr>
@@ -20160,7 +19643,7 @@
       </p:sp>
       <p:sp>
         <p:nvSpPr>
-          <p:cNvPr id="25" name="TextBox 24"/>
+          <p:cNvPr id="24" name="TextBox 23"/>
           <p:cNvSpPr txBox="1"/>
           <p:nvPr/>
         </p:nvSpPr>
@@ -20201,7 +19684,7 @@
       </p:sp>
       <p:sp>
         <p:nvSpPr>
-          <p:cNvPr id="26" name="Rounded Rectangle 25"/>
+          <p:cNvPr id="25" name="Rounded Rectangle 24"/>
           <p:cNvSpPr/>
           <p:nvPr/>
         </p:nvSpPr>
@@ -20245,7 +19728,7 @@
       </p:sp>
       <p:sp>
         <p:nvSpPr>
-          <p:cNvPr id="27" name="TextBox 26"/>
+          <p:cNvPr id="26" name="TextBox 25"/>
           <p:cNvSpPr txBox="1"/>
           <p:nvPr/>
         </p:nvSpPr>
@@ -20282,7 +19765,7 @@
       </p:sp>
       <p:sp>
         <p:nvSpPr>
-          <p:cNvPr id="28" name="TextBox 27"/>
+          <p:cNvPr id="27" name="TextBox 26"/>
           <p:cNvSpPr txBox="1"/>
           <p:nvPr/>
         </p:nvSpPr>
@@ -20323,7 +19806,7 @@
       </p:sp>
       <p:sp>
         <p:nvSpPr>
-          <p:cNvPr id="29" name="Rounded Rectangle 28"/>
+          <p:cNvPr id="28" name="Rounded Rectangle 27"/>
           <p:cNvSpPr/>
           <p:nvPr/>
         </p:nvSpPr>
@@ -20361,7 +19844,7 @@
       </p:sp>
       <p:sp>
         <p:nvSpPr>
-          <p:cNvPr id="30" name="TextBox 29"/>
+          <p:cNvPr id="29" name="TextBox 28"/>
           <p:cNvSpPr txBox="1"/>
           <p:nvPr/>
         </p:nvSpPr>
@@ -20398,7 +19881,7 @@
       </p:sp>
       <p:cxnSp>
         <p:nvCxnSpPr>
-          <p:cNvPr id="31" name="Connector 30"/>
+          <p:cNvPr id="30" name="Connector 29"/>
           <p:cNvCxnSpPr/>
           <p:nvPr/>
         </p:nvCxnSpPr>
@@ -20419,7 +19902,7 @@
       </p:cxnSp>
       <p:sp>
         <p:nvSpPr>
-          <p:cNvPr id="32" name="Oval 31"/>
+          <p:cNvPr id="31" name="Oval 30"/>
           <p:cNvSpPr/>
           <p:nvPr/>
         </p:nvSpPr>
@@ -20448,7 +19931,7 @@
       </p:sp>
       <p:sp>
         <p:nvSpPr>
-          <p:cNvPr id="33" name="TextBox 32"/>
+          <p:cNvPr id="32" name="TextBox 31"/>
           <p:cNvSpPr txBox="1"/>
           <p:nvPr/>
         </p:nvSpPr>
@@ -20485,7 +19968,7 @@
       </p:sp>
       <p:sp>
         <p:nvSpPr>
-          <p:cNvPr id="34" name="TextBox 33"/>
+          <p:cNvPr id="33" name="TextBox 32"/>
           <p:cNvSpPr txBox="1"/>
           <p:nvPr/>
         </p:nvSpPr>
@@ -20522,7 +20005,7 @@
       </p:sp>
       <p:sp>
         <p:nvSpPr>
-          <p:cNvPr id="35" name="TextBox 34"/>
+          <p:cNvPr id="34" name="TextBox 33"/>
           <p:cNvSpPr txBox="1"/>
           <p:nvPr/>
         </p:nvSpPr>
@@ -20563,7 +20046,7 @@
       </p:sp>
       <p:sp>
         <p:nvSpPr>
-          <p:cNvPr id="36" name="Oval 35"/>
+          <p:cNvPr id="35" name="Oval 34"/>
           <p:cNvSpPr/>
           <p:nvPr/>
         </p:nvSpPr>
@@ -20592,7 +20075,7 @@
       </p:sp>
       <p:sp>
         <p:nvSpPr>
-          <p:cNvPr id="37" name="TextBox 36"/>
+          <p:cNvPr id="36" name="TextBox 35"/>
           <p:cNvSpPr txBox="1"/>
           <p:nvPr/>
         </p:nvSpPr>
@@ -20629,7 +20112,7 @@
       </p:sp>
       <p:sp>
         <p:nvSpPr>
-          <p:cNvPr id="38" name="TextBox 37"/>
+          <p:cNvPr id="37" name="TextBox 36"/>
           <p:cNvSpPr txBox="1"/>
           <p:nvPr/>
         </p:nvSpPr>
@@ -20666,7 +20149,7 @@
       </p:sp>
       <p:sp>
         <p:nvSpPr>
-          <p:cNvPr id="39" name="TextBox 38"/>
+          <p:cNvPr id="38" name="TextBox 37"/>
           <p:cNvSpPr txBox="1"/>
           <p:nvPr/>
         </p:nvSpPr>
@@ -20707,7 +20190,7 @@
       </p:sp>
       <p:sp>
         <p:nvSpPr>
-          <p:cNvPr id="40" name="Oval 39"/>
+          <p:cNvPr id="39" name="Oval 38"/>
           <p:cNvSpPr/>
           <p:nvPr/>
         </p:nvSpPr>
@@ -20736,7 +20219,7 @@
       </p:sp>
       <p:sp>
         <p:nvSpPr>
-          <p:cNvPr id="41" name="TextBox 40"/>
+          <p:cNvPr id="40" name="TextBox 39"/>
           <p:cNvSpPr txBox="1"/>
           <p:nvPr/>
         </p:nvSpPr>
@@ -20773,7 +20256,7 @@
       </p:sp>
       <p:sp>
         <p:nvSpPr>
-          <p:cNvPr id="42" name="TextBox 41"/>
+          <p:cNvPr id="41" name="TextBox 40"/>
           <p:cNvSpPr txBox="1"/>
           <p:nvPr/>
         </p:nvSpPr>
@@ -20810,7 +20293,7 @@
       </p:sp>
       <p:sp>
         <p:nvSpPr>
-          <p:cNvPr id="43" name="TextBox 42"/>
+          <p:cNvPr id="42" name="TextBox 41"/>
           <p:cNvSpPr txBox="1"/>
           <p:nvPr/>
         </p:nvSpPr>
@@ -21173,44 +20656,6 @@
       </p:sp>
       <p:sp>
         <p:nvSpPr>
-          <p:cNvPr id="3" name="SecloreFooter">
-            <a:extLst>
-              <a:ext uri="{FF2B5EF4-FFF2-40B4-BE49-F238E27FC236}">
-                <a16:creationId xmlns:a16="http://schemas.microsoft.com/office/drawing/2014/main" id="{E1B6FAD4-8A9C-42BF-97AD-94B7D08E3088}"/>
-              </a:ext>
-            </a:extLst>
-          </p:cNvPr>
-          <p:cNvSpPr>
-            <a:spLocks noGrp="1"/>
-          </p:cNvSpPr>
-          <p:nvPr>
-            <p:ph type="ftr" sz="quarter" idx="13"/>
-          </p:nvPr>
-        </p:nvSpPr>
-        <p:spPr>
-          <a:xfrm>
-            <a:off x="0" y="6464616"/>
-            <a:ext cx="12192000" cy="281378"/>
-          </a:xfrm>
-        </p:spPr>
-        <p:txBody>
-          <a:bodyPr/>
-          <a:lstStyle/>
-          <a:p>
-            <a:r>
-              <a:rPr lang="en-US" sz="1200"/>
-              <a:t>Restricted - </a:t>
-            </a:r>
-            <a:r>
-              <a:rPr lang="ar-SA" sz="1200"/>
-              <a:t>مقيد</a:t>
-            </a:r>
-            <a:endParaRPr lang="en-US" sz="1200"/>
-          </a:p>
-        </p:txBody>
-      </p:sp>
-      <p:sp>
-        <p:nvSpPr>
           <p:cNvPr id="9902" name="TextBox 9901"/>
           <p:cNvSpPr txBox="1"/>
           <p:nvPr/>
@@ -21528,58 +20973,27 @@
         </p:nvSpPr>
         <p:spPr>
           <a:xfrm>
-            <a:off x="227420" y="6498731"/>
-            <a:ext cx="467734" cy="206790"/>
-          </a:xfrm>
-        </p:spPr>
-        <p:txBody>
-          <a:bodyPr/>
-          <a:lstStyle/>
-          <a:p>
+            <a:off x="411480" y="402336"/>
+            <a:ext cx="822960" cy="640080"/>
+          </a:xfrm>
+        </p:spPr>
+        <p:txBody>
+          <a:bodyPr anchor="ctr" lIns="0"/>
+          <a:lstStyle/>
+          <a:p>
+            <a:pPr algn="l"/>
             <a:fld id="{679EF615-E246-4FA6-9E75-123AAEB83405}" type="slidenum">
-              <a:rPr lang="en-PH" smtClean="0"/>
+              <a:rPr lang="en-US" smtClean="0" sz="1200" b="1">
+                <a:solidFill>
+                  <a:srgbClr val="2A206A"/>
+                </a:solidFill>
+                <a:latin typeface="DiodrumArabic-Semibold"/>
+                <a:cs typeface="DiodrumArabic-Semibold"/>
+              </a:rPr>
               <a:pPr/>
               <a:t>4</a:t>
             </a:fld>
             <a:endParaRPr lang="en-PH" dirty="0"/>
-          </a:p>
-        </p:txBody>
-      </p:sp>
-      <p:sp>
-        <p:nvSpPr>
-          <p:cNvPr id="12" name="SecloreFooter">
-            <a:extLst>
-              <a:ext uri="{FF2B5EF4-FFF2-40B4-BE49-F238E27FC236}">
-                <a16:creationId xmlns:a16="http://schemas.microsoft.com/office/drawing/2014/main" id="{3256E98C-32DF-42DD-9307-7E10BBFC8907}"/>
-              </a:ext>
-            </a:extLst>
-          </p:cNvPr>
-          <p:cNvSpPr>
-            <a:spLocks noGrp="1"/>
-          </p:cNvSpPr>
-          <p:nvPr>
-            <p:ph type="ftr" sz="quarter" idx="13"/>
-          </p:nvPr>
-        </p:nvSpPr>
-        <p:spPr>
-          <a:xfrm>
-            <a:off x="0" y="6356352"/>
-            <a:ext cx="12192000" cy="365125"/>
-          </a:xfrm>
-        </p:spPr>
-        <p:txBody>
-          <a:bodyPr/>
-          <a:lstStyle/>
-          <a:p>
-            <a:r>
-              <a:rPr lang="en-US"/>
-              <a:t>Restricted - </a:t>
-            </a:r>
-            <a:r>
-              <a:rPr lang="ar-SA"/>
-              <a:t>مقيد</a:t>
-            </a:r>
-            <a:endParaRPr lang="en-US"/>
           </a:p>
         </p:txBody>
       </p:sp>
@@ -21680,16 +21094,23 @@
         </p:nvSpPr>
         <p:spPr>
           <a:xfrm>
-            <a:off x="227420" y="6498731"/>
-            <a:ext cx="467734" cy="206790"/>
-          </a:xfrm>
-        </p:spPr>
-        <p:txBody>
-          <a:bodyPr/>
-          <a:lstStyle/>
-          <a:p>
+            <a:off x="411480" y="155448"/>
+            <a:ext cx="822960" cy="548640"/>
+          </a:xfrm>
+        </p:spPr>
+        <p:txBody>
+          <a:bodyPr anchor="ctr" lIns="0"/>
+          <a:lstStyle/>
+          <a:p>
+            <a:pPr algn="l"/>
             <a:fld id="{679EF615-E246-4FA6-9E75-123AAEB83405}" type="slidenum">
-              <a:rPr lang="en-PH" smtClean="0"/>
+              <a:rPr lang="en-US" smtClean="0" sz="1200" b="1">
+                <a:solidFill>
+                  <a:srgbClr val="2A206A"/>
+                </a:solidFill>
+                <a:latin typeface="DiodrumArabic-Semibold"/>
+                <a:cs typeface="DiodrumArabic-Semibold"/>
+              </a:rPr>
               <a:pPr/>
               <a:t>5</a:t>
             </a:fld>
@@ -21699,52 +21120,14 @@
       </p:sp>
       <p:sp>
         <p:nvSpPr>
-          <p:cNvPr id="11" name="SecloreFooter">
-            <a:extLst>
-              <a:ext uri="{FF2B5EF4-FFF2-40B4-BE49-F238E27FC236}">
-                <a16:creationId xmlns:a16="http://schemas.microsoft.com/office/drawing/2014/main" id="{FE53BD42-AF09-4407-AF8B-D0497E98ECF6}"/>
-              </a:ext>
-            </a:extLst>
-          </p:cNvPr>
-          <p:cNvSpPr>
-            <a:spLocks noGrp="1"/>
-          </p:cNvSpPr>
-          <p:nvPr>
-            <p:ph type="ftr" sz="quarter" idx="13"/>
-          </p:nvPr>
-        </p:nvSpPr>
-        <p:spPr>
-          <a:xfrm>
-            <a:off x="0" y="6356352"/>
-            <a:ext cx="12192000" cy="365125"/>
-          </a:xfrm>
-        </p:spPr>
-        <p:txBody>
-          <a:bodyPr/>
-          <a:lstStyle/>
-          <a:p>
-            <a:r>
-              <a:rPr lang="en-US"/>
-              <a:t>Restricted - </a:t>
-            </a:r>
-            <a:r>
-              <a:rPr lang="ar-SA"/>
-              <a:t>مقيد</a:t>
-            </a:r>
-            <a:endParaRPr lang="en-US"/>
-          </a:p>
-        </p:txBody>
-      </p:sp>
-      <p:sp>
-        <p:nvSpPr>
-          <p:cNvPr id="12" name="TextBox 11"/>
+          <p:cNvPr id="3" name="TextBox 2"/>
           <p:cNvSpPr txBox="1"/>
           <p:nvPr/>
         </p:nvSpPr>
         <p:spPr>
           <a:xfrm>
-            <a:off x="411480" y="155448"/>
-            <a:ext cx="11384280" cy="548640"/>
+            <a:off x="1234440" y="155448"/>
+            <a:ext cx="10561320" cy="548640"/>
           </a:xfrm>
           <a:prstGeom prst="rect">
             <a:avLst/>
@@ -21784,7 +21167,7 @@
       </p:sp>
       <p:cxnSp>
         <p:nvCxnSpPr>
-          <p:cNvPr id="13" name="Connector 12"/>
+          <p:cNvPr id="4" name="Connector 3"/>
           <p:cNvCxnSpPr/>
           <p:nvPr/>
         </p:nvCxnSpPr>
@@ -21813,7 +21196,7 @@
       </p:cxnSp>
       <p:sp>
         <p:nvSpPr>
-          <p:cNvPr id="14" name="TextBox 13"/>
+          <p:cNvPr id="5" name="TextBox 4"/>
           <p:cNvSpPr txBox="1"/>
           <p:nvPr/>
         </p:nvSpPr>
@@ -21850,7 +21233,7 @@
       </p:sp>
       <p:graphicFrame>
         <p:nvGraphicFramePr>
-          <p:cNvPr id="15" name="Table 14"/>
+          <p:cNvPr id="6" name="Table 5"/>
           <p:cNvGraphicFramePr>
             <a:graphicFrameLocks noGrp="1"/>
           </p:cNvGraphicFramePr>
@@ -22845,7 +22228,7 @@
       </p:graphicFrame>
       <p:sp>
         <p:nvSpPr>
-          <p:cNvPr id="16" name="Oval 15"/>
+          <p:cNvPr id="7" name="Oval 6"/>
           <p:cNvSpPr/>
           <p:nvPr/>
         </p:nvSpPr>
@@ -22874,7 +22257,7 @@
       </p:sp>
       <p:sp>
         <p:nvSpPr>
-          <p:cNvPr id="17" name="Oval 16"/>
+          <p:cNvPr id="8" name="Oval 7"/>
           <p:cNvSpPr/>
           <p:nvPr/>
         </p:nvSpPr>
@@ -22903,7 +22286,7 @@
       </p:sp>
       <p:sp>
         <p:nvSpPr>
-          <p:cNvPr id="18" name="Oval 17"/>
+          <p:cNvPr id="9" name="Oval 8"/>
           <p:cNvSpPr/>
           <p:nvPr/>
         </p:nvSpPr>
@@ -22932,7 +22315,7 @@
       </p:sp>
       <p:sp>
         <p:nvSpPr>
-          <p:cNvPr id="19" name="Rounded Rectangle 18"/>
+          <p:cNvPr id="10" name="Rounded Rectangle 9"/>
           <p:cNvSpPr/>
           <p:nvPr/>
         </p:nvSpPr>
@@ -22976,7 +22359,7 @@
       </p:sp>
       <p:sp>
         <p:nvSpPr>
-          <p:cNvPr id="20" name="TextBox 19"/>
+          <p:cNvPr id="11" name="TextBox 10"/>
           <p:cNvSpPr txBox="1"/>
           <p:nvPr/>
         </p:nvSpPr>
@@ -23013,7 +22396,7 @@
       </p:sp>
       <p:sp>
         <p:nvSpPr>
-          <p:cNvPr id="21" name="TextBox 20"/>
+          <p:cNvPr id="12" name="TextBox 11"/>
           <p:cNvSpPr txBox="1"/>
           <p:nvPr/>
         </p:nvSpPr>
@@ -23145,7 +22528,7 @@
         </p:nvSpPr>
         <p:spPr>
           <a:xfrm>
-            <a:off x="7498079" y="1468899"/>
+            <a:off x="7498079" y="1188720"/>
             <a:ext cx="2560320" cy="384721"/>
           </a:xfrm>
           <a:prstGeom prst="rect">
@@ -23178,60 +22561,13 @@
       </p:sp>
       <p:sp>
         <p:nvSpPr>
-          <p:cNvPr id="2" name="SecloreFooter">
-            <a:extLst>
-              <a:ext uri="{FF2B5EF4-FFF2-40B4-BE49-F238E27FC236}">
-                <a16:creationId xmlns:a16="http://schemas.microsoft.com/office/drawing/2014/main" id="{1B43696F-F98F-473A-978E-845299766F76}"/>
-              </a:ext>
-            </a:extLst>
-          </p:cNvPr>
-          <p:cNvSpPr>
-            <a:spLocks noGrp="1"/>
-          </p:cNvSpPr>
-          <p:nvPr>
-            <p:ph type="ftr" sz="quarter" idx="13"/>
-          </p:nvPr>
-        </p:nvSpPr>
-        <p:spPr>
-          <a:xfrm>
-            <a:off x="0" y="6464617"/>
-            <a:ext cx="12192000" cy="281378"/>
-          </a:xfrm>
-        </p:spPr>
-        <p:txBody>
-          <a:bodyPr/>
-          <a:lstStyle/>
-          <a:p>
-            <a:pPr defTabSz="812810">
-              <a:buClrTx/>
-            </a:pPr>
-            <a:r>
-              <a:rPr lang="en-US" sz="1200" kern="1200">
-                <a:ea typeface="+mn-ea"/>
-              </a:rPr>
-              <a:t>Restricted - </a:t>
-            </a:r>
-            <a:r>
-              <a:rPr lang="ar-SA" sz="1200" kern="1200">
-                <a:ea typeface="+mn-ea"/>
-              </a:rPr>
-              <a:t>مقيد</a:t>
-            </a:r>
-            <a:endParaRPr lang="en-US" sz="1200" kern="1200">
-              <a:ea typeface="+mn-ea"/>
-            </a:endParaRPr>
-          </a:p>
-        </p:txBody>
-      </p:sp>
-      <p:sp>
-        <p:nvSpPr>
           <p:cNvPr id="5" name="Rounded Rectangle 4"/>
           <p:cNvSpPr/>
           <p:nvPr/>
         </p:nvSpPr>
         <p:spPr>
           <a:xfrm>
-            <a:off x="3566160" y="1783080"/>
+            <a:off x="3566160" y="1691640"/>
             <a:ext cx="6126480" cy="1234440"/>
           </a:xfrm>
           <a:prstGeom prst="roundRect">
@@ -23269,7 +22605,7 @@
         </p:nvSpPr>
         <p:spPr>
           <a:xfrm>
-            <a:off x="8823960" y="1984248"/>
+            <a:off x="8823960" y="1892808"/>
             <a:ext cx="502920" cy="475488"/>
           </a:xfrm>
           <a:prstGeom prst="roundRect">
@@ -23313,7 +22649,7 @@
         </p:nvSpPr>
         <p:spPr>
           <a:xfrm>
-            <a:off x="8823960" y="1984248"/>
+            <a:off x="8823960" y="1892808"/>
             <a:ext cx="502920" cy="475488"/>
           </a:xfrm>
           <a:prstGeom prst="rect">
@@ -23350,7 +22686,7 @@
         </p:nvSpPr>
         <p:spPr>
           <a:xfrm>
-            <a:off x="3840480" y="1965960"/>
+            <a:off x="3840480" y="1874520"/>
             <a:ext cx="4800600" cy="457200"/>
           </a:xfrm>
           <a:prstGeom prst="rect">
@@ -23387,7 +22723,7 @@
         </p:nvSpPr>
         <p:spPr>
           <a:xfrm>
-            <a:off x="3840480" y="2441448"/>
+            <a:off x="3840480" y="2350008"/>
             <a:ext cx="4892040" cy="310896"/>
           </a:xfrm>
           <a:prstGeom prst="rect">
@@ -23434,7 +22770,7 @@
         </p:nvSpPr>
         <p:spPr>
           <a:xfrm>
-            <a:off x="3840480" y="2761488"/>
+            <a:off x="3840480" y="2670048"/>
             <a:ext cx="4892040" cy="310896"/>
           </a:xfrm>
           <a:prstGeom prst="rect">
@@ -23481,7 +22817,7 @@
         </p:nvSpPr>
         <p:spPr>
           <a:xfrm>
-            <a:off x="3566160" y="3200400"/>
+            <a:off x="3566160" y="3108960"/>
             <a:ext cx="6126480" cy="1691640"/>
           </a:xfrm>
           <a:prstGeom prst="roundRect">
@@ -23519,7 +22855,7 @@
         </p:nvSpPr>
         <p:spPr>
           <a:xfrm>
-            <a:off x="8823960" y="3401568"/>
+            <a:off x="8823960" y="3310128"/>
             <a:ext cx="502920" cy="475488"/>
           </a:xfrm>
           <a:prstGeom prst="roundRect">
@@ -23563,7 +22899,7 @@
         </p:nvSpPr>
         <p:spPr>
           <a:xfrm>
-            <a:off x="8823960" y="3401568"/>
+            <a:off x="8823960" y="3310128"/>
             <a:ext cx="502920" cy="475488"/>
           </a:xfrm>
           <a:prstGeom prst="rect">
@@ -23600,7 +22936,7 @@
         </p:nvSpPr>
         <p:spPr>
           <a:xfrm>
-            <a:off x="3840480" y="3383280"/>
+            <a:off x="3840480" y="3291840"/>
             <a:ext cx="4800600" cy="457200"/>
           </a:xfrm>
           <a:prstGeom prst="rect">
@@ -23637,7 +22973,7 @@
         </p:nvSpPr>
         <p:spPr>
           <a:xfrm>
-            <a:off x="3840480" y="3858768"/>
+            <a:off x="3840480" y="3767328"/>
             <a:ext cx="4892040" cy="310896"/>
           </a:xfrm>
           <a:prstGeom prst="rect">
@@ -23684,7 +23020,7 @@
         </p:nvSpPr>
         <p:spPr>
           <a:xfrm>
-            <a:off x="3840480" y="4178807"/>
+            <a:off x="3840480" y="4087368"/>
             <a:ext cx="4892040" cy="310896"/>
           </a:xfrm>
           <a:prstGeom prst="rect">
@@ -23731,7 +23067,7 @@
         </p:nvSpPr>
         <p:spPr>
           <a:xfrm>
-            <a:off x="3840480" y="4498847"/>
+            <a:off x="3840480" y="4407407"/>
             <a:ext cx="4892040" cy="310896"/>
           </a:xfrm>
           <a:prstGeom prst="rect">
@@ -23778,7 +23114,7 @@
         </p:nvSpPr>
         <p:spPr>
           <a:xfrm>
-            <a:off x="3566160" y="5074920"/>
+            <a:off x="3566160" y="4983480"/>
             <a:ext cx="6126480" cy="1234440"/>
           </a:xfrm>
           <a:prstGeom prst="roundRect">
@@ -23816,7 +23152,7 @@
         </p:nvSpPr>
         <p:spPr>
           <a:xfrm>
-            <a:off x="8823960" y="5276088"/>
+            <a:off x="8823960" y="5184648"/>
             <a:ext cx="502920" cy="475488"/>
           </a:xfrm>
           <a:prstGeom prst="roundRect">
@@ -23860,7 +23196,7 @@
         </p:nvSpPr>
         <p:spPr>
           <a:xfrm>
-            <a:off x="8823960" y="5276088"/>
+            <a:off x="8823960" y="5184648"/>
             <a:ext cx="502920" cy="475488"/>
           </a:xfrm>
           <a:prstGeom prst="rect">
@@ -23897,7 +23233,7 @@
         </p:nvSpPr>
         <p:spPr>
           <a:xfrm>
-            <a:off x="3840480" y="5257800"/>
+            <a:off x="3840480" y="5166360"/>
             <a:ext cx="4800600" cy="457200"/>
           </a:xfrm>
           <a:prstGeom prst="rect">
@@ -23934,7 +23270,7 @@
         </p:nvSpPr>
         <p:spPr>
           <a:xfrm>
-            <a:off x="3840480" y="5733288"/>
+            <a:off x="3840480" y="5641848"/>
             <a:ext cx="4892040" cy="310896"/>
           </a:xfrm>
           <a:prstGeom prst="rect">
@@ -23981,7 +23317,7 @@
         </p:nvSpPr>
         <p:spPr>
           <a:xfrm>
-            <a:off x="3840480" y="6053327"/>
+            <a:off x="3840480" y="5961888"/>
             <a:ext cx="4892040" cy="310896"/>
           </a:xfrm>
           <a:prstGeom prst="rect">
@@ -24302,58 +23638,27 @@
         </p:nvSpPr>
         <p:spPr>
           <a:xfrm>
-            <a:off x="227420" y="6498731"/>
-            <a:ext cx="467734" cy="206790"/>
-          </a:xfrm>
-        </p:spPr>
-        <p:txBody>
-          <a:bodyPr/>
-          <a:lstStyle/>
-          <a:p>
+            <a:off x="411480" y="402336"/>
+            <a:ext cx="822960" cy="640080"/>
+          </a:xfrm>
+        </p:spPr>
+        <p:txBody>
+          <a:bodyPr anchor="ctr" lIns="0"/>
+          <a:lstStyle/>
+          <a:p>
+            <a:pPr algn="l"/>
             <a:fld id="{679EF615-E246-4FA6-9E75-123AAEB83405}" type="slidenum">
-              <a:rPr lang="en-PH" smtClean="0"/>
+              <a:rPr lang="en-US" smtClean="0" sz="1200" b="1">
+                <a:solidFill>
+                  <a:srgbClr val="2A206A"/>
+                </a:solidFill>
+                <a:latin typeface="DiodrumArabic-Semibold"/>
+                <a:cs typeface="DiodrumArabic-Semibold"/>
+              </a:rPr>
               <a:pPr/>
               <a:t>4</a:t>
             </a:fld>
             <a:endParaRPr lang="en-PH" dirty="0"/>
-          </a:p>
-        </p:txBody>
-      </p:sp>
-      <p:sp>
-        <p:nvSpPr>
-          <p:cNvPr id="12" name="SecloreFooter">
-            <a:extLst>
-              <a:ext uri="{FF2B5EF4-FFF2-40B4-BE49-F238E27FC236}">
-                <a16:creationId xmlns:a16="http://schemas.microsoft.com/office/drawing/2014/main" id="{3256E98C-32DF-42DD-9307-7E10BBFC8907}"/>
-              </a:ext>
-            </a:extLst>
-          </p:cNvPr>
-          <p:cNvSpPr>
-            <a:spLocks noGrp="1"/>
-          </p:cNvSpPr>
-          <p:nvPr>
-            <p:ph type="ftr" sz="quarter" idx="13"/>
-          </p:nvPr>
-        </p:nvSpPr>
-        <p:spPr>
-          <a:xfrm>
-            <a:off x="0" y="6356352"/>
-            <a:ext cx="12192000" cy="365125"/>
-          </a:xfrm>
-        </p:spPr>
-        <p:txBody>
-          <a:bodyPr/>
-          <a:lstStyle/>
-          <a:p>
-            <a:r>
-              <a:rPr lang="en-US"/>
-              <a:t>Restricted - </a:t>
-            </a:r>
-            <a:r>
-              <a:rPr lang="ar-SA"/>
-              <a:t>مقيد</a:t>
-            </a:r>
-            <a:endParaRPr lang="en-US"/>
           </a:p>
         </p:txBody>
       </p:sp>
@@ -24454,16 +23759,23 @@
         </p:nvSpPr>
         <p:spPr>
           <a:xfrm>
-            <a:off x="227420" y="6498731"/>
-            <a:ext cx="467734" cy="206790"/>
-          </a:xfrm>
-        </p:spPr>
-        <p:txBody>
-          <a:bodyPr/>
-          <a:lstStyle/>
-          <a:p>
+            <a:off x="411480" y="155448"/>
+            <a:ext cx="822960" cy="548640"/>
+          </a:xfrm>
+        </p:spPr>
+        <p:txBody>
+          <a:bodyPr anchor="ctr" lIns="0"/>
+          <a:lstStyle/>
+          <a:p>
+            <a:pPr algn="l"/>
             <a:fld id="{679EF615-E246-4FA6-9E75-123AAEB83405}" type="slidenum">
-              <a:rPr lang="en-PH" smtClean="0"/>
+              <a:rPr lang="en-US" smtClean="0" sz="1200" b="1">
+                <a:solidFill>
+                  <a:srgbClr val="2A206A"/>
+                </a:solidFill>
+                <a:latin typeface="DiodrumArabic-Semibold"/>
+                <a:cs typeface="DiodrumArabic-Semibold"/>
+              </a:rPr>
               <a:pPr/>
               <a:t>5</a:t>
             </a:fld>
@@ -24473,52 +23785,14 @@
       </p:sp>
       <p:sp>
         <p:nvSpPr>
-          <p:cNvPr id="11" name="SecloreFooter">
-            <a:extLst>
-              <a:ext uri="{FF2B5EF4-FFF2-40B4-BE49-F238E27FC236}">
-                <a16:creationId xmlns:a16="http://schemas.microsoft.com/office/drawing/2014/main" id="{FE53BD42-AF09-4407-AF8B-D0497E98ECF6}"/>
-              </a:ext>
-            </a:extLst>
-          </p:cNvPr>
-          <p:cNvSpPr>
-            <a:spLocks noGrp="1"/>
-          </p:cNvSpPr>
-          <p:nvPr>
-            <p:ph type="ftr" sz="quarter" idx="13"/>
-          </p:nvPr>
-        </p:nvSpPr>
-        <p:spPr>
-          <a:xfrm>
-            <a:off x="0" y="6356352"/>
-            <a:ext cx="12192000" cy="365125"/>
-          </a:xfrm>
-        </p:spPr>
-        <p:txBody>
-          <a:bodyPr/>
-          <a:lstStyle/>
-          <a:p>
-            <a:r>
-              <a:rPr lang="en-US"/>
-              <a:t>Restricted - </a:t>
-            </a:r>
-            <a:r>
-              <a:rPr lang="ar-SA"/>
-              <a:t>مقيد</a:t>
-            </a:r>
-            <a:endParaRPr lang="en-US"/>
-          </a:p>
-        </p:txBody>
-      </p:sp>
-      <p:sp>
-        <p:nvSpPr>
-          <p:cNvPr id="12" name="TextBox 11"/>
+          <p:cNvPr id="3" name="TextBox 2"/>
           <p:cNvSpPr txBox="1"/>
           <p:nvPr/>
         </p:nvSpPr>
         <p:spPr>
           <a:xfrm>
-            <a:off x="411480" y="155448"/>
-            <a:ext cx="11384280" cy="548640"/>
+            <a:off x="1234440" y="155448"/>
+            <a:ext cx="10561320" cy="548640"/>
           </a:xfrm>
           <a:prstGeom prst="rect">
             <a:avLst/>
@@ -24558,7 +23832,7 @@
       </p:sp>
       <p:cxnSp>
         <p:nvCxnSpPr>
-          <p:cNvPr id="13" name="Connector 12"/>
+          <p:cNvPr id="4" name="Connector 3"/>
           <p:cNvCxnSpPr/>
           <p:nvPr/>
         </p:nvCxnSpPr>
@@ -24587,7 +23861,7 @@
       </p:cxnSp>
       <p:sp>
         <p:nvSpPr>
-          <p:cNvPr id="14" name="TextBox 13"/>
+          <p:cNvPr id="5" name="TextBox 4"/>
           <p:cNvSpPr txBox="1"/>
           <p:nvPr/>
         </p:nvSpPr>
@@ -24624,7 +23898,7 @@
       </p:sp>
       <p:sp>
         <p:nvSpPr>
-          <p:cNvPr id="15" name="Rounded Rectangle 14"/>
+          <p:cNvPr id="6" name="Rounded Rectangle 5"/>
           <p:cNvSpPr/>
           <p:nvPr/>
         </p:nvSpPr>
@@ -24662,7 +23936,7 @@
       </p:sp>
       <p:sp>
         <p:nvSpPr>
-          <p:cNvPr id="16" name="TextBox 15"/>
+          <p:cNvPr id="7" name="TextBox 6"/>
           <p:cNvSpPr txBox="1"/>
           <p:nvPr/>
         </p:nvSpPr>
@@ -24699,7 +23973,7 @@
       </p:sp>
       <p:cxnSp>
         <p:nvCxnSpPr>
-          <p:cNvPr id="17" name="Connector 16"/>
+          <p:cNvPr id="8" name="Connector 7"/>
           <p:cNvCxnSpPr/>
           <p:nvPr/>
         </p:nvCxnSpPr>
@@ -24720,7 +23994,7 @@
       </p:cxnSp>
       <p:sp>
         <p:nvSpPr>
-          <p:cNvPr id="18" name="TextBox 17"/>
+          <p:cNvPr id="9" name="TextBox 8"/>
           <p:cNvSpPr txBox="1"/>
           <p:nvPr/>
         </p:nvSpPr>
@@ -24819,7 +24093,7 @@
       </p:sp>
       <p:sp>
         <p:nvSpPr>
-          <p:cNvPr id="19" name="Rounded Rectangle 18"/>
+          <p:cNvPr id="10" name="Rounded Rectangle 9"/>
           <p:cNvSpPr/>
           <p:nvPr/>
         </p:nvSpPr>
@@ -24850,7 +24124,7 @@
       </p:sp>
       <p:sp>
         <p:nvSpPr>
-          <p:cNvPr id="20" name="TextBox 19"/>
+          <p:cNvPr id="11" name="TextBox 10"/>
           <p:cNvSpPr txBox="1"/>
           <p:nvPr/>
         </p:nvSpPr>
@@ -24901,7 +24175,7 @@
       </p:sp>
       <p:sp>
         <p:nvSpPr>
-          <p:cNvPr id="21" name="Rounded Rectangle 20"/>
+          <p:cNvPr id="12" name="Rounded Rectangle 11"/>
           <p:cNvSpPr/>
           <p:nvPr/>
         </p:nvSpPr>
@@ -24939,7 +24213,7 @@
       </p:sp>
       <p:sp>
         <p:nvSpPr>
-          <p:cNvPr id="22" name="TextBox 21"/>
+          <p:cNvPr id="13" name="TextBox 12"/>
           <p:cNvSpPr txBox="1"/>
           <p:nvPr/>
         </p:nvSpPr>
@@ -24976,7 +24250,7 @@
       </p:sp>
       <p:cxnSp>
         <p:nvCxnSpPr>
-          <p:cNvPr id="23" name="Connector 22"/>
+          <p:cNvPr id="14" name="Connector 13"/>
           <p:cNvCxnSpPr/>
           <p:nvPr/>
         </p:nvCxnSpPr>
@@ -24997,7 +24271,7 @@
       </p:cxnSp>
       <p:sp>
         <p:nvSpPr>
-          <p:cNvPr id="24" name="TextBox 23"/>
+          <p:cNvPr id="15" name="TextBox 14"/>
           <p:cNvSpPr txBox="1"/>
           <p:nvPr/>
         </p:nvSpPr>
@@ -25071,7 +24345,7 @@
       </p:sp>
       <p:sp>
         <p:nvSpPr>
-          <p:cNvPr id="25" name="Rounded Rectangle 24"/>
+          <p:cNvPr id="16" name="Rounded Rectangle 15"/>
           <p:cNvSpPr/>
           <p:nvPr/>
         </p:nvSpPr>
@@ -25102,7 +24376,7 @@
       </p:sp>
       <p:sp>
         <p:nvSpPr>
-          <p:cNvPr id="26" name="TextBox 25"/>
+          <p:cNvPr id="17" name="TextBox 16"/>
           <p:cNvSpPr txBox="1"/>
           <p:nvPr/>
         </p:nvSpPr>
@@ -25153,7 +24427,7 @@
       </p:sp>
       <p:sp>
         <p:nvSpPr>
-          <p:cNvPr id="27" name="Rounded Rectangle 26"/>
+          <p:cNvPr id="18" name="Rounded Rectangle 17"/>
           <p:cNvSpPr/>
           <p:nvPr/>
         </p:nvSpPr>
@@ -25191,7 +24465,7 @@
       </p:sp>
       <p:sp>
         <p:nvSpPr>
-          <p:cNvPr id="28" name="TextBox 27"/>
+          <p:cNvPr id="19" name="TextBox 18"/>
           <p:cNvSpPr txBox="1"/>
           <p:nvPr/>
         </p:nvSpPr>
@@ -25228,7 +24502,7 @@
       </p:sp>
       <p:cxnSp>
         <p:nvCxnSpPr>
-          <p:cNvPr id="29" name="Connector 28"/>
+          <p:cNvPr id="20" name="Connector 19"/>
           <p:cNvCxnSpPr/>
           <p:nvPr/>
         </p:nvCxnSpPr>
@@ -25249,7 +24523,7 @@
       </p:cxnSp>
       <p:sp>
         <p:nvSpPr>
-          <p:cNvPr id="30" name="TextBox 29"/>
+          <p:cNvPr id="21" name="TextBox 20"/>
           <p:cNvSpPr txBox="1"/>
           <p:nvPr/>
         </p:nvSpPr>
@@ -25323,7 +24597,7 @@
       </p:sp>
       <p:sp>
         <p:nvSpPr>
-          <p:cNvPr id="31" name="Rounded Rectangle 30"/>
+          <p:cNvPr id="22" name="Rounded Rectangle 21"/>
           <p:cNvSpPr/>
           <p:nvPr/>
         </p:nvSpPr>
@@ -25354,7 +24628,7 @@
       </p:sp>
       <p:sp>
         <p:nvSpPr>
-          <p:cNvPr id="32" name="TextBox 31"/>
+          <p:cNvPr id="23" name="TextBox 22"/>
           <p:cNvSpPr txBox="1"/>
           <p:nvPr/>
         </p:nvSpPr>
@@ -25405,7 +24679,7 @@
       </p:sp>
       <p:sp>
         <p:nvSpPr>
-          <p:cNvPr id="33" name="Rounded Rectangle 32"/>
+          <p:cNvPr id="24" name="Rounded Rectangle 23"/>
           <p:cNvSpPr/>
           <p:nvPr/>
         </p:nvSpPr>
@@ -25443,7 +24717,7 @@
       </p:sp>
       <p:sp>
         <p:nvSpPr>
-          <p:cNvPr id="34" name="TextBox 33"/>
+          <p:cNvPr id="25" name="TextBox 24"/>
           <p:cNvSpPr txBox="1"/>
           <p:nvPr/>
         </p:nvSpPr>
@@ -25480,7 +24754,7 @@
       </p:sp>
       <p:cxnSp>
         <p:nvCxnSpPr>
-          <p:cNvPr id="35" name="Connector 34"/>
+          <p:cNvPr id="26" name="Connector 25"/>
           <p:cNvCxnSpPr/>
           <p:nvPr/>
         </p:nvCxnSpPr>
@@ -25501,7 +24775,7 @@
       </p:cxnSp>
       <p:sp>
         <p:nvSpPr>
-          <p:cNvPr id="36" name="TextBox 35"/>
+          <p:cNvPr id="27" name="TextBox 26"/>
           <p:cNvSpPr txBox="1"/>
           <p:nvPr/>
         </p:nvSpPr>
@@ -25600,7 +24874,7 @@
       </p:sp>
       <p:sp>
         <p:nvSpPr>
-          <p:cNvPr id="37" name="Rounded Rectangle 36"/>
+          <p:cNvPr id="28" name="Rounded Rectangle 27"/>
           <p:cNvSpPr/>
           <p:nvPr/>
         </p:nvSpPr>
@@ -25631,7 +24905,7 @@
       </p:sp>
       <p:sp>
         <p:nvSpPr>
-          <p:cNvPr id="38" name="TextBox 37"/>
+          <p:cNvPr id="29" name="TextBox 28"/>
           <p:cNvSpPr txBox="1"/>
           <p:nvPr/>
         </p:nvSpPr>
@@ -25682,7 +24956,7 @@
       </p:sp>
       <p:sp>
         <p:nvSpPr>
-          <p:cNvPr id="39" name="TextBox 38"/>
+          <p:cNvPr id="30" name="TextBox 29"/>
           <p:cNvSpPr txBox="1"/>
           <p:nvPr/>
         </p:nvSpPr>
@@ -25719,7 +24993,7 @@
       </p:sp>
       <p:sp>
         <p:nvSpPr>
-          <p:cNvPr id="40" name="Rounded Rectangle 39"/>
+          <p:cNvPr id="31" name="Rounded Rectangle 30"/>
           <p:cNvSpPr/>
           <p:nvPr/>
         </p:nvSpPr>
@@ -25750,7 +25024,7 @@
       </p:sp>
       <p:sp>
         <p:nvSpPr>
-          <p:cNvPr id="41" name="TextBox 40"/>
+          <p:cNvPr id="32" name="TextBox 31"/>
           <p:cNvSpPr txBox="1"/>
           <p:nvPr/>
         </p:nvSpPr>
@@ -25787,7 +25061,7 @@
       </p:sp>
       <p:sp>
         <p:nvSpPr>
-          <p:cNvPr id="42" name="TextBox 41"/>
+          <p:cNvPr id="33" name="TextBox 32"/>
           <p:cNvSpPr txBox="1"/>
           <p:nvPr/>
         </p:nvSpPr>
@@ -25828,7 +25102,7 @@
       </p:sp>
       <p:sp>
         <p:nvSpPr>
-          <p:cNvPr id="43" name="Rounded Rectangle 42"/>
+          <p:cNvPr id="34" name="Rounded Rectangle 33"/>
           <p:cNvSpPr/>
           <p:nvPr/>
         </p:nvSpPr>
@@ -25859,7 +25133,7 @@
       </p:sp>
       <p:sp>
         <p:nvSpPr>
-          <p:cNvPr id="44" name="TextBox 43"/>
+          <p:cNvPr id="35" name="TextBox 34"/>
           <p:cNvSpPr txBox="1"/>
           <p:nvPr/>
         </p:nvSpPr>
@@ -25896,7 +25170,7 @@
       </p:sp>
       <p:sp>
         <p:nvSpPr>
-          <p:cNvPr id="45" name="TextBox 44"/>
+          <p:cNvPr id="36" name="TextBox 35"/>
           <p:cNvSpPr txBox="1"/>
           <p:nvPr/>
         </p:nvSpPr>
@@ -25937,7 +25211,7 @@
       </p:sp>
       <p:sp>
         <p:nvSpPr>
-          <p:cNvPr id="46" name="Rounded Rectangle 45"/>
+          <p:cNvPr id="37" name="Rounded Rectangle 36"/>
           <p:cNvSpPr/>
           <p:nvPr/>
         </p:nvSpPr>
@@ -25968,7 +25242,7 @@
       </p:sp>
       <p:sp>
         <p:nvSpPr>
-          <p:cNvPr id="47" name="TextBox 46"/>
+          <p:cNvPr id="38" name="TextBox 37"/>
           <p:cNvSpPr txBox="1"/>
           <p:nvPr/>
         </p:nvSpPr>
@@ -26005,7 +25279,7 @@
       </p:sp>
       <p:sp>
         <p:nvSpPr>
-          <p:cNvPr id="48" name="TextBox 47"/>
+          <p:cNvPr id="39" name="TextBox 38"/>
           <p:cNvSpPr txBox="1"/>
           <p:nvPr/>
         </p:nvSpPr>
@@ -26046,7 +25320,7 @@
       </p:sp>
       <p:sp>
         <p:nvSpPr>
-          <p:cNvPr id="49" name="Rounded Rectangle 48"/>
+          <p:cNvPr id="40" name="Rounded Rectangle 39"/>
           <p:cNvSpPr/>
           <p:nvPr/>
         </p:nvSpPr>
@@ -26077,7 +25351,7 @@
       </p:sp>
       <p:sp>
         <p:nvSpPr>
-          <p:cNvPr id="50" name="TextBox 49"/>
+          <p:cNvPr id="41" name="TextBox 40"/>
           <p:cNvSpPr txBox="1"/>
           <p:nvPr/>
         </p:nvSpPr>
@@ -26114,7 +25388,7 @@
       </p:sp>
       <p:sp>
         <p:nvSpPr>
-          <p:cNvPr id="51" name="TextBox 50"/>
+          <p:cNvPr id="42" name="TextBox 41"/>
           <p:cNvSpPr txBox="1"/>
           <p:nvPr/>
         </p:nvSpPr>
@@ -26197,53 +25471,6 @@
       </p:grpSpPr>
       <p:sp>
         <p:nvSpPr>
-          <p:cNvPr id="2" name="SecloreFooter">
-            <a:extLst>
-              <a:ext uri="{FF2B5EF4-FFF2-40B4-BE49-F238E27FC236}">
-                <a16:creationId xmlns:a16="http://schemas.microsoft.com/office/drawing/2014/main" id="{6CC517B5-B24D-4177-9328-EED9BBDA23E3}"/>
-              </a:ext>
-            </a:extLst>
-          </p:cNvPr>
-          <p:cNvSpPr>
-            <a:spLocks noGrp="1"/>
-          </p:cNvSpPr>
-          <p:nvPr>
-            <p:ph type="ftr" sz="quarter" idx="13"/>
-          </p:nvPr>
-        </p:nvSpPr>
-        <p:spPr>
-          <a:xfrm>
-            <a:off x="0" y="6464617"/>
-            <a:ext cx="12192000" cy="281378"/>
-          </a:xfrm>
-        </p:spPr>
-        <p:txBody>
-          <a:bodyPr/>
-          <a:lstStyle/>
-          <a:p>
-            <a:pPr defTabSz="812810">
-              <a:buClrTx/>
-            </a:pPr>
-            <a:r>
-              <a:rPr lang="en-US" sz="1200" kern="1200">
-                <a:ea typeface="+mn-ea"/>
-              </a:rPr>
-              <a:t>Restricted - </a:t>
-            </a:r>
-            <a:r>
-              <a:rPr lang="ar-SA" sz="1200" kern="1200">
-                <a:ea typeface="+mn-ea"/>
-              </a:rPr>
-              <a:t>مقيد</a:t>
-            </a:r>
-            <a:endParaRPr lang="en-US" sz="1200" kern="1200">
-              <a:ea typeface="+mn-ea"/>
-            </a:endParaRPr>
-          </a:p>
-        </p:txBody>
-      </p:sp>
-      <p:sp>
-        <p:nvSpPr>
           <p:cNvPr id="3" name="title">
             <a:extLst>
               <a:ext uri="{FF2B5EF4-FFF2-40B4-BE49-F238E27FC236}">
@@ -26335,16 +25562,23 @@
         </p:nvSpPr>
         <p:spPr>
           <a:xfrm>
-            <a:off x="227420" y="6498731"/>
-            <a:ext cx="467734" cy="206790"/>
-          </a:xfrm>
-        </p:spPr>
-        <p:txBody>
-          <a:bodyPr/>
-          <a:lstStyle/>
-          <a:p>
+            <a:off x="411480" y="155448"/>
+            <a:ext cx="822960" cy="548640"/>
+          </a:xfrm>
+        </p:spPr>
+        <p:txBody>
+          <a:bodyPr anchor="ctr" lIns="0"/>
+          <a:lstStyle/>
+          <a:p>
+            <a:pPr algn="l"/>
             <a:fld id="{679EF615-E246-4FA6-9E75-123AAEB83405}" type="slidenum">
-              <a:rPr lang="en-PH" smtClean="0"/>
+              <a:rPr lang="en-US" smtClean="0" sz="1200" b="1">
+                <a:solidFill>
+                  <a:srgbClr val="2A206A"/>
+                </a:solidFill>
+                <a:latin typeface="DiodrumArabic-Semibold"/>
+                <a:cs typeface="DiodrumArabic-Semibold"/>
+              </a:rPr>
               <a:pPr/>
               <a:t>5</a:t>
             </a:fld>
@@ -26354,52 +25588,14 @@
       </p:sp>
       <p:sp>
         <p:nvSpPr>
-          <p:cNvPr id="11" name="SecloreFooter">
-            <a:extLst>
-              <a:ext uri="{FF2B5EF4-FFF2-40B4-BE49-F238E27FC236}">
-                <a16:creationId xmlns:a16="http://schemas.microsoft.com/office/drawing/2014/main" id="{FE53BD42-AF09-4407-AF8B-D0497E98ECF6}"/>
-              </a:ext>
-            </a:extLst>
-          </p:cNvPr>
-          <p:cNvSpPr>
-            <a:spLocks noGrp="1"/>
-          </p:cNvSpPr>
-          <p:nvPr>
-            <p:ph type="ftr" sz="quarter" idx="13"/>
-          </p:nvPr>
-        </p:nvSpPr>
-        <p:spPr>
-          <a:xfrm>
-            <a:off x="0" y="6356352"/>
-            <a:ext cx="12192000" cy="365125"/>
-          </a:xfrm>
-        </p:spPr>
-        <p:txBody>
-          <a:bodyPr/>
-          <a:lstStyle/>
-          <a:p>
-            <a:r>
-              <a:rPr lang="en-US"/>
-              <a:t>Restricted - </a:t>
-            </a:r>
-            <a:r>
-              <a:rPr lang="ar-SA"/>
-              <a:t>مقيد</a:t>
-            </a:r>
-            <a:endParaRPr lang="en-US"/>
-          </a:p>
-        </p:txBody>
-      </p:sp>
-      <p:sp>
-        <p:nvSpPr>
-          <p:cNvPr id="12" name="TextBox 11"/>
+          <p:cNvPr id="3" name="TextBox 2"/>
           <p:cNvSpPr txBox="1"/>
           <p:nvPr/>
         </p:nvSpPr>
         <p:spPr>
           <a:xfrm>
-            <a:off x="411480" y="155448"/>
-            <a:ext cx="11384280" cy="548640"/>
+            <a:off x="1234440" y="155448"/>
+            <a:ext cx="10561320" cy="548640"/>
           </a:xfrm>
           <a:prstGeom prst="rect">
             <a:avLst/>
@@ -26429,7 +25625,7 @@
       </p:sp>
       <p:cxnSp>
         <p:nvCxnSpPr>
-          <p:cNvPr id="13" name="Connector 12"/>
+          <p:cNvPr id="4" name="Connector 3"/>
           <p:cNvCxnSpPr/>
           <p:nvPr/>
         </p:nvCxnSpPr>
@@ -26458,7 +25654,7 @@
       </p:cxnSp>
       <p:sp>
         <p:nvSpPr>
-          <p:cNvPr id="14" name="TextBox 13"/>
+          <p:cNvPr id="5" name="TextBox 4"/>
           <p:cNvSpPr txBox="1"/>
           <p:nvPr/>
         </p:nvSpPr>
@@ -26495,7 +25691,7 @@
       </p:sp>
       <p:sp>
         <p:nvSpPr>
-          <p:cNvPr id="15" name="Rounded Rectangle 14"/>
+          <p:cNvPr id="6" name="Rounded Rectangle 5"/>
           <p:cNvSpPr/>
           <p:nvPr/>
         </p:nvSpPr>
@@ -26533,7 +25729,7 @@
       </p:sp>
       <p:sp>
         <p:nvSpPr>
-          <p:cNvPr id="16" name="TextBox 15"/>
+          <p:cNvPr id="7" name="TextBox 6"/>
           <p:cNvSpPr txBox="1"/>
           <p:nvPr/>
         </p:nvSpPr>
@@ -26570,7 +25766,7 @@
       </p:sp>
       <p:sp>
         <p:nvSpPr>
-          <p:cNvPr id="17" name="TextBox 16"/>
+          <p:cNvPr id="8" name="TextBox 7"/>
           <p:cNvSpPr txBox="1"/>
           <p:nvPr/>
         </p:nvSpPr>
@@ -26607,7 +25803,7 @@
       </p:sp>
       <p:sp>
         <p:nvSpPr>
-          <p:cNvPr id="18" name="TextBox 17"/>
+          <p:cNvPr id="9" name="TextBox 8"/>
           <p:cNvSpPr txBox="1"/>
           <p:nvPr/>
         </p:nvSpPr>
@@ -26644,7 +25840,7 @@
       </p:sp>
       <p:sp>
         <p:nvSpPr>
-          <p:cNvPr id="19" name="Rounded Rectangle 18"/>
+          <p:cNvPr id="10" name="Rounded Rectangle 9"/>
           <p:cNvSpPr/>
           <p:nvPr/>
         </p:nvSpPr>
@@ -26682,7 +25878,7 @@
       </p:sp>
       <p:sp>
         <p:nvSpPr>
-          <p:cNvPr id="20" name="TextBox 19"/>
+          <p:cNvPr id="11" name="TextBox 10"/>
           <p:cNvSpPr txBox="1"/>
           <p:nvPr/>
         </p:nvSpPr>
@@ -26719,7 +25915,7 @@
       </p:sp>
       <p:sp>
         <p:nvSpPr>
-          <p:cNvPr id="21" name="TextBox 20"/>
+          <p:cNvPr id="12" name="TextBox 11"/>
           <p:cNvSpPr txBox="1"/>
           <p:nvPr/>
         </p:nvSpPr>
@@ -26756,7 +25952,7 @@
       </p:sp>
       <p:sp>
         <p:nvSpPr>
-          <p:cNvPr id="22" name="TextBox 21"/>
+          <p:cNvPr id="13" name="TextBox 12"/>
           <p:cNvSpPr txBox="1"/>
           <p:nvPr/>
         </p:nvSpPr>
@@ -26793,7 +25989,7 @@
       </p:sp>
       <p:sp>
         <p:nvSpPr>
-          <p:cNvPr id="23" name="Rounded Rectangle 22"/>
+          <p:cNvPr id="14" name="Rounded Rectangle 13"/>
           <p:cNvSpPr/>
           <p:nvPr/>
         </p:nvSpPr>
@@ -26831,7 +26027,7 @@
       </p:sp>
       <p:sp>
         <p:nvSpPr>
-          <p:cNvPr id="24" name="TextBox 23"/>
+          <p:cNvPr id="15" name="TextBox 14"/>
           <p:cNvSpPr txBox="1"/>
           <p:nvPr/>
         </p:nvSpPr>
@@ -26868,7 +26064,7 @@
       </p:sp>
       <p:sp>
         <p:nvSpPr>
-          <p:cNvPr id="25" name="TextBox 24"/>
+          <p:cNvPr id="16" name="TextBox 15"/>
           <p:cNvSpPr txBox="1"/>
           <p:nvPr/>
         </p:nvSpPr>
@@ -26905,7 +26101,7 @@
       </p:sp>
       <p:sp>
         <p:nvSpPr>
-          <p:cNvPr id="26" name="TextBox 25"/>
+          <p:cNvPr id="17" name="TextBox 16"/>
           <p:cNvSpPr txBox="1"/>
           <p:nvPr/>
         </p:nvSpPr>
@@ -26942,7 +26138,7 @@
       </p:sp>
       <p:sp>
         <p:nvSpPr>
-          <p:cNvPr id="27" name="Rounded Rectangle 26"/>
+          <p:cNvPr id="18" name="Rounded Rectangle 17"/>
           <p:cNvSpPr/>
           <p:nvPr/>
         </p:nvSpPr>
@@ -26980,7 +26176,7 @@
       </p:sp>
       <p:sp>
         <p:nvSpPr>
-          <p:cNvPr id="28" name="TextBox 27"/>
+          <p:cNvPr id="19" name="TextBox 18"/>
           <p:cNvSpPr txBox="1"/>
           <p:nvPr/>
         </p:nvSpPr>
@@ -27017,7 +26213,7 @@
       </p:sp>
       <p:sp>
         <p:nvSpPr>
-          <p:cNvPr id="29" name="TextBox 28"/>
+          <p:cNvPr id="20" name="TextBox 19"/>
           <p:cNvSpPr txBox="1"/>
           <p:nvPr/>
         </p:nvSpPr>
@@ -27054,7 +26250,7 @@
       </p:sp>
       <p:sp>
         <p:nvSpPr>
-          <p:cNvPr id="30" name="TextBox 29"/>
+          <p:cNvPr id="21" name="TextBox 20"/>
           <p:cNvSpPr txBox="1"/>
           <p:nvPr/>
         </p:nvSpPr>
@@ -27091,7 +26287,7 @@
       </p:sp>
       <p:sp>
         <p:nvSpPr>
-          <p:cNvPr id="31" name="Rounded Rectangle 30"/>
+          <p:cNvPr id="22" name="Rounded Rectangle 21"/>
           <p:cNvSpPr/>
           <p:nvPr/>
         </p:nvSpPr>
@@ -27135,7 +26331,7 @@
       </p:sp>
       <p:sp>
         <p:nvSpPr>
-          <p:cNvPr id="32" name="TextBox 31"/>
+          <p:cNvPr id="23" name="TextBox 22"/>
           <p:cNvSpPr txBox="1"/>
           <p:nvPr/>
         </p:nvSpPr>
@@ -27172,7 +26368,7 @@
       </p:sp>
       <p:sp>
         <p:nvSpPr>
-          <p:cNvPr id="33" name="TextBox 32"/>
+          <p:cNvPr id="24" name="TextBox 23"/>
           <p:cNvSpPr txBox="1"/>
           <p:nvPr/>
         </p:nvSpPr>
@@ -27236,7 +26432,7 @@
       </p:sp>
       <p:sp>
         <p:nvSpPr>
-          <p:cNvPr id="34" name="TextBox 33"/>
+          <p:cNvPr id="25" name="TextBox 24"/>
           <p:cNvSpPr txBox="1"/>
           <p:nvPr/>
         </p:nvSpPr>
@@ -27273,7 +26469,7 @@
       </p:sp>
       <p:graphicFrame>
         <p:nvGraphicFramePr>
-          <p:cNvPr id="35" name="Table 34"/>
+          <p:cNvPr id="26" name="Table 25"/>
           <p:cNvGraphicFramePr>
             <a:graphicFrameLocks noGrp="1"/>
           </p:cNvGraphicFramePr>
@@ -28075,7 +27271,7 @@
       </p:graphicFrame>
       <p:sp>
         <p:nvSpPr>
-          <p:cNvPr id="36" name="Oval 35"/>
+          <p:cNvPr id="27" name="Oval 26"/>
           <p:cNvSpPr/>
           <p:nvPr/>
         </p:nvSpPr>
@@ -28104,7 +27300,7 @@
       </p:sp>
       <p:sp>
         <p:nvSpPr>
-          <p:cNvPr id="37" name="Oval 36"/>
+          <p:cNvPr id="28" name="Oval 27"/>
           <p:cNvSpPr/>
           <p:nvPr/>
         </p:nvSpPr>
@@ -28133,7 +27329,7 @@
       </p:sp>
       <p:sp>
         <p:nvSpPr>
-          <p:cNvPr id="38" name="Oval 37"/>
+          <p:cNvPr id="29" name="Oval 28"/>
           <p:cNvSpPr/>
           <p:nvPr/>
         </p:nvSpPr>
@@ -28458,53 +27654,6 @@
       </p:sp>
       <p:sp>
         <p:nvSpPr>
-          <p:cNvPr id="2" name="SecloreFooter">
-            <a:extLst>
-              <a:ext uri="{FF2B5EF4-FFF2-40B4-BE49-F238E27FC236}">
-                <a16:creationId xmlns:a16="http://schemas.microsoft.com/office/drawing/2014/main" id="{7C5C409F-5ECF-46AD-96DC-FDA8B9EFC21E}"/>
-              </a:ext>
-            </a:extLst>
-          </p:cNvPr>
-          <p:cNvSpPr>
-            <a:spLocks noGrp="1"/>
-          </p:cNvSpPr>
-          <p:nvPr>
-            <p:ph type="ftr" sz="quarter" idx="13"/>
-          </p:nvPr>
-        </p:nvSpPr>
-        <p:spPr>
-          <a:xfrm>
-            <a:off x="0" y="6464617"/>
-            <a:ext cx="12192000" cy="281378"/>
-          </a:xfrm>
-        </p:spPr>
-        <p:txBody>
-          <a:bodyPr/>
-          <a:lstStyle/>
-          <a:p>
-            <a:pPr defTabSz="812810">
-              <a:buClrTx/>
-            </a:pPr>
-            <a:r>
-              <a:rPr lang="en-US" sz="1200" kern="1200">
-                <a:ea typeface="+mn-ea"/>
-              </a:rPr>
-              <a:t>Restricted - </a:t>
-            </a:r>
-            <a:r>
-              <a:rPr lang="ar-SA" sz="1200" kern="1200">
-                <a:ea typeface="+mn-ea"/>
-              </a:rPr>
-              <a:t>مقيد</a:t>
-            </a:r>
-            <a:endParaRPr lang="en-US" sz="1200" kern="1200">
-              <a:ea typeface="+mn-ea"/>
-            </a:endParaRPr>
-          </a:p>
-        </p:txBody>
-      </p:sp>
-      <p:sp>
-        <p:nvSpPr>
           <p:cNvPr id="9902" name="TextBox 9901"/>
           <p:cNvSpPr txBox="1"/>
           <p:nvPr/>
@@ -28822,58 +27971,27 @@
         </p:nvSpPr>
         <p:spPr>
           <a:xfrm>
-            <a:off x="227420" y="6498731"/>
-            <a:ext cx="467734" cy="206790"/>
-          </a:xfrm>
-        </p:spPr>
-        <p:txBody>
-          <a:bodyPr/>
-          <a:lstStyle/>
-          <a:p>
+            <a:off x="411480" y="402336"/>
+            <a:ext cx="822960" cy="640080"/>
+          </a:xfrm>
+        </p:spPr>
+        <p:txBody>
+          <a:bodyPr anchor="ctr" lIns="0"/>
+          <a:lstStyle/>
+          <a:p>
+            <a:pPr algn="l"/>
             <a:fld id="{679EF615-E246-4FA6-9E75-123AAEB83405}" type="slidenum">
-              <a:rPr lang="en-PH" smtClean="0"/>
+              <a:rPr lang="en-US" smtClean="0" sz="1200" b="1">
+                <a:solidFill>
+                  <a:srgbClr val="2A206A"/>
+                </a:solidFill>
+                <a:latin typeface="DiodrumArabic-Semibold"/>
+                <a:cs typeface="DiodrumArabic-Semibold"/>
+              </a:rPr>
               <a:pPr/>
               <a:t>4</a:t>
             </a:fld>
             <a:endParaRPr lang="en-PH" dirty="0"/>
-          </a:p>
-        </p:txBody>
-      </p:sp>
-      <p:sp>
-        <p:nvSpPr>
-          <p:cNvPr id="12" name="SecloreFooter">
-            <a:extLst>
-              <a:ext uri="{FF2B5EF4-FFF2-40B4-BE49-F238E27FC236}">
-                <a16:creationId xmlns:a16="http://schemas.microsoft.com/office/drawing/2014/main" id="{3256E98C-32DF-42DD-9307-7E10BBFC8907}"/>
-              </a:ext>
-            </a:extLst>
-          </p:cNvPr>
-          <p:cNvSpPr>
-            <a:spLocks noGrp="1"/>
-          </p:cNvSpPr>
-          <p:nvPr>
-            <p:ph type="ftr" sz="quarter" idx="13"/>
-          </p:nvPr>
-        </p:nvSpPr>
-        <p:spPr>
-          <a:xfrm>
-            <a:off x="0" y="6356352"/>
-            <a:ext cx="12192000" cy="365125"/>
-          </a:xfrm>
-        </p:spPr>
-        <p:txBody>
-          <a:bodyPr/>
-          <a:lstStyle/>
-          <a:p>
-            <a:r>
-              <a:rPr lang="en-US"/>
-              <a:t>Restricted - </a:t>
-            </a:r>
-            <a:r>
-              <a:rPr lang="ar-SA"/>
-              <a:t>مقيد</a:t>
-            </a:r>
-            <a:endParaRPr lang="en-US"/>
           </a:p>
         </p:txBody>
       </p:sp>
@@ -28974,16 +28092,23 @@
         </p:nvSpPr>
         <p:spPr>
           <a:xfrm>
-            <a:off x="227420" y="6498731"/>
-            <a:ext cx="467734" cy="206790"/>
-          </a:xfrm>
-        </p:spPr>
-        <p:txBody>
-          <a:bodyPr/>
-          <a:lstStyle/>
-          <a:p>
+            <a:off x="411480" y="155448"/>
+            <a:ext cx="822960" cy="548640"/>
+          </a:xfrm>
+        </p:spPr>
+        <p:txBody>
+          <a:bodyPr anchor="ctr" lIns="0"/>
+          <a:lstStyle/>
+          <a:p>
+            <a:pPr algn="l"/>
             <a:fld id="{679EF615-E246-4FA6-9E75-123AAEB83405}" type="slidenum">
-              <a:rPr lang="en-PH" smtClean="0"/>
+              <a:rPr lang="en-US" smtClean="0" sz="1200" b="1">
+                <a:solidFill>
+                  <a:srgbClr val="2A206A"/>
+                </a:solidFill>
+                <a:latin typeface="DiodrumArabic-Semibold"/>
+                <a:cs typeface="DiodrumArabic-Semibold"/>
+              </a:rPr>
               <a:pPr/>
               <a:t>5</a:t>
             </a:fld>
@@ -28993,52 +28118,14 @@
       </p:sp>
       <p:sp>
         <p:nvSpPr>
-          <p:cNvPr id="11" name="SecloreFooter">
-            <a:extLst>
-              <a:ext uri="{FF2B5EF4-FFF2-40B4-BE49-F238E27FC236}">
-                <a16:creationId xmlns:a16="http://schemas.microsoft.com/office/drawing/2014/main" id="{FE53BD42-AF09-4407-AF8B-D0497E98ECF6}"/>
-              </a:ext>
-            </a:extLst>
-          </p:cNvPr>
-          <p:cNvSpPr>
-            <a:spLocks noGrp="1"/>
-          </p:cNvSpPr>
-          <p:nvPr>
-            <p:ph type="ftr" sz="quarter" idx="13"/>
-          </p:nvPr>
-        </p:nvSpPr>
-        <p:spPr>
-          <a:xfrm>
-            <a:off x="0" y="6356352"/>
-            <a:ext cx="12192000" cy="365125"/>
-          </a:xfrm>
-        </p:spPr>
-        <p:txBody>
-          <a:bodyPr/>
-          <a:lstStyle/>
-          <a:p>
-            <a:r>
-              <a:rPr lang="en-US"/>
-              <a:t>Restricted - </a:t>
-            </a:r>
-            <a:r>
-              <a:rPr lang="ar-SA"/>
-              <a:t>مقيد</a:t>
-            </a:r>
-            <a:endParaRPr lang="en-US"/>
-          </a:p>
-        </p:txBody>
-      </p:sp>
-      <p:sp>
-        <p:nvSpPr>
-          <p:cNvPr id="12" name="TextBox 11"/>
+          <p:cNvPr id="3" name="TextBox 2"/>
           <p:cNvSpPr txBox="1"/>
           <p:nvPr/>
         </p:nvSpPr>
         <p:spPr>
           <a:xfrm>
-            <a:off x="411480" y="155448"/>
-            <a:ext cx="11384280" cy="548640"/>
+            <a:off x="1234440" y="155448"/>
+            <a:ext cx="10561320" cy="548640"/>
           </a:xfrm>
           <a:prstGeom prst="rect">
             <a:avLst/>
@@ -29078,7 +28165,7 @@
       </p:sp>
       <p:cxnSp>
         <p:nvCxnSpPr>
-          <p:cNvPr id="13" name="Connector 12"/>
+          <p:cNvPr id="4" name="Connector 3"/>
           <p:cNvCxnSpPr/>
           <p:nvPr/>
         </p:nvCxnSpPr>
@@ -29107,7 +28194,7 @@
       </p:cxnSp>
       <p:sp>
         <p:nvSpPr>
-          <p:cNvPr id="14" name="TextBox 13"/>
+          <p:cNvPr id="5" name="TextBox 4"/>
           <p:cNvSpPr txBox="1"/>
           <p:nvPr/>
         </p:nvSpPr>
@@ -29144,7 +28231,7 @@
       </p:sp>
       <p:sp>
         <p:nvSpPr>
-          <p:cNvPr id="15" name="Rounded Rectangle 14"/>
+          <p:cNvPr id="6" name="Rounded Rectangle 5"/>
           <p:cNvSpPr/>
           <p:nvPr/>
         </p:nvSpPr>
@@ -29188,7 +28275,7 @@
       </p:sp>
       <p:sp>
         <p:nvSpPr>
-          <p:cNvPr id="16" name="TextBox 15"/>
+          <p:cNvPr id="7" name="TextBox 6"/>
           <p:cNvSpPr txBox="1"/>
           <p:nvPr/>
         </p:nvSpPr>
@@ -29225,7 +28312,7 @@
       </p:sp>
       <p:sp>
         <p:nvSpPr>
-          <p:cNvPr id="17" name="TextBox 16"/>
+          <p:cNvPr id="8" name="TextBox 7"/>
           <p:cNvSpPr txBox="1"/>
           <p:nvPr/>
         </p:nvSpPr>
@@ -29262,7 +28349,7 @@
       </p:sp>
       <p:sp>
         <p:nvSpPr>
-          <p:cNvPr id="18" name="TextBox 17"/>
+          <p:cNvPr id="9" name="TextBox 8"/>
           <p:cNvSpPr txBox="1"/>
           <p:nvPr/>
         </p:nvSpPr>
@@ -29320,7 +28407,7 @@
       </p:sp>
       <p:sp>
         <p:nvSpPr>
-          <p:cNvPr id="19" name="Rounded Rectangle 18"/>
+          <p:cNvPr id="10" name="Rounded Rectangle 9"/>
           <p:cNvSpPr/>
           <p:nvPr/>
         </p:nvSpPr>
@@ -29351,7 +28438,7 @@
       </p:sp>
       <p:sp>
         <p:nvSpPr>
-          <p:cNvPr id="20" name="Rounded Rectangle 19"/>
+          <p:cNvPr id="11" name="Rounded Rectangle 10"/>
           <p:cNvSpPr/>
           <p:nvPr/>
         </p:nvSpPr>
@@ -29380,7 +28467,7 @@
       </p:sp>
       <p:sp>
         <p:nvSpPr>
-          <p:cNvPr id="21" name="TextBox 20"/>
+          <p:cNvPr id="12" name="TextBox 11"/>
           <p:cNvSpPr txBox="1"/>
           <p:nvPr/>
         </p:nvSpPr>
@@ -29417,7 +28504,7 @@
       </p:sp>
       <p:cxnSp>
         <p:nvCxnSpPr>
-          <p:cNvPr id="22" name="Connector 21"/>
+          <p:cNvPr id="13" name="Connector 12"/>
           <p:cNvCxnSpPr/>
           <p:nvPr/>
         </p:nvCxnSpPr>
@@ -29438,7 +28525,7 @@
       </p:cxnSp>
       <p:sp>
         <p:nvSpPr>
-          <p:cNvPr id="23" name="TextBox 22"/>
+          <p:cNvPr id="14" name="TextBox 13"/>
           <p:cNvSpPr txBox="1"/>
           <p:nvPr/>
         </p:nvSpPr>
@@ -29475,7 +28562,7 @@
       </p:sp>
       <p:sp>
         <p:nvSpPr>
-          <p:cNvPr id="24" name="TextBox 23"/>
+          <p:cNvPr id="15" name="TextBox 14"/>
           <p:cNvSpPr txBox="1"/>
           <p:nvPr/>
         </p:nvSpPr>
@@ -29512,7 +28599,7 @@
       </p:sp>
       <p:sp>
         <p:nvSpPr>
-          <p:cNvPr id="25" name="TextBox 24"/>
+          <p:cNvPr id="16" name="TextBox 15"/>
           <p:cNvSpPr txBox="1"/>
           <p:nvPr/>
         </p:nvSpPr>
@@ -29570,7 +28657,7 @@
       </p:sp>
       <p:sp>
         <p:nvSpPr>
-          <p:cNvPr id="26" name="Rounded Rectangle 25"/>
+          <p:cNvPr id="17" name="Rounded Rectangle 16"/>
           <p:cNvSpPr/>
           <p:nvPr/>
         </p:nvSpPr>
@@ -29613,7 +28700,7 @@
       </p:sp>
       <p:sp>
         <p:nvSpPr>
-          <p:cNvPr id="27" name="Rounded Rectangle 26"/>
+          <p:cNvPr id="18" name="Rounded Rectangle 17"/>
           <p:cNvSpPr/>
           <p:nvPr/>
         </p:nvSpPr>
@@ -29656,7 +28743,7 @@
       </p:sp>
       <p:cxnSp>
         <p:nvCxnSpPr>
-          <p:cNvPr id="28" name="Connector 27"/>
+          <p:cNvPr id="19" name="Connector 18"/>
           <p:cNvCxnSpPr/>
           <p:nvPr/>
         </p:nvCxnSpPr>
@@ -29677,7 +28764,7 @@
       </p:cxnSp>
       <p:sp>
         <p:nvSpPr>
-          <p:cNvPr id="29" name="TextBox 28"/>
+          <p:cNvPr id="20" name="TextBox 19"/>
           <p:cNvSpPr txBox="1"/>
           <p:nvPr/>
         </p:nvSpPr>
@@ -29714,7 +28801,7 @@
       </p:sp>
       <p:sp>
         <p:nvSpPr>
-          <p:cNvPr id="30" name="TextBox 29"/>
+          <p:cNvPr id="21" name="TextBox 20"/>
           <p:cNvSpPr txBox="1"/>
           <p:nvPr/>
         </p:nvSpPr>
@@ -29751,7 +28838,7 @@
       </p:sp>
       <p:sp>
         <p:nvSpPr>
-          <p:cNvPr id="31" name="TextBox 30"/>
+          <p:cNvPr id="22" name="TextBox 21"/>
           <p:cNvSpPr txBox="1"/>
           <p:nvPr/>
         </p:nvSpPr>
@@ -29809,7 +28896,7 @@
       </p:sp>
       <p:sp>
         <p:nvSpPr>
-          <p:cNvPr id="32" name="Rounded Rectangle 31"/>
+          <p:cNvPr id="23" name="Rounded Rectangle 22"/>
           <p:cNvSpPr/>
           <p:nvPr/>
         </p:nvSpPr>
@@ -29852,7 +28939,7 @@
       </p:sp>
       <p:sp>
         <p:nvSpPr>
-          <p:cNvPr id="33" name="TextBox 32"/>
+          <p:cNvPr id="24" name="TextBox 23"/>
           <p:cNvSpPr txBox="1"/>
           <p:nvPr/>
         </p:nvSpPr>
@@ -29889,7 +28976,7 @@
       </p:sp>
       <p:sp>
         <p:nvSpPr>
-          <p:cNvPr id="34" name="Rounded Rectangle 33"/>
+          <p:cNvPr id="25" name="Rounded Rectangle 24"/>
           <p:cNvSpPr/>
           <p:nvPr/>
         </p:nvSpPr>
@@ -29927,7 +29014,7 @@
       </p:sp>
       <p:sp>
         <p:nvSpPr>
-          <p:cNvPr id="35" name="TextBox 34"/>
+          <p:cNvPr id="26" name="TextBox 25"/>
           <p:cNvSpPr txBox="1"/>
           <p:nvPr/>
         </p:nvSpPr>
@@ -29964,7 +29051,7 @@
       </p:sp>
       <p:cxnSp>
         <p:nvCxnSpPr>
-          <p:cNvPr id="36" name="Connector 35"/>
+          <p:cNvPr id="27" name="Connector 26"/>
           <p:cNvCxnSpPr/>
           <p:nvPr/>
         </p:nvCxnSpPr>
@@ -29985,7 +29072,7 @@
       </p:cxnSp>
       <p:sp>
         <p:nvSpPr>
-          <p:cNvPr id="37" name="TextBox 36"/>
+          <p:cNvPr id="28" name="TextBox 27"/>
           <p:cNvSpPr txBox="1"/>
           <p:nvPr/>
         </p:nvSpPr>
@@ -30032,7 +29119,7 @@
       </p:sp>
       <p:sp>
         <p:nvSpPr>
-          <p:cNvPr id="38" name="TextBox 37"/>
+          <p:cNvPr id="29" name="TextBox 28"/>
           <p:cNvSpPr txBox="1"/>
           <p:nvPr/>
         </p:nvSpPr>
@@ -30073,7 +29160,7 @@
       </p:sp>
       <p:sp>
         <p:nvSpPr>
-          <p:cNvPr id="39" name="Rounded Rectangle 38"/>
+          <p:cNvPr id="30" name="Rounded Rectangle 29"/>
           <p:cNvSpPr/>
           <p:nvPr/>
         </p:nvSpPr>
@@ -30111,7 +29198,7 @@
       </p:sp>
       <p:sp>
         <p:nvSpPr>
-          <p:cNvPr id="40" name="TextBox 39"/>
+          <p:cNvPr id="31" name="TextBox 30"/>
           <p:cNvSpPr txBox="1"/>
           <p:nvPr/>
         </p:nvSpPr>
@@ -30148,7 +29235,7 @@
       </p:sp>
       <p:cxnSp>
         <p:nvCxnSpPr>
-          <p:cNvPr id="41" name="Connector 40"/>
+          <p:cNvPr id="32" name="Connector 31"/>
           <p:cNvCxnSpPr/>
           <p:nvPr/>
         </p:nvCxnSpPr>
@@ -30169,7 +29256,7 @@
       </p:cxnSp>
       <p:sp>
         <p:nvSpPr>
-          <p:cNvPr id="42" name="TextBox 41"/>
+          <p:cNvPr id="33" name="TextBox 32"/>
           <p:cNvSpPr txBox="1"/>
           <p:nvPr/>
         </p:nvSpPr>
@@ -30216,7 +29303,7 @@
       </p:sp>
       <p:sp>
         <p:nvSpPr>
-          <p:cNvPr id="43" name="TextBox 42"/>
+          <p:cNvPr id="34" name="TextBox 33"/>
           <p:cNvSpPr txBox="1"/>
           <p:nvPr/>
         </p:nvSpPr>
@@ -30257,7 +29344,7 @@
       </p:sp>
       <p:sp>
         <p:nvSpPr>
-          <p:cNvPr id="44" name="Rounded Rectangle 43"/>
+          <p:cNvPr id="35" name="Rounded Rectangle 34"/>
           <p:cNvSpPr/>
           <p:nvPr/>
         </p:nvSpPr>
@@ -30295,7 +29382,7 @@
       </p:sp>
       <p:sp>
         <p:nvSpPr>
-          <p:cNvPr id="45" name="TextBox 44"/>
+          <p:cNvPr id="36" name="TextBox 35"/>
           <p:cNvSpPr txBox="1"/>
           <p:nvPr/>
         </p:nvSpPr>
@@ -30332,7 +29419,7 @@
       </p:sp>
       <p:cxnSp>
         <p:nvCxnSpPr>
-          <p:cNvPr id="46" name="Connector 45"/>
+          <p:cNvPr id="37" name="Connector 36"/>
           <p:cNvCxnSpPr/>
           <p:nvPr/>
         </p:nvCxnSpPr>
@@ -30353,7 +29440,7 @@
       </p:cxnSp>
       <p:sp>
         <p:nvSpPr>
-          <p:cNvPr id="47" name="TextBox 46"/>
+          <p:cNvPr id="38" name="TextBox 37"/>
           <p:cNvSpPr txBox="1"/>
           <p:nvPr/>
         </p:nvSpPr>
@@ -30400,7 +29487,7 @@
       </p:sp>
       <p:sp>
         <p:nvSpPr>
-          <p:cNvPr id="48" name="TextBox 47"/>
+          <p:cNvPr id="39" name="TextBox 38"/>
           <p:cNvSpPr txBox="1"/>
           <p:nvPr/>
         </p:nvSpPr>
@@ -30441,7 +29528,7 @@
       </p:sp>
       <p:sp>
         <p:nvSpPr>
-          <p:cNvPr id="49" name="TextBox 48"/>
+          <p:cNvPr id="40" name="TextBox 39"/>
           <p:cNvSpPr txBox="1"/>
           <p:nvPr/>
         </p:nvSpPr>
@@ -30536,16 +29623,23 @@
         </p:nvSpPr>
         <p:spPr>
           <a:xfrm>
-            <a:off x="227420" y="6498731"/>
-            <a:ext cx="467734" cy="206790"/>
-          </a:xfrm>
-        </p:spPr>
-        <p:txBody>
-          <a:bodyPr/>
-          <a:lstStyle/>
-          <a:p>
+            <a:off x="411480" y="155448"/>
+            <a:ext cx="822960" cy="548640"/>
+          </a:xfrm>
+        </p:spPr>
+        <p:txBody>
+          <a:bodyPr anchor="ctr" lIns="0"/>
+          <a:lstStyle/>
+          <a:p>
+            <a:pPr algn="l"/>
             <a:fld id="{679EF615-E246-4FA6-9E75-123AAEB83405}" type="slidenum">
-              <a:rPr lang="en-PH" smtClean="0"/>
+              <a:rPr lang="en-US" smtClean="0" sz="1200" b="1">
+                <a:solidFill>
+                  <a:srgbClr val="2A206A"/>
+                </a:solidFill>
+                <a:latin typeface="DiodrumArabic-Semibold"/>
+                <a:cs typeface="DiodrumArabic-Semibold"/>
+              </a:rPr>
               <a:pPr/>
               <a:t>5</a:t>
             </a:fld>
@@ -30555,52 +29649,14 @@
       </p:sp>
       <p:sp>
         <p:nvSpPr>
-          <p:cNvPr id="11" name="SecloreFooter">
-            <a:extLst>
-              <a:ext uri="{FF2B5EF4-FFF2-40B4-BE49-F238E27FC236}">
-                <a16:creationId xmlns:a16="http://schemas.microsoft.com/office/drawing/2014/main" id="{FE53BD42-AF09-4407-AF8B-D0497E98ECF6}"/>
-              </a:ext>
-            </a:extLst>
-          </p:cNvPr>
-          <p:cNvSpPr>
-            <a:spLocks noGrp="1"/>
-          </p:cNvSpPr>
-          <p:nvPr>
-            <p:ph type="ftr" sz="quarter" idx="13"/>
-          </p:nvPr>
-        </p:nvSpPr>
-        <p:spPr>
-          <a:xfrm>
-            <a:off x="0" y="6356352"/>
-            <a:ext cx="12192000" cy="365125"/>
-          </a:xfrm>
-        </p:spPr>
-        <p:txBody>
-          <a:bodyPr/>
-          <a:lstStyle/>
-          <a:p>
-            <a:r>
-              <a:rPr lang="en-US"/>
-              <a:t>Restricted - </a:t>
-            </a:r>
-            <a:r>
-              <a:rPr lang="ar-SA"/>
-              <a:t>مقيد</a:t>
-            </a:r>
-            <a:endParaRPr lang="en-US"/>
-          </a:p>
-        </p:txBody>
-      </p:sp>
-      <p:sp>
-        <p:nvSpPr>
-          <p:cNvPr id="12" name="TextBox 11"/>
+          <p:cNvPr id="3" name="TextBox 2"/>
           <p:cNvSpPr txBox="1"/>
           <p:nvPr/>
         </p:nvSpPr>
         <p:spPr>
           <a:xfrm>
-            <a:off x="411480" y="155448"/>
-            <a:ext cx="11384280" cy="548640"/>
+            <a:off x="1234440" y="155448"/>
+            <a:ext cx="10561320" cy="548640"/>
           </a:xfrm>
           <a:prstGeom prst="rect">
             <a:avLst/>
@@ -30640,7 +29696,7 @@
       </p:sp>
       <p:cxnSp>
         <p:nvCxnSpPr>
-          <p:cNvPr id="13" name="Connector 12"/>
+          <p:cNvPr id="4" name="Connector 3"/>
           <p:cNvCxnSpPr/>
           <p:nvPr/>
         </p:nvCxnSpPr>
@@ -30669,7 +29725,7 @@
       </p:cxnSp>
       <p:sp>
         <p:nvSpPr>
-          <p:cNvPr id="14" name="TextBox 13"/>
+          <p:cNvPr id="5" name="TextBox 4"/>
           <p:cNvSpPr txBox="1"/>
           <p:nvPr/>
         </p:nvSpPr>
@@ -30706,7 +29762,7 @@
       </p:sp>
       <p:sp>
         <p:nvSpPr>
-          <p:cNvPr id="15" name="Rounded Rectangle 14"/>
+          <p:cNvPr id="6" name="Rounded Rectangle 5"/>
           <p:cNvSpPr/>
           <p:nvPr/>
         </p:nvSpPr>
@@ -30750,7 +29806,7 @@
       </p:sp>
       <p:sp>
         <p:nvSpPr>
-          <p:cNvPr id="16" name="TextBox 15"/>
+          <p:cNvPr id="7" name="TextBox 6"/>
           <p:cNvSpPr txBox="1"/>
           <p:nvPr/>
         </p:nvSpPr>
@@ -30787,7 +29843,7 @@
       </p:sp>
       <p:sp>
         <p:nvSpPr>
-          <p:cNvPr id="17" name="TextBox 16"/>
+          <p:cNvPr id="8" name="TextBox 7"/>
           <p:cNvSpPr txBox="1"/>
           <p:nvPr/>
         </p:nvSpPr>
@@ -30845,7 +29901,7 @@
       </p:sp>
       <p:cxnSp>
         <p:nvCxnSpPr>
-          <p:cNvPr id="18" name="Connector 17"/>
+          <p:cNvPr id="9" name="Connector 8"/>
           <p:cNvCxnSpPr/>
           <p:nvPr/>
         </p:nvCxnSpPr>
@@ -30866,7 +29922,7 @@
       </p:cxnSp>
       <p:sp>
         <p:nvSpPr>
-          <p:cNvPr id="19" name="Rounded Rectangle 18"/>
+          <p:cNvPr id="10" name="Rounded Rectangle 9"/>
           <p:cNvSpPr/>
           <p:nvPr/>
         </p:nvSpPr>
@@ -30909,7 +29965,7 @@
       </p:sp>
       <p:sp>
         <p:nvSpPr>
-          <p:cNvPr id="20" name="Rounded Rectangle 19"/>
+          <p:cNvPr id="11" name="Rounded Rectangle 10"/>
           <p:cNvSpPr/>
           <p:nvPr/>
         </p:nvSpPr>
@@ -30952,7 +30008,7 @@
       </p:sp>
       <p:sp>
         <p:nvSpPr>
-          <p:cNvPr id="21" name="Rounded Rectangle 20"/>
+          <p:cNvPr id="12" name="Rounded Rectangle 11"/>
           <p:cNvSpPr/>
           <p:nvPr/>
         </p:nvSpPr>
@@ -30995,7 +30051,7 @@
       </p:sp>
       <p:sp>
         <p:nvSpPr>
-          <p:cNvPr id="22" name="Rounded Rectangle 21"/>
+          <p:cNvPr id="13" name="Rounded Rectangle 12"/>
           <p:cNvSpPr/>
           <p:nvPr/>
         </p:nvSpPr>
@@ -31033,7 +30089,7 @@
       </p:sp>
       <p:sp>
         <p:nvSpPr>
-          <p:cNvPr id="23" name="TextBox 22"/>
+          <p:cNvPr id="14" name="TextBox 13"/>
           <p:cNvSpPr txBox="1"/>
           <p:nvPr/>
         </p:nvSpPr>
@@ -31070,7 +30126,7 @@
       </p:sp>
       <p:cxnSp>
         <p:nvCxnSpPr>
-          <p:cNvPr id="24" name="Connector 23"/>
+          <p:cNvPr id="15" name="Connector 14"/>
           <p:cNvCxnSpPr/>
           <p:nvPr/>
         </p:nvCxnSpPr>
@@ -31091,7 +30147,7 @@
       </p:cxnSp>
       <p:sp>
         <p:nvSpPr>
-          <p:cNvPr id="25" name="TextBox 24"/>
+          <p:cNvPr id="16" name="TextBox 15"/>
           <p:cNvSpPr txBox="1"/>
           <p:nvPr/>
         </p:nvSpPr>
@@ -31138,7 +30194,7 @@
       </p:sp>
       <p:sp>
         <p:nvSpPr>
-          <p:cNvPr id="26" name="TextBox 25"/>
+          <p:cNvPr id="17" name="TextBox 16"/>
           <p:cNvSpPr txBox="1"/>
           <p:nvPr/>
         </p:nvSpPr>
@@ -31175,7 +30231,7 @@
       </p:sp>
       <p:sp>
         <p:nvSpPr>
-          <p:cNvPr id="27" name="Rounded Rectangle 26"/>
+          <p:cNvPr id="18" name="Rounded Rectangle 17"/>
           <p:cNvSpPr/>
           <p:nvPr/>
         </p:nvSpPr>
@@ -31218,7 +30274,7 @@
       </p:sp>
       <p:sp>
         <p:nvSpPr>
-          <p:cNvPr id="28" name="Rounded Rectangle 27"/>
+          <p:cNvPr id="19" name="Rounded Rectangle 18"/>
           <p:cNvSpPr/>
           <p:nvPr/>
         </p:nvSpPr>
@@ -31261,7 +30317,7 @@
       </p:sp>
       <p:sp>
         <p:nvSpPr>
-          <p:cNvPr id="29" name="Rounded Rectangle 28"/>
+          <p:cNvPr id="20" name="Rounded Rectangle 19"/>
           <p:cNvSpPr/>
           <p:nvPr/>
         </p:nvSpPr>
@@ -31299,7 +30355,7 @@
       </p:sp>
       <p:sp>
         <p:nvSpPr>
-          <p:cNvPr id="30" name="TextBox 29"/>
+          <p:cNvPr id="21" name="TextBox 20"/>
           <p:cNvSpPr txBox="1"/>
           <p:nvPr/>
         </p:nvSpPr>
@@ -31336,7 +30392,7 @@
       </p:sp>
       <p:cxnSp>
         <p:nvCxnSpPr>
-          <p:cNvPr id="31" name="Connector 30"/>
+          <p:cNvPr id="22" name="Connector 21"/>
           <p:cNvCxnSpPr/>
           <p:nvPr/>
         </p:nvCxnSpPr>
@@ -31357,7 +30413,7 @@
       </p:cxnSp>
       <p:sp>
         <p:nvSpPr>
-          <p:cNvPr id="32" name="TextBox 31"/>
+          <p:cNvPr id="23" name="TextBox 22"/>
           <p:cNvSpPr txBox="1"/>
           <p:nvPr/>
         </p:nvSpPr>
@@ -31404,7 +30460,7 @@
       </p:sp>
       <p:sp>
         <p:nvSpPr>
-          <p:cNvPr id="33" name="TextBox 32"/>
+          <p:cNvPr id="24" name="TextBox 23"/>
           <p:cNvSpPr txBox="1"/>
           <p:nvPr/>
         </p:nvSpPr>
@@ -31441,7 +30497,7 @@
       </p:sp>
       <p:sp>
         <p:nvSpPr>
-          <p:cNvPr id="34" name="Rounded Rectangle 33"/>
+          <p:cNvPr id="25" name="Rounded Rectangle 24"/>
           <p:cNvSpPr/>
           <p:nvPr/>
         </p:nvSpPr>
@@ -31484,7 +30540,7 @@
       </p:sp>
       <p:sp>
         <p:nvSpPr>
-          <p:cNvPr id="35" name="Rounded Rectangle 34"/>
+          <p:cNvPr id="26" name="Rounded Rectangle 25"/>
           <p:cNvSpPr/>
           <p:nvPr/>
         </p:nvSpPr>
@@ -31527,7 +30583,7 @@
       </p:sp>
       <p:sp>
         <p:nvSpPr>
-          <p:cNvPr id="36" name="TextBox 35"/>
+          <p:cNvPr id="27" name="TextBox 26"/>
           <p:cNvSpPr txBox="1"/>
           <p:nvPr/>
         </p:nvSpPr>
@@ -31564,7 +30620,7 @@
       </p:sp>
       <p:sp>
         <p:nvSpPr>
-          <p:cNvPr id="37" name="Rounded Rectangle 36"/>
+          <p:cNvPr id="28" name="Rounded Rectangle 27"/>
           <p:cNvSpPr/>
           <p:nvPr/>
         </p:nvSpPr>
@@ -31602,7 +30658,7 @@
       </p:sp>
       <p:sp>
         <p:nvSpPr>
-          <p:cNvPr id="38" name="TextBox 37"/>
+          <p:cNvPr id="29" name="TextBox 28"/>
           <p:cNvSpPr txBox="1"/>
           <p:nvPr/>
         </p:nvSpPr>
@@ -31639,7 +30695,7 @@
       </p:sp>
       <p:cxnSp>
         <p:nvCxnSpPr>
-          <p:cNvPr id="39" name="Connector 38"/>
+          <p:cNvPr id="30" name="Connector 29"/>
           <p:cNvCxnSpPr/>
           <p:nvPr/>
         </p:nvCxnSpPr>
@@ -31660,7 +30716,7 @@
       </p:cxnSp>
       <p:sp>
         <p:nvSpPr>
-          <p:cNvPr id="40" name="TextBox 39"/>
+          <p:cNvPr id="31" name="TextBox 30"/>
           <p:cNvSpPr txBox="1"/>
           <p:nvPr/>
         </p:nvSpPr>
@@ -31707,7 +30763,7 @@
       </p:sp>
       <p:sp>
         <p:nvSpPr>
-          <p:cNvPr id="41" name="TextBox 40"/>
+          <p:cNvPr id="32" name="TextBox 31"/>
           <p:cNvSpPr txBox="1"/>
           <p:nvPr/>
         </p:nvSpPr>
@@ -31744,7 +30800,7 @@
       </p:sp>
       <p:sp>
         <p:nvSpPr>
-          <p:cNvPr id="42" name="Rounded Rectangle 41"/>
+          <p:cNvPr id="33" name="Rounded Rectangle 32"/>
           <p:cNvSpPr/>
           <p:nvPr/>
         </p:nvSpPr>
@@ -31787,7 +30843,7 @@
       </p:sp>
       <p:sp>
         <p:nvSpPr>
-          <p:cNvPr id="43" name="Rounded Rectangle 42"/>
+          <p:cNvPr id="34" name="Rounded Rectangle 33"/>
           <p:cNvSpPr/>
           <p:nvPr/>
         </p:nvSpPr>
@@ -31830,7 +30886,7 @@
       </p:sp>
       <p:sp>
         <p:nvSpPr>
-          <p:cNvPr id="44" name="TextBox 43"/>
+          <p:cNvPr id="35" name="TextBox 34"/>
           <p:cNvSpPr txBox="1"/>
           <p:nvPr/>
         </p:nvSpPr>
@@ -31867,7 +30923,7 @@
       </p:sp>
       <p:sp>
         <p:nvSpPr>
-          <p:cNvPr id="45" name="Rounded Rectangle 44"/>
+          <p:cNvPr id="36" name="Rounded Rectangle 35"/>
           <p:cNvSpPr/>
           <p:nvPr/>
         </p:nvSpPr>
@@ -31905,7 +30961,7 @@
       </p:sp>
       <p:sp>
         <p:nvSpPr>
-          <p:cNvPr id="46" name="TextBox 45"/>
+          <p:cNvPr id="37" name="TextBox 36"/>
           <p:cNvSpPr txBox="1"/>
           <p:nvPr/>
         </p:nvSpPr>
@@ -31942,7 +30998,7 @@
       </p:sp>
       <p:graphicFrame>
         <p:nvGraphicFramePr>
-          <p:cNvPr id="47" name="Chart 46"/>
+          <p:cNvPr id="38" name="Chart 37"/>
           <p:cNvGraphicFramePr>
             <a:graphicFrameLocks noGrp="1"/>
           </p:cNvGraphicFramePr>
@@ -31960,7 +31016,7 @@
       </p:graphicFrame>
       <p:sp>
         <p:nvSpPr>
-          <p:cNvPr id="48" name="TextBox 47"/>
+          <p:cNvPr id="39" name="TextBox 38"/>
           <p:cNvSpPr txBox="1"/>
           <p:nvPr/>
         </p:nvSpPr>
@@ -32380,15 +31436,15 @@
         </p:nvSpPr>
         <p:spPr>
           <a:xfrm>
-            <a:off x="227420" y="6498731"/>
-            <a:ext cx="467734" cy="206790"/>
-          </a:xfrm>
-        </p:spPr>
-        <p:txBody>
-          <a:bodyPr/>
-          <a:lstStyle/>
-          <a:p>
-            <a:pPr marL="0" marR="0" lvl="0" indent="0" algn="ctr" defTabSz="914400" rtl="0" eaLnBrk="1" fontAlgn="auto" latinLnBrk="0" hangingPunct="1">
+            <a:off x="411480" y="402336"/>
+            <a:ext cx="822960" cy="640080"/>
+          </a:xfrm>
+        </p:spPr>
+        <p:txBody>
+          <a:bodyPr anchor="ctr" lIns="0"/>
+          <a:lstStyle/>
+          <a:p>
+            <a:pPr marL="0" marR="0" lvl="0" indent="0" algn="l" defTabSz="914400" rtl="0" eaLnBrk="1" fontAlgn="auto" latinLnBrk="0" hangingPunct="1">
               <a:lnSpc>
                 <a:spcPct val="100000"/>
               </a:lnSpc>
@@ -32408,21 +31464,12 @@
               <a:defRPr/>
             </a:pPr>
             <a:fld id="{679EF615-E246-4FA6-9E75-123AAEB83405}" type="slidenum">
-              <a:rPr kumimoji="0" lang="en-PH" sz="900" b="0" i="0" u="none" strike="noStrike" kern="0" cap="none" spc="0" normalizeH="0" baseline="0" noProof="0" smtClean="0">
-                <a:ln>
-                  <a:noFill/>
-                </a:ln>
+              <a:rPr kumimoji="0" lang="en-US" sz="1200" b="1" i="0" u="none" strike="noStrike" kern="0" cap="none" spc="0" normalizeH="0" baseline="0" noProof="0" smtClean="0">
                 <a:solidFill>
-                  <a:prstClr val="white">
-                    <a:lumMod val="65000"/>
-                  </a:prstClr>
+                  <a:srgbClr val="2A206A"/>
                 </a:solidFill>
-                <a:effectLst/>
-                <a:uLnTx/>
-                <a:uFillTx/>
                 <a:latin typeface="DiodrumArabic-Semibold"/>
-                <a:cs typeface="Arial"/>
-                <a:sym typeface="Arial"/>
+                <a:cs typeface="DiodrumArabic-Semibold"/>
               </a:rPr>
               <a:pPr marL="0" marR="0" lvl="0" indent="0" algn="ctr" defTabSz="914400" rtl="0" eaLnBrk="1" fontAlgn="auto" latinLnBrk="0" hangingPunct="1">
                 <a:lnSpc>
@@ -32458,102 +31505,6 @@
               <a:uLnTx/>
               <a:uFillTx/>
               <a:latin typeface="DiodrumArabic-Semibold"/>
-              <a:cs typeface="Arial"/>
-              <a:sym typeface="Arial"/>
-            </a:endParaRPr>
-          </a:p>
-        </p:txBody>
-      </p:sp>
-      <p:sp>
-        <p:nvSpPr>
-          <p:cNvPr id="12" name="SecloreFooter">
-            <a:extLst>
-              <a:ext uri="{FF2B5EF4-FFF2-40B4-BE49-F238E27FC236}">
-                <a16:creationId xmlns:a16="http://schemas.microsoft.com/office/drawing/2014/main" id="{3256E98C-32DF-42DD-9307-7E10BBFC8907}"/>
-              </a:ext>
-            </a:extLst>
-          </p:cNvPr>
-          <p:cNvSpPr>
-            <a:spLocks noGrp="1"/>
-          </p:cNvSpPr>
-          <p:nvPr>
-            <p:ph type="ftr" sz="quarter" idx="13"/>
-          </p:nvPr>
-        </p:nvSpPr>
-        <p:spPr>
-          <a:xfrm>
-            <a:off x="0" y="6356352"/>
-            <a:ext cx="12192000" cy="365125"/>
-          </a:xfrm>
-        </p:spPr>
-        <p:txBody>
-          <a:bodyPr/>
-          <a:lstStyle/>
-          <a:p>
-            <a:pPr marL="0" marR="0" lvl="0" indent="0" algn="ctr" defTabSz="914400" rtl="0" eaLnBrk="1" fontAlgn="auto" latinLnBrk="0" hangingPunct="1">
-              <a:lnSpc>
-                <a:spcPct val="100000"/>
-              </a:lnSpc>
-              <a:spcBef>
-                <a:spcPts val="0"/>
-              </a:spcBef>
-              <a:spcAft>
-                <a:spcPts val="0"/>
-              </a:spcAft>
-              <a:buClr>
-                <a:srgbClr val="000000"/>
-              </a:buClr>
-              <a:buSzTx/>
-              <a:buFont typeface="Arial"/>
-              <a:buNone/>
-              <a:tabLst/>
-              <a:defRPr/>
-            </a:pPr>
-            <a:r>
-              <a:rPr kumimoji="0" lang="en-US" sz="1200" b="0" i="0" u="none" strike="noStrike" kern="0" cap="none" spc="0" normalizeH="0" baseline="0" noProof="0">
-                <a:ln>
-                  <a:noFill/>
-                </a:ln>
-                <a:solidFill>
-                  <a:srgbClr val="F0C231"/>
-                </a:solidFill>
-                <a:effectLst/>
-                <a:uLnTx/>
-                <a:uFillTx/>
-                <a:latin typeface="Arial"/>
-                <a:cs typeface="Arial"/>
-                <a:sym typeface="Arial"/>
-              </a:rPr>
-              <a:t>Restricted - </a:t>
-            </a:r>
-            <a:r>
-              <a:rPr kumimoji="0" lang="ar-SA" sz="1200" b="0" i="0" u="none" strike="noStrike" kern="0" cap="none" spc="0" normalizeH="0" baseline="0" noProof="0">
-                <a:ln>
-                  <a:noFill/>
-                </a:ln>
-                <a:solidFill>
-                  <a:srgbClr val="F0C231"/>
-                </a:solidFill>
-                <a:effectLst/>
-                <a:uLnTx/>
-                <a:uFillTx/>
-                <a:latin typeface="Arial"/>
-                <a:cs typeface="Arial"/>
-                <a:sym typeface="Arial"/>
-              </a:rPr>
-              <a:t>مقيد</a:t>
-            </a:r>
-            <a:endParaRPr kumimoji="0" lang="en-US" sz="1200" b="0" i="0" u="none" strike="noStrike" kern="0" cap="none" spc="0" normalizeH="0" baseline="0" noProof="0">
-              <a:ln>
-                <a:noFill/>
-              </a:ln>
-              <a:solidFill>
-                <a:srgbClr val="F0C231"/>
-              </a:solidFill>
-              <a:effectLst/>
-              <a:uLnTx/>
-              <a:uFillTx/>
-              <a:latin typeface="Arial"/>
               <a:cs typeface="Arial"/>
               <a:sym typeface="Arial"/>
             </a:endParaRPr>
@@ -32657,15 +31608,15 @@
         </p:nvSpPr>
         <p:spPr>
           <a:xfrm>
-            <a:off x="227420" y="6498731"/>
-            <a:ext cx="467734" cy="206790"/>
-          </a:xfrm>
-        </p:spPr>
-        <p:txBody>
-          <a:bodyPr/>
-          <a:lstStyle/>
-          <a:p>
-            <a:pPr marL="0" marR="0" lvl="0" indent="0" algn="ctr" defTabSz="914400" rtl="0" eaLnBrk="1" fontAlgn="auto" latinLnBrk="0" hangingPunct="1">
+            <a:off x="411480" y="155448"/>
+            <a:ext cx="822960" cy="548640"/>
+          </a:xfrm>
+        </p:spPr>
+        <p:txBody>
+          <a:bodyPr anchor="ctr" lIns="0"/>
+          <a:lstStyle/>
+          <a:p>
+            <a:pPr marL="0" marR="0" lvl="0" indent="0" algn="l" defTabSz="914400" rtl="0" eaLnBrk="1" fontAlgn="auto" latinLnBrk="0" hangingPunct="1">
               <a:lnSpc>
                 <a:spcPct val="100000"/>
               </a:lnSpc>
@@ -32685,21 +31636,12 @@
               <a:defRPr/>
             </a:pPr>
             <a:fld id="{679EF615-E246-4FA6-9E75-123AAEB83405}" type="slidenum">
-              <a:rPr kumimoji="0" lang="en-PH" sz="900" b="0" i="0" u="none" strike="noStrike" kern="0" cap="none" spc="0" normalizeH="0" baseline="0" noProof="0" smtClean="0">
-                <a:ln>
-                  <a:noFill/>
-                </a:ln>
+              <a:rPr kumimoji="0" lang="en-US" sz="1200" b="1" i="0" u="none" strike="noStrike" kern="0" cap="none" spc="0" normalizeH="0" baseline="0" noProof="0" smtClean="0">
                 <a:solidFill>
-                  <a:prstClr val="white">
-                    <a:lumMod val="65000"/>
-                  </a:prstClr>
+                  <a:srgbClr val="2A206A"/>
                 </a:solidFill>
-                <a:effectLst/>
-                <a:uLnTx/>
-                <a:uFillTx/>
                 <a:latin typeface="DiodrumArabic-Semibold"/>
-                <a:cs typeface="Arial"/>
-                <a:sym typeface="Arial"/>
+                <a:cs typeface="DiodrumArabic-Semibold"/>
               </a:rPr>
               <a:pPr marL="0" marR="0" lvl="0" indent="0" algn="ctr" defTabSz="914400" rtl="0" eaLnBrk="1" fontAlgn="auto" latinLnBrk="0" hangingPunct="1">
                 <a:lnSpc>
@@ -32743,52 +31685,14 @@
       </p:sp>
       <p:sp>
         <p:nvSpPr>
-          <p:cNvPr id="4" name="SecloreFooter">
-            <a:extLst>
-              <a:ext uri="{FF2B5EF4-FFF2-40B4-BE49-F238E27FC236}">
-                <a16:creationId xmlns:a16="http://schemas.microsoft.com/office/drawing/2014/main" id="{CE9AD31D-2698-4E61-B15D-8DB3C6F01D89}"/>
-              </a:ext>
-            </a:extLst>
-          </p:cNvPr>
-          <p:cNvSpPr>
-            <a:spLocks noGrp="1"/>
-          </p:cNvSpPr>
-          <p:nvPr>
-            <p:ph type="ftr" sz="quarter" idx="13"/>
-          </p:nvPr>
-        </p:nvSpPr>
-        <p:spPr>
-          <a:xfrm>
-            <a:off x="0" y="6356352"/>
-            <a:ext cx="12192000" cy="365125"/>
-          </a:xfrm>
-        </p:spPr>
-        <p:txBody>
-          <a:bodyPr/>
-          <a:lstStyle/>
-          <a:p>
-            <a:r>
-              <a:rPr lang="en-US"/>
-              <a:t>Restricted - </a:t>
-            </a:r>
-            <a:r>
-              <a:rPr lang="ar-SA"/>
-              <a:t>مقيد</a:t>
-            </a:r>
-            <a:endParaRPr lang="en-US"/>
-          </a:p>
-        </p:txBody>
-      </p:sp>
-      <p:sp>
-        <p:nvSpPr>
-          <p:cNvPr id="5" name="TextBox 4"/>
+          <p:cNvPr id="3" name="TextBox 2"/>
           <p:cNvSpPr txBox="1"/>
           <p:nvPr/>
         </p:nvSpPr>
         <p:spPr>
           <a:xfrm>
-            <a:off x="411480" y="155448"/>
-            <a:ext cx="11384280" cy="548640"/>
+            <a:off x="1234440" y="155448"/>
+            <a:ext cx="10561320" cy="548640"/>
           </a:xfrm>
           <a:prstGeom prst="rect">
             <a:avLst/>
@@ -32828,7 +31732,7 @@
       </p:sp>
       <p:cxnSp>
         <p:nvCxnSpPr>
-          <p:cNvPr id="6" name="Connector 5"/>
+          <p:cNvPr id="4" name="Connector 3"/>
           <p:cNvCxnSpPr/>
           <p:nvPr/>
         </p:nvCxnSpPr>
@@ -32857,7 +31761,7 @@
       </p:cxnSp>
       <p:sp>
         <p:nvSpPr>
-          <p:cNvPr id="7" name="TextBox 6"/>
+          <p:cNvPr id="5" name="TextBox 4"/>
           <p:cNvSpPr txBox="1"/>
           <p:nvPr/>
         </p:nvSpPr>
@@ -32894,7 +31798,7 @@
       </p:sp>
       <p:sp>
         <p:nvSpPr>
-          <p:cNvPr id="8" name="Rounded Rectangle 7"/>
+          <p:cNvPr id="6" name="Rounded Rectangle 5"/>
           <p:cNvSpPr/>
           <p:nvPr/>
         </p:nvSpPr>
@@ -32938,7 +31842,7 @@
       </p:sp>
       <p:sp>
         <p:nvSpPr>
-          <p:cNvPr id="9" name="TextBox 8"/>
+          <p:cNvPr id="7" name="TextBox 6"/>
           <p:cNvSpPr txBox="1"/>
           <p:nvPr/>
         </p:nvSpPr>
@@ -32975,7 +31879,7 @@
       </p:sp>
       <p:sp>
         <p:nvSpPr>
-          <p:cNvPr id="10" name="TextBox 9"/>
+          <p:cNvPr id="8" name="TextBox 7"/>
           <p:cNvSpPr txBox="1"/>
           <p:nvPr/>
         </p:nvSpPr>
@@ -33033,7 +31937,7 @@
       </p:sp>
       <p:cxnSp>
         <p:nvCxnSpPr>
-          <p:cNvPr id="11" name="Connector 10"/>
+          <p:cNvPr id="9" name="Connector 8"/>
           <p:cNvCxnSpPr/>
           <p:nvPr/>
         </p:nvCxnSpPr>
@@ -33054,7 +31958,7 @@
       </p:cxnSp>
       <p:pic>
         <p:nvPicPr>
-          <p:cNvPr id="12" name="Picture 11" descr="image.png"/>
+          <p:cNvPr id="10" name="Picture 9" descr="image.png"/>
           <p:cNvPicPr>
             <a:picLocks noChangeAspect="1"/>
           </p:cNvPicPr>
@@ -33078,7 +31982,7 @@
       </p:pic>
       <p:sp>
         <p:nvSpPr>
-          <p:cNvPr id="13" name="TextBox 12"/>
+          <p:cNvPr id="11" name="TextBox 10"/>
           <p:cNvSpPr txBox="1"/>
           <p:nvPr/>
         </p:nvSpPr>
@@ -33125,7 +32029,7 @@
       </p:sp>
       <p:pic>
         <p:nvPicPr>
-          <p:cNvPr id="14" name="Picture 13" descr="image.png"/>
+          <p:cNvPr id="12" name="Picture 11" descr="image.png"/>
           <p:cNvPicPr>
             <a:picLocks noChangeAspect="1"/>
           </p:cNvPicPr>
@@ -33149,7 +32053,7 @@
       </p:pic>
       <p:sp>
         <p:nvSpPr>
-          <p:cNvPr id="15" name="TextBox 14"/>
+          <p:cNvPr id="13" name="TextBox 12"/>
           <p:cNvSpPr txBox="1"/>
           <p:nvPr/>
         </p:nvSpPr>
@@ -33196,7 +32100,7 @@
       </p:sp>
       <p:sp>
         <p:nvSpPr>
-          <p:cNvPr id="16" name="Rounded Rectangle 15"/>
+          <p:cNvPr id="14" name="Rounded Rectangle 13"/>
           <p:cNvSpPr/>
           <p:nvPr/>
         </p:nvSpPr>
@@ -33227,7 +32131,7 @@
       </p:sp>
       <p:sp>
         <p:nvSpPr>
-          <p:cNvPr id="17" name="TextBox 16"/>
+          <p:cNvPr id="15" name="TextBox 14"/>
           <p:cNvSpPr txBox="1"/>
           <p:nvPr/>
         </p:nvSpPr>
@@ -33278,7 +32182,7 @@
       </p:sp>
       <p:sp>
         <p:nvSpPr>
-          <p:cNvPr id="18" name="TextBox 17"/>
+          <p:cNvPr id="16" name="TextBox 15"/>
           <p:cNvSpPr txBox="1"/>
           <p:nvPr/>
         </p:nvSpPr>
@@ -33315,7 +32219,7 @@
       </p:sp>
       <p:graphicFrame>
         <p:nvGraphicFramePr>
-          <p:cNvPr id="19" name="Table 18"/>
+          <p:cNvPr id="17" name="Table 16"/>
           <p:cNvGraphicFramePr>
             <a:graphicFrameLocks noGrp="1"/>
           </p:cNvGraphicFramePr>
@@ -34505,7 +33409,7 @@
       </p:graphicFrame>
       <p:pic>
         <p:nvPicPr>
-          <p:cNvPr id="20" name="Picture 19" descr="image.png"/>
+          <p:cNvPr id="18" name="Picture 17" descr="image.png"/>
           <p:cNvPicPr>
             <a:picLocks noChangeAspect="1"/>
           </p:cNvPicPr>
@@ -34529,7 +33433,7 @@
       </p:pic>
       <p:pic>
         <p:nvPicPr>
-          <p:cNvPr id="21" name="Picture 20" descr="image.png"/>
+          <p:cNvPr id="19" name="Picture 18" descr="image.png"/>
           <p:cNvPicPr>
             <a:picLocks noChangeAspect="1"/>
           </p:cNvPicPr>
@@ -34553,7 +33457,7 @@
       </p:pic>
       <p:pic>
         <p:nvPicPr>
-          <p:cNvPr id="22" name="Picture 21" descr="image.png"/>
+          <p:cNvPr id="20" name="Picture 19" descr="image.png"/>
           <p:cNvPicPr>
             <a:picLocks noChangeAspect="1"/>
           </p:cNvPicPr>
@@ -34577,7 +33481,7 @@
       </p:pic>
       <p:sp>
         <p:nvSpPr>
-          <p:cNvPr id="23" name="TextBox 22"/>
+          <p:cNvPr id="21" name="TextBox 20"/>
           <p:cNvSpPr txBox="1"/>
           <p:nvPr/>
         </p:nvSpPr>

</xml_diff>

<commit_message>
Restore DNA footer: page number bottom-left, deck title bottom-right
Per the author's direction, the page number returns to the footer under the
template's green dash (navy, semibold) and the deck title is added bottom-right
beside the DGA watermark, above the curve line. The classification label stays
removed. Skill docs and the Arabic changelog updated to record the decision.

Co-Authored-By: Claude Fable 5.1 <noreply@anthropic.com>
Claude-Session: https://claude.ai/code/session_01DqbpVeRtGUjuL1kQxRaNtp
</commit_message>
<xml_diff>
--- a/docs/presentations/qudratak-progress-report-jun-aug-2026.pptx
+++ b/docs/presentations/qudratak-progress-report-jun-aug-2026.pptx
@@ -11064,6 +11064,49 @@
           </a:p>
         </p:txBody>
       </p:sp>
+      <p:cxnSp>
+        <p:nvCxnSpPr>
+          <p:cNvPr id="13" name="Straight Connector 12">
+            <a:extLst>
+              <a:ext uri="{FF2B5EF4-FFF2-40B4-BE49-F238E27FC236}">
+                <a16:creationId xmlns:a16="http://schemas.microsoft.com/office/drawing/2014/main" id="{C3020FC5-0604-4C0D-B7C1-3E6CDC6B3AE1}"/>
+              </a:ext>
+            </a:extLst>
+          </p:cNvPr>
+          <p:cNvCxnSpPr>
+            <a:cxnSpLocks/>
+          </p:cNvCxnSpPr>
+          <p:nvPr userDrawn="1"/>
+        </p:nvCxnSpPr>
+        <p:spPr>
+          <a:xfrm>
+            <a:off x="382635" y="6380480"/>
+            <a:ext cx="212814" cy="0"/>
+          </a:xfrm>
+          <a:prstGeom prst="line">
+            <a:avLst/>
+          </a:prstGeom>
+          <a:ln w="19050" cap="rnd">
+            <a:solidFill>
+              <a:schemeClr val="accent1"/>
+            </a:solidFill>
+          </a:ln>
+        </p:spPr>
+        <p:style>
+          <a:lnRef idx="1">
+            <a:schemeClr val="accent1"/>
+          </a:lnRef>
+          <a:fillRef idx="0">
+            <a:schemeClr val="accent1"/>
+          </a:fillRef>
+          <a:effectRef idx="0">
+            <a:schemeClr val="accent1"/>
+          </a:effectRef>
+          <a:fontRef idx="minor">
+            <a:schemeClr val="tx1"/>
+          </a:fontRef>
+        </p:style>
+      </p:cxnSp>
       <p:sp>
         <p:nvSpPr>
           <p:cNvPr id="22" name="Slide Number Placeholder 6">
@@ -14258,12 +14301,12 @@
         </p:nvSpPr>
         <p:spPr>
           <a:xfrm>
-            <a:off x="411480" y="402336"/>
-            <a:ext cx="822960" cy="640080"/>
-          </a:xfrm>
-        </p:spPr>
-        <p:txBody>
-          <a:bodyPr anchor="ctr" lIns="0"/>
+            <a:off x="384048" y="6455664"/>
+            <a:ext cx="731520" cy="237744"/>
+          </a:xfrm>
+        </p:spPr>
+        <p:txBody>
+          <a:bodyPr anchor="ctr" lIns="0" tIns="0" bIns="0"/>
           <a:lstStyle/>
           <a:p>
             <a:pPr marL="0" marR="0" lvl="0" indent="0" algn="l" defTabSz="914400" rtl="0" eaLnBrk="1" fontAlgn="auto" latinLnBrk="0" hangingPunct="1">
@@ -14286,7 +14329,7 @@
               <a:defRPr/>
             </a:pPr>
             <a:fld id="{679EF615-E246-4FA6-9E75-123AAEB83405}" type="slidenum">
-              <a:rPr kumimoji="0" lang="en-US" sz="1200" b="1" i="0" u="none" strike="noStrike" kern="0" cap="none" spc="0" normalizeH="0" baseline="0" noProof="0" smtClean="0">
+              <a:rPr kumimoji="0" lang="en-US" sz="1050" b="1" i="0" u="none" strike="noStrike" kern="0" cap="none" spc="0" normalizeH="0" baseline="0" noProof="0" smtClean="0">
                 <a:solidFill>
                   <a:srgbClr val="2A206A"/>
                 </a:solidFill>
@@ -14336,6 +14379,43 @@
       <p:sp>
         <p:nvSpPr>
           <p:cNvPr id="81" name="TextBox 80"/>
+          <p:cNvSpPr txBox="1"/>
+          <p:nvPr/>
+        </p:nvSpPr>
+        <p:spPr>
+          <a:xfrm>
+            <a:off x="6583680" y="6254496"/>
+            <a:ext cx="5120640" cy="237744"/>
+          </a:xfrm>
+          <a:prstGeom prst="rect">
+            <a:avLst/>
+          </a:prstGeom>
+          <a:noFill/>
+        </p:spPr>
+        <p:txBody>
+          <a:bodyPr wrap="square" lIns="0" rIns="0" tIns="0" bIns="0" anchor="ctr">
+            <a:spAutoFit/>
+            <a:noAutofit/>
+          </a:bodyPr>
+          <a:lstStyle/>
+          <a:p>
+            <a:pPr algn="r" rtl="1"/>
+            <a:r>
+              <a:rPr lang="ar-SA" sz="900" b="0" dirty="0">
+                <a:solidFill>
+                  <a:srgbClr val="6E6E86"/>
+                </a:solidFill>
+                <a:latin typeface="DiodrumArabic-Regular" pitchFamily="2" charset="-78"/>
+                <a:cs typeface="DiodrumArabic-Regular" pitchFamily="2" charset="-78"/>
+              </a:rPr>
+              <a:t>برنامج القدرات الرقمية «قدراتك»   |   تقرير سير الأعمال الربعي – يونيو – أغسطس 2026</a:t>
+            </a:r>
+          </a:p>
+        </p:txBody>
+      </p:sp>
+      <p:sp>
+        <p:nvSpPr>
+          <p:cNvPr id="82" name="TextBox 81"/>
           <p:cNvSpPr txBox="1"/>
           <p:nvPr/>
         </p:nvSpPr>
@@ -14436,17 +14516,17 @@
         </p:nvSpPr>
         <p:spPr>
           <a:xfrm>
-            <a:off x="411480" y="155448"/>
-            <a:ext cx="822960" cy="548640"/>
-          </a:xfrm>
-        </p:spPr>
-        <p:txBody>
-          <a:bodyPr anchor="ctr" lIns="0"/>
+            <a:off x="384048" y="6455664"/>
+            <a:ext cx="731520" cy="237744"/>
+          </a:xfrm>
+        </p:spPr>
+        <p:txBody>
+          <a:bodyPr anchor="ctr" lIns="0" tIns="0" bIns="0"/>
           <a:lstStyle/>
           <a:p>
             <a:pPr algn="l"/>
             <a:fld id="{679EF615-E246-4FA6-9E75-123AAEB83405}" type="slidenum">
-              <a:rPr lang="en-US" smtClean="0" sz="1200" b="1">
+              <a:rPr lang="en-US" smtClean="0" sz="1050" b="1">
                 <a:solidFill>
                   <a:srgbClr val="2A206A"/>
                 </a:solidFill>
@@ -14468,8 +14548,8 @@
         </p:nvSpPr>
         <p:spPr>
           <a:xfrm>
-            <a:off x="1234440" y="155448"/>
-            <a:ext cx="10561320" cy="548640"/>
+            <a:off x="411480" y="155448"/>
+            <a:ext cx="11384280" cy="548640"/>
           </a:xfrm>
           <a:prstGeom prst="rect">
             <a:avLst/>
@@ -14507,9 +14587,46 @@
           </a:p>
         </p:txBody>
       </p:sp>
+      <p:sp>
+        <p:nvSpPr>
+          <p:cNvPr id="4" name="TextBox 3"/>
+          <p:cNvSpPr txBox="1"/>
+          <p:nvPr/>
+        </p:nvSpPr>
+        <p:spPr>
+          <a:xfrm>
+            <a:off x="6583680" y="6254496"/>
+            <a:ext cx="5120640" cy="237744"/>
+          </a:xfrm>
+          <a:prstGeom prst="rect">
+            <a:avLst/>
+          </a:prstGeom>
+          <a:noFill/>
+        </p:spPr>
+        <p:txBody>
+          <a:bodyPr wrap="square" lIns="0" rIns="0" tIns="0" bIns="0" anchor="ctr">
+            <a:spAutoFit/>
+            <a:noAutofit/>
+          </a:bodyPr>
+          <a:lstStyle/>
+          <a:p>
+            <a:pPr algn="r" rtl="1"/>
+            <a:r>
+              <a:rPr lang="ar-SA" sz="900" b="0" dirty="0">
+                <a:solidFill>
+                  <a:srgbClr val="6E6E86"/>
+                </a:solidFill>
+                <a:latin typeface="DiodrumArabic-Regular" pitchFamily="2" charset="-78"/>
+                <a:cs typeface="DiodrumArabic-Regular" pitchFamily="2" charset="-78"/>
+              </a:rPr>
+              <a:t>برنامج القدرات الرقمية «قدراتك»   |   تقرير سير الأعمال الربعي – يونيو – أغسطس 2026</a:t>
+            </a:r>
+          </a:p>
+        </p:txBody>
+      </p:sp>
       <p:cxnSp>
         <p:nvCxnSpPr>
-          <p:cNvPr id="4" name="Connector 3"/>
+          <p:cNvPr id="5" name="Connector 4"/>
           <p:cNvCxnSpPr/>
           <p:nvPr/>
         </p:nvCxnSpPr>
@@ -14538,7 +14655,7 @@
       </p:cxnSp>
       <p:sp>
         <p:nvSpPr>
-          <p:cNvPr id="5" name="Rounded Rectangle 4"/>
+          <p:cNvPr id="6" name="Rounded Rectangle 5"/>
           <p:cNvSpPr/>
           <p:nvPr/>
         </p:nvSpPr>
@@ -14582,7 +14699,7 @@
       </p:sp>
       <p:sp>
         <p:nvSpPr>
-          <p:cNvPr id="6" name="TextBox 5"/>
+          <p:cNvPr id="7" name="TextBox 6"/>
           <p:cNvSpPr txBox="1"/>
           <p:nvPr/>
         </p:nvSpPr>
@@ -14623,7 +14740,7 @@
       </p:sp>
       <p:pic>
         <p:nvPicPr>
-          <p:cNvPr id="7" name="Picture 6" descr="mcit_logo.png"/>
+          <p:cNvPr id="8" name="Picture 7" descr="mcit_logo.png"/>
           <p:cNvPicPr>
             <a:picLocks noChangeAspect="1"/>
           </p:cNvPicPr>
@@ -14647,7 +14764,7 @@
       </p:pic>
       <p:sp>
         <p:nvSpPr>
-          <p:cNvPr id="8" name="TextBox 7"/>
+          <p:cNvPr id="9" name="TextBox 8"/>
           <p:cNvSpPr txBox="1"/>
           <p:nvPr/>
         </p:nvSpPr>
@@ -14684,7 +14801,7 @@
       </p:sp>
       <p:sp>
         <p:nvSpPr>
-          <p:cNvPr id="9" name="Rounded Rectangle 8"/>
+          <p:cNvPr id="10" name="Rounded Rectangle 9"/>
           <p:cNvSpPr/>
           <p:nvPr/>
         </p:nvSpPr>
@@ -14722,7 +14839,7 @@
       </p:sp>
       <p:sp>
         <p:nvSpPr>
-          <p:cNvPr id="10" name="Rounded Rectangle 9"/>
+          <p:cNvPr id="11" name="Rounded Rectangle 10"/>
           <p:cNvSpPr/>
           <p:nvPr/>
         </p:nvSpPr>
@@ -14759,7 +14876,7 @@
       </p:sp>
       <p:sp>
         <p:nvSpPr>
-          <p:cNvPr id="11" name="TextBox 10"/>
+          <p:cNvPr id="12" name="TextBox 11"/>
           <p:cNvSpPr txBox="1"/>
           <p:nvPr/>
         </p:nvSpPr>
@@ -14817,7 +14934,7 @@
       </p:sp>
       <p:sp>
         <p:nvSpPr>
-          <p:cNvPr id="12" name="TextBox 11"/>
+          <p:cNvPr id="13" name="TextBox 12"/>
           <p:cNvSpPr txBox="1"/>
           <p:nvPr/>
         </p:nvSpPr>
@@ -14868,7 +14985,7 @@
       </p:sp>
       <p:sp>
         <p:nvSpPr>
-          <p:cNvPr id="13" name="TextBox 12"/>
+          <p:cNvPr id="14" name="TextBox 13"/>
           <p:cNvSpPr txBox="1"/>
           <p:nvPr/>
         </p:nvSpPr>
@@ -14919,7 +15036,7 @@
       </p:sp>
       <p:sp>
         <p:nvSpPr>
-          <p:cNvPr id="14" name="Rounded Rectangle 13"/>
+          <p:cNvPr id="15" name="Rounded Rectangle 14"/>
           <p:cNvSpPr/>
           <p:nvPr/>
         </p:nvSpPr>
@@ -14962,7 +15079,7 @@
       </p:sp>
       <p:sp>
         <p:nvSpPr>
-          <p:cNvPr id="15" name="Oval 14"/>
+          <p:cNvPr id="16" name="Oval 15"/>
           <p:cNvSpPr/>
           <p:nvPr/>
         </p:nvSpPr>
@@ -14991,7 +15108,7 @@
       </p:sp>
       <p:sp>
         <p:nvSpPr>
-          <p:cNvPr id="16" name="Rounded Rectangle 15"/>
+          <p:cNvPr id="17" name="Rounded Rectangle 16"/>
           <p:cNvSpPr/>
           <p:nvPr/>
         </p:nvSpPr>
@@ -15029,7 +15146,7 @@
       </p:sp>
       <p:sp>
         <p:nvSpPr>
-          <p:cNvPr id="17" name="Rounded Rectangle 16"/>
+          <p:cNvPr id="18" name="Rounded Rectangle 17"/>
           <p:cNvSpPr/>
           <p:nvPr/>
         </p:nvSpPr>
@@ -15066,7 +15183,7 @@
       </p:sp>
       <p:sp>
         <p:nvSpPr>
-          <p:cNvPr id="18" name="TextBox 17"/>
+          <p:cNvPr id="19" name="TextBox 18"/>
           <p:cNvSpPr txBox="1"/>
           <p:nvPr/>
         </p:nvSpPr>
@@ -15124,7 +15241,7 @@
       </p:sp>
       <p:sp>
         <p:nvSpPr>
-          <p:cNvPr id="19" name="TextBox 18"/>
+          <p:cNvPr id="20" name="TextBox 19"/>
           <p:cNvSpPr txBox="1"/>
           <p:nvPr/>
         </p:nvSpPr>
@@ -15175,7 +15292,7 @@
       </p:sp>
       <p:sp>
         <p:nvSpPr>
-          <p:cNvPr id="20" name="TextBox 19"/>
+          <p:cNvPr id="21" name="TextBox 20"/>
           <p:cNvSpPr txBox="1"/>
           <p:nvPr/>
         </p:nvSpPr>
@@ -15226,7 +15343,7 @@
       </p:sp>
       <p:sp>
         <p:nvSpPr>
-          <p:cNvPr id="21" name="Rounded Rectangle 20"/>
+          <p:cNvPr id="22" name="Rounded Rectangle 21"/>
           <p:cNvSpPr/>
           <p:nvPr/>
         </p:nvSpPr>
@@ -15269,7 +15386,7 @@
       </p:sp>
       <p:sp>
         <p:nvSpPr>
-          <p:cNvPr id="22" name="Oval 21"/>
+          <p:cNvPr id="23" name="Oval 22"/>
           <p:cNvSpPr/>
           <p:nvPr/>
         </p:nvSpPr>
@@ -15298,7 +15415,7 @@
       </p:sp>
       <p:sp>
         <p:nvSpPr>
-          <p:cNvPr id="23" name="Rounded Rectangle 22"/>
+          <p:cNvPr id="24" name="Rounded Rectangle 23"/>
           <p:cNvSpPr/>
           <p:nvPr/>
         </p:nvSpPr>
@@ -15336,7 +15453,7 @@
       </p:sp>
       <p:sp>
         <p:nvSpPr>
-          <p:cNvPr id="24" name="Rounded Rectangle 23"/>
+          <p:cNvPr id="25" name="Rounded Rectangle 24"/>
           <p:cNvSpPr/>
           <p:nvPr/>
         </p:nvSpPr>
@@ -15373,7 +15490,7 @@
       </p:sp>
       <p:sp>
         <p:nvSpPr>
-          <p:cNvPr id="25" name="TextBox 24"/>
+          <p:cNvPr id="26" name="TextBox 25"/>
           <p:cNvSpPr txBox="1"/>
           <p:nvPr/>
         </p:nvSpPr>
@@ -15431,7 +15548,7 @@
       </p:sp>
       <p:sp>
         <p:nvSpPr>
-          <p:cNvPr id="26" name="TextBox 25"/>
+          <p:cNvPr id="27" name="TextBox 26"/>
           <p:cNvSpPr txBox="1"/>
           <p:nvPr/>
         </p:nvSpPr>
@@ -15482,7 +15599,7 @@
       </p:sp>
       <p:sp>
         <p:nvSpPr>
-          <p:cNvPr id="27" name="TextBox 26"/>
+          <p:cNvPr id="28" name="TextBox 27"/>
           <p:cNvSpPr txBox="1"/>
           <p:nvPr/>
         </p:nvSpPr>
@@ -15533,7 +15650,7 @@
       </p:sp>
       <p:sp>
         <p:nvSpPr>
-          <p:cNvPr id="28" name="Rounded Rectangle 27"/>
+          <p:cNvPr id="29" name="Rounded Rectangle 28"/>
           <p:cNvSpPr/>
           <p:nvPr/>
         </p:nvSpPr>
@@ -15576,7 +15693,7 @@
       </p:sp>
       <p:sp>
         <p:nvSpPr>
-          <p:cNvPr id="29" name="Oval 28"/>
+          <p:cNvPr id="30" name="Oval 29"/>
           <p:cNvSpPr/>
           <p:nvPr/>
         </p:nvSpPr>
@@ -15605,7 +15722,7 @@
       </p:sp>
       <p:sp>
         <p:nvSpPr>
-          <p:cNvPr id="30" name="Rounded Rectangle 29"/>
+          <p:cNvPr id="31" name="Rounded Rectangle 30"/>
           <p:cNvSpPr/>
           <p:nvPr/>
         </p:nvSpPr>
@@ -15636,7 +15753,7 @@
       </p:sp>
       <p:sp>
         <p:nvSpPr>
-          <p:cNvPr id="31" name="TextBox 30"/>
+          <p:cNvPr id="32" name="TextBox 31"/>
           <p:cNvSpPr txBox="1"/>
           <p:nvPr/>
         </p:nvSpPr>
@@ -16052,12 +16169,12 @@
         </p:nvSpPr>
         <p:spPr>
           <a:xfrm>
-            <a:off x="411480" y="402336"/>
-            <a:ext cx="822960" cy="640080"/>
-          </a:xfrm>
-        </p:spPr>
-        <p:txBody>
-          <a:bodyPr anchor="ctr" lIns="0"/>
+            <a:off x="384048" y="6455664"/>
+            <a:ext cx="731520" cy="237744"/>
+          </a:xfrm>
+        </p:spPr>
+        <p:txBody>
+          <a:bodyPr anchor="ctr" lIns="0" tIns="0" bIns="0"/>
           <a:lstStyle/>
           <a:p>
             <a:pPr marL="0" marR="0" lvl="0" indent="0" algn="l" defTabSz="914400" rtl="0" eaLnBrk="1" fontAlgn="auto" latinLnBrk="0" hangingPunct="1">
@@ -16080,7 +16197,7 @@
               <a:defRPr/>
             </a:pPr>
             <a:fld id="{679EF615-E246-4FA6-9E75-123AAEB83405}" type="slidenum">
-              <a:rPr kumimoji="0" lang="en-US" sz="1200" b="1" i="0" u="none" strike="noStrike" kern="0" cap="none" spc="0" normalizeH="0" baseline="0" noProof="0" smtClean="0">
+              <a:rPr kumimoji="0" lang="en-US" sz="1050" b="1" i="0" u="none" strike="noStrike" kern="0" cap="none" spc="0" normalizeH="0" baseline="0" noProof="0" smtClean="0">
                 <a:solidFill>
                   <a:srgbClr val="2A206A"/>
                 </a:solidFill>
@@ -16130,6 +16247,43 @@
       <p:sp>
         <p:nvSpPr>
           <p:cNvPr id="81" name="TextBox 80"/>
+          <p:cNvSpPr txBox="1"/>
+          <p:nvPr/>
+        </p:nvSpPr>
+        <p:spPr>
+          <a:xfrm>
+            <a:off x="6583680" y="6254496"/>
+            <a:ext cx="5120640" cy="237744"/>
+          </a:xfrm>
+          <a:prstGeom prst="rect">
+            <a:avLst/>
+          </a:prstGeom>
+          <a:noFill/>
+        </p:spPr>
+        <p:txBody>
+          <a:bodyPr wrap="square" lIns="0" rIns="0" tIns="0" bIns="0" anchor="ctr">
+            <a:spAutoFit/>
+            <a:noAutofit/>
+          </a:bodyPr>
+          <a:lstStyle/>
+          <a:p>
+            <a:pPr algn="r" rtl="1"/>
+            <a:r>
+              <a:rPr lang="ar-SA" sz="900" b="0" dirty="0">
+                <a:solidFill>
+                  <a:srgbClr val="6E6E86"/>
+                </a:solidFill>
+                <a:latin typeface="DiodrumArabic-Regular" pitchFamily="2" charset="-78"/>
+                <a:cs typeface="DiodrumArabic-Regular" pitchFamily="2" charset="-78"/>
+              </a:rPr>
+              <a:t>برنامج القدرات الرقمية «قدراتك»   |   تقرير سير الأعمال الربعي – يونيو – أغسطس 2026</a:t>
+            </a:r>
+          </a:p>
+        </p:txBody>
+      </p:sp>
+      <p:sp>
+        <p:nvSpPr>
+          <p:cNvPr id="82" name="TextBox 81"/>
           <p:cNvSpPr txBox="1"/>
           <p:nvPr/>
         </p:nvSpPr>
@@ -16230,17 +16384,17 @@
         </p:nvSpPr>
         <p:spPr>
           <a:xfrm>
-            <a:off x="411480" y="155448"/>
-            <a:ext cx="822960" cy="548640"/>
-          </a:xfrm>
-        </p:spPr>
-        <p:txBody>
-          <a:bodyPr anchor="ctr" lIns="0"/>
+            <a:off x="384048" y="6455664"/>
+            <a:ext cx="731520" cy="237744"/>
+          </a:xfrm>
+        </p:spPr>
+        <p:txBody>
+          <a:bodyPr anchor="ctr" lIns="0" tIns="0" bIns="0"/>
           <a:lstStyle/>
           <a:p>
             <a:pPr algn="l"/>
             <a:fld id="{679EF615-E246-4FA6-9E75-123AAEB83405}" type="slidenum">
-              <a:rPr lang="en-US" smtClean="0" sz="1200" b="1">
+              <a:rPr lang="en-US" smtClean="0" sz="1050" b="1">
                 <a:solidFill>
                   <a:srgbClr val="2A206A"/>
                 </a:solidFill>
@@ -16262,8 +16416,8 @@
         </p:nvSpPr>
         <p:spPr>
           <a:xfrm>
-            <a:off x="1234440" y="155448"/>
-            <a:ext cx="10561320" cy="548640"/>
+            <a:off x="411480" y="155448"/>
+            <a:ext cx="11384280" cy="548640"/>
           </a:xfrm>
           <a:prstGeom prst="rect">
             <a:avLst/>
@@ -16301,9 +16455,46 @@
           </a:p>
         </p:txBody>
       </p:sp>
+      <p:sp>
+        <p:nvSpPr>
+          <p:cNvPr id="4" name="TextBox 3"/>
+          <p:cNvSpPr txBox="1"/>
+          <p:nvPr/>
+        </p:nvSpPr>
+        <p:spPr>
+          <a:xfrm>
+            <a:off x="6583680" y="6254496"/>
+            <a:ext cx="5120640" cy="237744"/>
+          </a:xfrm>
+          <a:prstGeom prst="rect">
+            <a:avLst/>
+          </a:prstGeom>
+          <a:noFill/>
+        </p:spPr>
+        <p:txBody>
+          <a:bodyPr wrap="square" lIns="0" rIns="0" tIns="0" bIns="0" anchor="ctr">
+            <a:spAutoFit/>
+            <a:noAutofit/>
+          </a:bodyPr>
+          <a:lstStyle/>
+          <a:p>
+            <a:pPr algn="r" rtl="1"/>
+            <a:r>
+              <a:rPr lang="ar-SA" sz="900" b="0" dirty="0">
+                <a:solidFill>
+                  <a:srgbClr val="6E6E86"/>
+                </a:solidFill>
+                <a:latin typeface="DiodrumArabic-Regular" pitchFamily="2" charset="-78"/>
+                <a:cs typeface="DiodrumArabic-Regular" pitchFamily="2" charset="-78"/>
+              </a:rPr>
+              <a:t>برنامج القدرات الرقمية «قدراتك»   |   تقرير سير الأعمال الربعي – يونيو – أغسطس 2026</a:t>
+            </a:r>
+          </a:p>
+        </p:txBody>
+      </p:sp>
       <p:cxnSp>
         <p:nvCxnSpPr>
-          <p:cNvPr id="4" name="Connector 3"/>
+          <p:cNvPr id="5" name="Connector 4"/>
           <p:cNvCxnSpPr/>
           <p:nvPr/>
         </p:nvCxnSpPr>
@@ -16332,7 +16523,7 @@
       </p:cxnSp>
       <p:sp>
         <p:nvSpPr>
-          <p:cNvPr id="5" name="Rounded Rectangle 4"/>
+          <p:cNvPr id="6" name="Rounded Rectangle 5"/>
           <p:cNvSpPr/>
           <p:nvPr/>
         </p:nvSpPr>
@@ -16376,7 +16567,7 @@
       </p:sp>
       <p:sp>
         <p:nvSpPr>
-          <p:cNvPr id="6" name="TextBox 5"/>
+          <p:cNvPr id="7" name="TextBox 6"/>
           <p:cNvSpPr txBox="1"/>
           <p:nvPr/>
         </p:nvSpPr>
@@ -16417,7 +16608,7 @@
       </p:sp>
       <p:sp>
         <p:nvSpPr>
-          <p:cNvPr id="7" name="TextBox 6"/>
+          <p:cNvPr id="8" name="TextBox 7"/>
           <p:cNvSpPr txBox="1"/>
           <p:nvPr/>
         </p:nvSpPr>
@@ -16454,7 +16645,7 @@
       </p:sp>
       <p:cxnSp>
         <p:nvCxnSpPr>
-          <p:cNvPr id="8" name="Connector 7"/>
+          <p:cNvPr id="9" name="Connector 8"/>
           <p:cNvCxnSpPr/>
           <p:nvPr/>
         </p:nvCxnSpPr>
@@ -16475,7 +16666,7 @@
       </p:cxnSp>
       <p:sp>
         <p:nvSpPr>
-          <p:cNvPr id="9" name="Oval 8"/>
+          <p:cNvPr id="10" name="Oval 9"/>
           <p:cNvSpPr/>
           <p:nvPr/>
         </p:nvSpPr>
@@ -16506,7 +16697,7 @@
       </p:sp>
       <p:sp>
         <p:nvSpPr>
-          <p:cNvPr id="10" name="TextBox 9"/>
+          <p:cNvPr id="11" name="TextBox 10"/>
           <p:cNvSpPr txBox="1"/>
           <p:nvPr/>
         </p:nvSpPr>
@@ -16543,7 +16734,7 @@
       </p:sp>
       <p:sp>
         <p:nvSpPr>
-          <p:cNvPr id="11" name="TextBox 10"/>
+          <p:cNvPr id="12" name="TextBox 11"/>
           <p:cNvSpPr txBox="1"/>
           <p:nvPr/>
         </p:nvSpPr>
@@ -16584,7 +16775,7 @@
       </p:sp>
       <p:sp>
         <p:nvSpPr>
-          <p:cNvPr id="12" name="Oval 11"/>
+          <p:cNvPr id="13" name="Oval 12"/>
           <p:cNvSpPr/>
           <p:nvPr/>
         </p:nvSpPr>
@@ -16615,7 +16806,7 @@
       </p:sp>
       <p:sp>
         <p:nvSpPr>
-          <p:cNvPr id="13" name="TextBox 12"/>
+          <p:cNvPr id="14" name="TextBox 13"/>
           <p:cNvSpPr txBox="1"/>
           <p:nvPr/>
         </p:nvSpPr>
@@ -16652,7 +16843,7 @@
       </p:sp>
       <p:sp>
         <p:nvSpPr>
-          <p:cNvPr id="14" name="TextBox 13"/>
+          <p:cNvPr id="15" name="TextBox 14"/>
           <p:cNvSpPr txBox="1"/>
           <p:nvPr/>
         </p:nvSpPr>
@@ -16693,7 +16884,7 @@
       </p:sp>
       <p:sp>
         <p:nvSpPr>
-          <p:cNvPr id="15" name="Oval 14"/>
+          <p:cNvPr id="16" name="Oval 15"/>
           <p:cNvSpPr/>
           <p:nvPr/>
         </p:nvSpPr>
@@ -16724,7 +16915,7 @@
       </p:sp>
       <p:sp>
         <p:nvSpPr>
-          <p:cNvPr id="16" name="TextBox 15"/>
+          <p:cNvPr id="17" name="TextBox 16"/>
           <p:cNvSpPr txBox="1"/>
           <p:nvPr/>
         </p:nvSpPr>
@@ -16761,7 +16952,7 @@
       </p:sp>
       <p:sp>
         <p:nvSpPr>
-          <p:cNvPr id="17" name="TextBox 16"/>
+          <p:cNvPr id="18" name="TextBox 17"/>
           <p:cNvSpPr txBox="1"/>
           <p:nvPr/>
         </p:nvSpPr>
@@ -16802,7 +16993,7 @@
       </p:sp>
       <p:sp>
         <p:nvSpPr>
-          <p:cNvPr id="18" name="Oval 17"/>
+          <p:cNvPr id="19" name="Oval 18"/>
           <p:cNvSpPr/>
           <p:nvPr/>
         </p:nvSpPr>
@@ -16833,7 +17024,7 @@
       </p:sp>
       <p:sp>
         <p:nvSpPr>
-          <p:cNvPr id="19" name="TextBox 18"/>
+          <p:cNvPr id="20" name="TextBox 19"/>
           <p:cNvSpPr txBox="1"/>
           <p:nvPr/>
         </p:nvSpPr>
@@ -16870,7 +17061,7 @@
       </p:sp>
       <p:sp>
         <p:nvSpPr>
-          <p:cNvPr id="20" name="TextBox 19"/>
+          <p:cNvPr id="21" name="TextBox 20"/>
           <p:cNvSpPr txBox="1"/>
           <p:nvPr/>
         </p:nvSpPr>
@@ -16911,7 +17102,7 @@
       </p:sp>
       <p:sp>
         <p:nvSpPr>
-          <p:cNvPr id="21" name="Oval 20"/>
+          <p:cNvPr id="22" name="Oval 21"/>
           <p:cNvSpPr/>
           <p:nvPr/>
         </p:nvSpPr>
@@ -16942,7 +17133,7 @@
       </p:sp>
       <p:sp>
         <p:nvSpPr>
-          <p:cNvPr id="22" name="TextBox 21"/>
+          <p:cNvPr id="23" name="TextBox 22"/>
           <p:cNvSpPr txBox="1"/>
           <p:nvPr/>
         </p:nvSpPr>
@@ -16979,7 +17170,7 @@
       </p:sp>
       <p:sp>
         <p:nvSpPr>
-          <p:cNvPr id="23" name="TextBox 22"/>
+          <p:cNvPr id="24" name="TextBox 23"/>
           <p:cNvSpPr txBox="1"/>
           <p:nvPr/>
         </p:nvSpPr>
@@ -17020,7 +17211,7 @@
       </p:sp>
       <p:sp>
         <p:nvSpPr>
-          <p:cNvPr id="24" name="Oval 23"/>
+          <p:cNvPr id="25" name="Oval 24"/>
           <p:cNvSpPr/>
           <p:nvPr/>
         </p:nvSpPr>
@@ -17051,7 +17242,7 @@
       </p:sp>
       <p:sp>
         <p:nvSpPr>
-          <p:cNvPr id="25" name="TextBox 24"/>
+          <p:cNvPr id="26" name="TextBox 25"/>
           <p:cNvSpPr txBox="1"/>
           <p:nvPr/>
         </p:nvSpPr>
@@ -17088,7 +17279,7 @@
       </p:sp>
       <p:sp>
         <p:nvSpPr>
-          <p:cNvPr id="26" name="TextBox 25"/>
+          <p:cNvPr id="27" name="TextBox 26"/>
           <p:cNvSpPr txBox="1"/>
           <p:nvPr/>
         </p:nvSpPr>
@@ -17129,7 +17320,7 @@
       </p:sp>
       <p:sp>
         <p:nvSpPr>
-          <p:cNvPr id="27" name="Oval 26"/>
+          <p:cNvPr id="28" name="Oval 27"/>
           <p:cNvSpPr/>
           <p:nvPr/>
         </p:nvSpPr>
@@ -17160,7 +17351,7 @@
       </p:sp>
       <p:sp>
         <p:nvSpPr>
-          <p:cNvPr id="28" name="TextBox 27"/>
+          <p:cNvPr id="29" name="TextBox 28"/>
           <p:cNvSpPr txBox="1"/>
           <p:nvPr/>
         </p:nvSpPr>
@@ -17197,7 +17388,7 @@
       </p:sp>
       <p:sp>
         <p:nvSpPr>
-          <p:cNvPr id="29" name="TextBox 28"/>
+          <p:cNvPr id="30" name="TextBox 29"/>
           <p:cNvSpPr txBox="1"/>
           <p:nvPr/>
         </p:nvSpPr>
@@ -17238,7 +17429,7 @@
       </p:sp>
       <p:sp>
         <p:nvSpPr>
-          <p:cNvPr id="30" name="Oval 29"/>
+          <p:cNvPr id="31" name="Oval 30"/>
           <p:cNvSpPr/>
           <p:nvPr/>
         </p:nvSpPr>
@@ -17269,7 +17460,7 @@
       </p:sp>
       <p:sp>
         <p:nvSpPr>
-          <p:cNvPr id="31" name="TextBox 30"/>
+          <p:cNvPr id="32" name="TextBox 31"/>
           <p:cNvSpPr txBox="1"/>
           <p:nvPr/>
         </p:nvSpPr>
@@ -17306,7 +17497,7 @@
       </p:sp>
       <p:sp>
         <p:nvSpPr>
-          <p:cNvPr id="32" name="TextBox 31"/>
+          <p:cNvPr id="33" name="TextBox 32"/>
           <p:cNvSpPr txBox="1"/>
           <p:nvPr/>
         </p:nvSpPr>
@@ -17347,7 +17538,7 @@
       </p:sp>
       <p:sp>
         <p:nvSpPr>
-          <p:cNvPr id="33" name="TextBox 32"/>
+          <p:cNvPr id="34" name="TextBox 33"/>
           <p:cNvSpPr txBox="1"/>
           <p:nvPr/>
         </p:nvSpPr>
@@ -17384,7 +17575,7 @@
       </p:sp>
       <p:sp>
         <p:nvSpPr>
-          <p:cNvPr id="34" name="Oval 33"/>
+          <p:cNvPr id="35" name="Oval 34"/>
           <p:cNvSpPr/>
           <p:nvPr/>
         </p:nvSpPr>
@@ -17413,7 +17604,7 @@
       </p:sp>
       <p:sp>
         <p:nvSpPr>
-          <p:cNvPr id="35" name="TextBox 34"/>
+          <p:cNvPr id="36" name="TextBox 35"/>
           <p:cNvSpPr txBox="1"/>
           <p:nvPr/>
         </p:nvSpPr>
@@ -17450,7 +17641,7 @@
       </p:sp>
       <p:sp>
         <p:nvSpPr>
-          <p:cNvPr id="36" name="Oval 35"/>
+          <p:cNvPr id="37" name="Oval 36"/>
           <p:cNvSpPr/>
           <p:nvPr/>
         </p:nvSpPr>
@@ -17479,7 +17670,7 @@
       </p:sp>
       <p:sp>
         <p:nvSpPr>
-          <p:cNvPr id="37" name="TextBox 36"/>
+          <p:cNvPr id="38" name="TextBox 37"/>
           <p:cNvSpPr txBox="1"/>
           <p:nvPr/>
         </p:nvSpPr>
@@ -17516,7 +17707,7 @@
       </p:sp>
       <p:sp>
         <p:nvSpPr>
-          <p:cNvPr id="38" name="Oval 37"/>
+          <p:cNvPr id="39" name="Oval 38"/>
           <p:cNvSpPr/>
           <p:nvPr/>
         </p:nvSpPr>
@@ -17545,7 +17736,7 @@
       </p:sp>
       <p:sp>
         <p:nvSpPr>
-          <p:cNvPr id="39" name="Rounded Rectangle 38"/>
+          <p:cNvPr id="40" name="Rounded Rectangle 39"/>
           <p:cNvSpPr/>
           <p:nvPr/>
         </p:nvSpPr>
@@ -17589,7 +17780,7 @@
       </p:sp>
       <p:sp>
         <p:nvSpPr>
-          <p:cNvPr id="40" name="TextBox 39"/>
+          <p:cNvPr id="41" name="TextBox 40"/>
           <p:cNvSpPr txBox="1"/>
           <p:nvPr/>
         </p:nvSpPr>
@@ -17626,7 +17817,7 @@
       </p:sp>
       <p:sp>
         <p:nvSpPr>
-          <p:cNvPr id="41" name="TextBox 40"/>
+          <p:cNvPr id="42" name="TextBox 41"/>
           <p:cNvSpPr txBox="1"/>
           <p:nvPr/>
         </p:nvSpPr>
@@ -17684,7 +17875,7 @@
       </p:sp>
       <p:sp>
         <p:nvSpPr>
-          <p:cNvPr id="42" name="Rounded Rectangle 41"/>
+          <p:cNvPr id="43" name="Rounded Rectangle 42"/>
           <p:cNvSpPr/>
           <p:nvPr/>
         </p:nvSpPr>
@@ -17727,7 +17918,7 @@
       </p:sp>
       <p:graphicFrame>
         <p:nvGraphicFramePr>
-          <p:cNvPr id="43" name="Table 42"/>
+          <p:cNvPr id="44" name="Table 43"/>
           <p:cNvGraphicFramePr>
             <a:graphicFrameLocks noGrp="1"/>
           </p:cNvGraphicFramePr>
@@ -18699,12 +18890,12 @@
         </p:nvSpPr>
         <p:spPr>
           <a:xfrm>
-            <a:off x="411480" y="402336"/>
-            <a:ext cx="822960" cy="640080"/>
-          </a:xfrm>
-        </p:spPr>
-        <p:txBody>
-          <a:bodyPr anchor="ctr" lIns="0"/>
+            <a:off x="384048" y="6455664"/>
+            <a:ext cx="731520" cy="237744"/>
+          </a:xfrm>
+        </p:spPr>
+        <p:txBody>
+          <a:bodyPr anchor="ctr" lIns="0" tIns="0" bIns="0"/>
           <a:lstStyle/>
           <a:p>
             <a:pPr marL="0" marR="0" lvl="0" indent="0" algn="l" defTabSz="914400" rtl="0" eaLnBrk="1" fontAlgn="auto" latinLnBrk="0" hangingPunct="1">
@@ -18727,7 +18918,7 @@
               <a:defRPr/>
             </a:pPr>
             <a:fld id="{679EF615-E246-4FA6-9E75-123AAEB83405}" type="slidenum">
-              <a:rPr kumimoji="0" lang="en-US" sz="1200" b="1" i="0" u="none" strike="noStrike" kern="0" cap="none" spc="0" normalizeH="0" baseline="0" noProof="0" smtClean="0">
+              <a:rPr kumimoji="0" lang="en-US" sz="1050" b="1" i="0" u="none" strike="noStrike" kern="0" cap="none" spc="0" normalizeH="0" baseline="0" noProof="0" smtClean="0">
                 <a:solidFill>
                   <a:srgbClr val="2A206A"/>
                 </a:solidFill>
@@ -18777,6 +18968,43 @@
       <p:sp>
         <p:nvSpPr>
           <p:cNvPr id="81" name="TextBox 80"/>
+          <p:cNvSpPr txBox="1"/>
+          <p:nvPr/>
+        </p:nvSpPr>
+        <p:spPr>
+          <a:xfrm>
+            <a:off x="6583680" y="6254496"/>
+            <a:ext cx="5120640" cy="237744"/>
+          </a:xfrm>
+          <a:prstGeom prst="rect">
+            <a:avLst/>
+          </a:prstGeom>
+          <a:noFill/>
+        </p:spPr>
+        <p:txBody>
+          <a:bodyPr wrap="square" lIns="0" rIns="0" tIns="0" bIns="0" anchor="ctr">
+            <a:spAutoFit/>
+            <a:noAutofit/>
+          </a:bodyPr>
+          <a:lstStyle/>
+          <a:p>
+            <a:pPr algn="r" rtl="1"/>
+            <a:r>
+              <a:rPr lang="ar-SA" sz="900" b="0" dirty="0">
+                <a:solidFill>
+                  <a:srgbClr val="6E6E86"/>
+                </a:solidFill>
+                <a:latin typeface="DiodrumArabic-Regular" pitchFamily="2" charset="-78"/>
+                <a:cs typeface="DiodrumArabic-Regular" pitchFamily="2" charset="-78"/>
+              </a:rPr>
+              <a:t>برنامج القدرات الرقمية «قدراتك»   |   تقرير سير الأعمال الربعي – يونيو – أغسطس 2026</a:t>
+            </a:r>
+          </a:p>
+        </p:txBody>
+      </p:sp>
+      <p:sp>
+        <p:nvSpPr>
+          <p:cNvPr id="82" name="TextBox 81"/>
           <p:cNvSpPr txBox="1"/>
           <p:nvPr/>
         </p:nvSpPr>
@@ -18877,17 +19105,17 @@
         </p:nvSpPr>
         <p:spPr>
           <a:xfrm>
-            <a:off x="411480" y="155448"/>
-            <a:ext cx="822960" cy="548640"/>
-          </a:xfrm>
-        </p:spPr>
-        <p:txBody>
-          <a:bodyPr anchor="ctr" lIns="0"/>
+            <a:off x="384048" y="6455664"/>
+            <a:ext cx="731520" cy="237744"/>
+          </a:xfrm>
+        </p:spPr>
+        <p:txBody>
+          <a:bodyPr anchor="ctr" lIns="0" tIns="0" bIns="0"/>
           <a:lstStyle/>
           <a:p>
             <a:pPr algn="l"/>
             <a:fld id="{679EF615-E246-4FA6-9E75-123AAEB83405}" type="slidenum">
-              <a:rPr lang="en-US" smtClean="0" sz="1200" b="1">
+              <a:rPr lang="en-US" smtClean="0" sz="1050" b="1">
                 <a:solidFill>
                   <a:srgbClr val="2A206A"/>
                 </a:solidFill>
@@ -18909,8 +19137,8 @@
         </p:nvSpPr>
         <p:spPr>
           <a:xfrm>
-            <a:off x="1234440" y="155448"/>
-            <a:ext cx="10561320" cy="548640"/>
+            <a:off x="411480" y="155448"/>
+            <a:ext cx="11384280" cy="548640"/>
           </a:xfrm>
           <a:prstGeom prst="rect">
             <a:avLst/>
@@ -18948,9 +19176,46 @@
           </a:p>
         </p:txBody>
       </p:sp>
+      <p:sp>
+        <p:nvSpPr>
+          <p:cNvPr id="4" name="TextBox 3"/>
+          <p:cNvSpPr txBox="1"/>
+          <p:nvPr/>
+        </p:nvSpPr>
+        <p:spPr>
+          <a:xfrm>
+            <a:off x="6583680" y="6254496"/>
+            <a:ext cx="5120640" cy="237744"/>
+          </a:xfrm>
+          <a:prstGeom prst="rect">
+            <a:avLst/>
+          </a:prstGeom>
+          <a:noFill/>
+        </p:spPr>
+        <p:txBody>
+          <a:bodyPr wrap="square" lIns="0" rIns="0" tIns="0" bIns="0" anchor="ctr">
+            <a:spAutoFit/>
+            <a:noAutofit/>
+          </a:bodyPr>
+          <a:lstStyle/>
+          <a:p>
+            <a:pPr algn="r" rtl="1"/>
+            <a:r>
+              <a:rPr lang="ar-SA" sz="900" b="0" dirty="0">
+                <a:solidFill>
+                  <a:srgbClr val="6E6E86"/>
+                </a:solidFill>
+                <a:latin typeface="DiodrumArabic-Regular" pitchFamily="2" charset="-78"/>
+                <a:cs typeface="DiodrumArabic-Regular" pitchFamily="2" charset="-78"/>
+              </a:rPr>
+              <a:t>برنامج القدرات الرقمية «قدراتك»   |   تقرير سير الأعمال الربعي – يونيو – أغسطس 2026</a:t>
+            </a:r>
+          </a:p>
+        </p:txBody>
+      </p:sp>
       <p:cxnSp>
         <p:nvCxnSpPr>
-          <p:cNvPr id="4" name="Connector 3"/>
+          <p:cNvPr id="5" name="Connector 4"/>
           <p:cNvCxnSpPr/>
           <p:nvPr/>
         </p:nvCxnSpPr>
@@ -18979,7 +19244,7 @@
       </p:cxnSp>
       <p:sp>
         <p:nvSpPr>
-          <p:cNvPr id="5" name="Rounded Rectangle 4"/>
+          <p:cNvPr id="6" name="Rounded Rectangle 5"/>
           <p:cNvSpPr/>
           <p:nvPr/>
         </p:nvSpPr>
@@ -19023,7 +19288,7 @@
       </p:sp>
       <p:sp>
         <p:nvSpPr>
-          <p:cNvPr id="6" name="TextBox 5"/>
+          <p:cNvPr id="7" name="TextBox 6"/>
           <p:cNvSpPr txBox="1"/>
           <p:nvPr/>
         </p:nvSpPr>
@@ -19064,7 +19329,7 @@
       </p:sp>
       <p:pic>
         <p:nvPicPr>
-          <p:cNvPr id="7" name="Picture 6" descr="image.png"/>
+          <p:cNvPr id="8" name="Picture 7" descr="image.png"/>
           <p:cNvPicPr>
             <a:picLocks noChangeAspect="1"/>
           </p:cNvPicPr>
@@ -19088,7 +19353,7 @@
       </p:pic>
       <p:sp>
         <p:nvSpPr>
-          <p:cNvPr id="8" name="Rounded Rectangle 7"/>
+          <p:cNvPr id="9" name="Rounded Rectangle 8"/>
           <p:cNvSpPr/>
           <p:nvPr/>
         </p:nvSpPr>
@@ -19126,7 +19391,7 @@
       </p:sp>
       <p:sp>
         <p:nvSpPr>
-          <p:cNvPr id="9" name="TextBox 8"/>
+          <p:cNvPr id="10" name="TextBox 9"/>
           <p:cNvSpPr txBox="1"/>
           <p:nvPr/>
         </p:nvSpPr>
@@ -19163,7 +19428,7 @@
       </p:sp>
       <p:cxnSp>
         <p:nvCxnSpPr>
-          <p:cNvPr id="10" name="Connector 9"/>
+          <p:cNvPr id="11" name="Connector 10"/>
           <p:cNvCxnSpPr/>
           <p:nvPr/>
         </p:nvCxnSpPr>
@@ -19184,7 +19449,7 @@
       </p:cxnSp>
       <p:cxnSp>
         <p:nvCxnSpPr>
-          <p:cNvPr id="11" name="Connector 10"/>
+          <p:cNvPr id="12" name="Connector 11"/>
           <p:cNvCxnSpPr/>
           <p:nvPr/>
         </p:nvCxnSpPr>
@@ -19205,7 +19470,7 @@
       </p:cxnSp>
       <p:sp>
         <p:nvSpPr>
-          <p:cNvPr id="12" name="Oval 11"/>
+          <p:cNvPr id="13" name="Oval 12"/>
           <p:cNvSpPr/>
           <p:nvPr/>
         </p:nvSpPr>
@@ -19236,7 +19501,7 @@
       </p:sp>
       <p:sp>
         <p:nvSpPr>
-          <p:cNvPr id="13" name="TextBox 12"/>
+          <p:cNvPr id="14" name="TextBox 13"/>
           <p:cNvSpPr txBox="1"/>
           <p:nvPr/>
         </p:nvSpPr>
@@ -19273,7 +19538,7 @@
       </p:sp>
       <p:sp>
         <p:nvSpPr>
-          <p:cNvPr id="14" name="TextBox 13"/>
+          <p:cNvPr id="15" name="TextBox 14"/>
           <p:cNvSpPr txBox="1"/>
           <p:nvPr/>
         </p:nvSpPr>
@@ -19310,7 +19575,7 @@
       </p:sp>
       <p:sp>
         <p:nvSpPr>
-          <p:cNvPr id="15" name="TextBox 14"/>
+          <p:cNvPr id="16" name="TextBox 15"/>
           <p:cNvSpPr txBox="1"/>
           <p:nvPr/>
         </p:nvSpPr>
@@ -19351,7 +19616,7 @@
       </p:sp>
       <p:sp>
         <p:nvSpPr>
-          <p:cNvPr id="16" name="Oval 15"/>
+          <p:cNvPr id="17" name="Oval 16"/>
           <p:cNvSpPr/>
           <p:nvPr/>
         </p:nvSpPr>
@@ -19382,7 +19647,7 @@
       </p:sp>
       <p:sp>
         <p:nvSpPr>
-          <p:cNvPr id="17" name="TextBox 16"/>
+          <p:cNvPr id="18" name="TextBox 17"/>
           <p:cNvSpPr txBox="1"/>
           <p:nvPr/>
         </p:nvSpPr>
@@ -19419,7 +19684,7 @@
       </p:sp>
       <p:sp>
         <p:nvSpPr>
-          <p:cNvPr id="18" name="TextBox 17"/>
+          <p:cNvPr id="19" name="TextBox 18"/>
           <p:cNvSpPr txBox="1"/>
           <p:nvPr/>
         </p:nvSpPr>
@@ -19456,7 +19721,7 @@
       </p:sp>
       <p:sp>
         <p:nvSpPr>
-          <p:cNvPr id="19" name="TextBox 18"/>
+          <p:cNvPr id="20" name="TextBox 19"/>
           <p:cNvSpPr txBox="1"/>
           <p:nvPr/>
         </p:nvSpPr>
@@ -19497,7 +19762,7 @@
       </p:sp>
       <p:sp>
         <p:nvSpPr>
-          <p:cNvPr id="20" name="Rounded Rectangle 19"/>
+          <p:cNvPr id="21" name="Rounded Rectangle 20"/>
           <p:cNvSpPr/>
           <p:nvPr/>
         </p:nvSpPr>
@@ -19538,7 +19803,7 @@
       </p:sp>
       <p:sp>
         <p:nvSpPr>
-          <p:cNvPr id="21" name="Oval 20"/>
+          <p:cNvPr id="22" name="Oval 21"/>
           <p:cNvSpPr/>
           <p:nvPr/>
         </p:nvSpPr>
@@ -19569,7 +19834,7 @@
       </p:sp>
       <p:sp>
         <p:nvSpPr>
-          <p:cNvPr id="22" name="TextBox 21"/>
+          <p:cNvPr id="23" name="TextBox 22"/>
           <p:cNvSpPr txBox="1"/>
           <p:nvPr/>
         </p:nvSpPr>
@@ -19606,7 +19871,7 @@
       </p:sp>
       <p:sp>
         <p:nvSpPr>
-          <p:cNvPr id="23" name="TextBox 22"/>
+          <p:cNvPr id="24" name="TextBox 23"/>
           <p:cNvSpPr txBox="1"/>
           <p:nvPr/>
         </p:nvSpPr>
@@ -19643,7 +19908,7 @@
       </p:sp>
       <p:sp>
         <p:nvSpPr>
-          <p:cNvPr id="24" name="TextBox 23"/>
+          <p:cNvPr id="25" name="TextBox 24"/>
           <p:cNvSpPr txBox="1"/>
           <p:nvPr/>
         </p:nvSpPr>
@@ -19684,7 +19949,7 @@
       </p:sp>
       <p:sp>
         <p:nvSpPr>
-          <p:cNvPr id="25" name="Rounded Rectangle 24"/>
+          <p:cNvPr id="26" name="Rounded Rectangle 25"/>
           <p:cNvSpPr/>
           <p:nvPr/>
         </p:nvSpPr>
@@ -19728,7 +19993,7 @@
       </p:sp>
       <p:sp>
         <p:nvSpPr>
-          <p:cNvPr id="26" name="TextBox 25"/>
+          <p:cNvPr id="27" name="TextBox 26"/>
           <p:cNvSpPr txBox="1"/>
           <p:nvPr/>
         </p:nvSpPr>
@@ -19765,7 +20030,7 @@
       </p:sp>
       <p:sp>
         <p:nvSpPr>
-          <p:cNvPr id="27" name="TextBox 26"/>
+          <p:cNvPr id="28" name="TextBox 27"/>
           <p:cNvSpPr txBox="1"/>
           <p:nvPr/>
         </p:nvSpPr>
@@ -19806,7 +20071,7 @@
       </p:sp>
       <p:sp>
         <p:nvSpPr>
-          <p:cNvPr id="28" name="Rounded Rectangle 27"/>
+          <p:cNvPr id="29" name="Rounded Rectangle 28"/>
           <p:cNvSpPr/>
           <p:nvPr/>
         </p:nvSpPr>
@@ -19844,7 +20109,7 @@
       </p:sp>
       <p:sp>
         <p:nvSpPr>
-          <p:cNvPr id="29" name="TextBox 28"/>
+          <p:cNvPr id="30" name="TextBox 29"/>
           <p:cNvSpPr txBox="1"/>
           <p:nvPr/>
         </p:nvSpPr>
@@ -19881,7 +20146,7 @@
       </p:sp>
       <p:cxnSp>
         <p:nvCxnSpPr>
-          <p:cNvPr id="30" name="Connector 29"/>
+          <p:cNvPr id="31" name="Connector 30"/>
           <p:cNvCxnSpPr/>
           <p:nvPr/>
         </p:nvCxnSpPr>
@@ -19902,7 +20167,7 @@
       </p:cxnSp>
       <p:sp>
         <p:nvSpPr>
-          <p:cNvPr id="31" name="Oval 30"/>
+          <p:cNvPr id="32" name="Oval 31"/>
           <p:cNvSpPr/>
           <p:nvPr/>
         </p:nvSpPr>
@@ -19931,7 +20196,7 @@
       </p:sp>
       <p:sp>
         <p:nvSpPr>
-          <p:cNvPr id="32" name="TextBox 31"/>
+          <p:cNvPr id="33" name="TextBox 32"/>
           <p:cNvSpPr txBox="1"/>
           <p:nvPr/>
         </p:nvSpPr>
@@ -19968,7 +20233,7 @@
       </p:sp>
       <p:sp>
         <p:nvSpPr>
-          <p:cNvPr id="33" name="TextBox 32"/>
+          <p:cNvPr id="34" name="TextBox 33"/>
           <p:cNvSpPr txBox="1"/>
           <p:nvPr/>
         </p:nvSpPr>
@@ -20005,7 +20270,7 @@
       </p:sp>
       <p:sp>
         <p:nvSpPr>
-          <p:cNvPr id="34" name="TextBox 33"/>
+          <p:cNvPr id="35" name="TextBox 34"/>
           <p:cNvSpPr txBox="1"/>
           <p:nvPr/>
         </p:nvSpPr>
@@ -20046,7 +20311,7 @@
       </p:sp>
       <p:sp>
         <p:nvSpPr>
-          <p:cNvPr id="35" name="Oval 34"/>
+          <p:cNvPr id="36" name="Oval 35"/>
           <p:cNvSpPr/>
           <p:nvPr/>
         </p:nvSpPr>
@@ -20075,7 +20340,7 @@
       </p:sp>
       <p:sp>
         <p:nvSpPr>
-          <p:cNvPr id="36" name="TextBox 35"/>
+          <p:cNvPr id="37" name="TextBox 36"/>
           <p:cNvSpPr txBox="1"/>
           <p:nvPr/>
         </p:nvSpPr>
@@ -20112,7 +20377,7 @@
       </p:sp>
       <p:sp>
         <p:nvSpPr>
-          <p:cNvPr id="37" name="TextBox 36"/>
+          <p:cNvPr id="38" name="TextBox 37"/>
           <p:cNvSpPr txBox="1"/>
           <p:nvPr/>
         </p:nvSpPr>
@@ -20149,7 +20414,7 @@
       </p:sp>
       <p:sp>
         <p:nvSpPr>
-          <p:cNvPr id="38" name="TextBox 37"/>
+          <p:cNvPr id="39" name="TextBox 38"/>
           <p:cNvSpPr txBox="1"/>
           <p:nvPr/>
         </p:nvSpPr>
@@ -20190,7 +20455,7 @@
       </p:sp>
       <p:sp>
         <p:nvSpPr>
-          <p:cNvPr id="39" name="Oval 38"/>
+          <p:cNvPr id="40" name="Oval 39"/>
           <p:cNvSpPr/>
           <p:nvPr/>
         </p:nvSpPr>
@@ -20219,7 +20484,7 @@
       </p:sp>
       <p:sp>
         <p:nvSpPr>
-          <p:cNvPr id="40" name="TextBox 39"/>
+          <p:cNvPr id="41" name="TextBox 40"/>
           <p:cNvSpPr txBox="1"/>
           <p:nvPr/>
         </p:nvSpPr>
@@ -20256,7 +20521,7 @@
       </p:sp>
       <p:sp>
         <p:nvSpPr>
-          <p:cNvPr id="41" name="TextBox 40"/>
+          <p:cNvPr id="42" name="TextBox 41"/>
           <p:cNvSpPr txBox="1"/>
           <p:nvPr/>
         </p:nvSpPr>
@@ -20293,7 +20558,7 @@
       </p:sp>
       <p:sp>
         <p:nvSpPr>
-          <p:cNvPr id="42" name="TextBox 41"/>
+          <p:cNvPr id="43" name="TextBox 42"/>
           <p:cNvSpPr txBox="1"/>
           <p:nvPr/>
         </p:nvSpPr>
@@ -20973,17 +21238,17 @@
         </p:nvSpPr>
         <p:spPr>
           <a:xfrm>
-            <a:off x="411480" y="402336"/>
-            <a:ext cx="822960" cy="640080"/>
-          </a:xfrm>
-        </p:spPr>
-        <p:txBody>
-          <a:bodyPr anchor="ctr" lIns="0"/>
+            <a:off x="384048" y="6455664"/>
+            <a:ext cx="731520" cy="237744"/>
+          </a:xfrm>
+        </p:spPr>
+        <p:txBody>
+          <a:bodyPr anchor="ctr" lIns="0" tIns="0" bIns="0"/>
           <a:lstStyle/>
           <a:p>
             <a:pPr algn="l"/>
             <a:fld id="{679EF615-E246-4FA6-9E75-123AAEB83405}" type="slidenum">
-              <a:rPr lang="en-US" smtClean="0" sz="1200" b="1">
+              <a:rPr lang="en-US" smtClean="0" sz="1050" b="1">
                 <a:solidFill>
                   <a:srgbClr val="2A206A"/>
                 </a:solidFill>
@@ -21000,6 +21265,43 @@
       <p:sp>
         <p:nvSpPr>
           <p:cNvPr id="81" name="TextBox 80"/>
+          <p:cNvSpPr txBox="1"/>
+          <p:nvPr/>
+        </p:nvSpPr>
+        <p:spPr>
+          <a:xfrm>
+            <a:off x="6583680" y="6254496"/>
+            <a:ext cx="5120640" cy="237744"/>
+          </a:xfrm>
+          <a:prstGeom prst="rect">
+            <a:avLst/>
+          </a:prstGeom>
+          <a:noFill/>
+        </p:spPr>
+        <p:txBody>
+          <a:bodyPr wrap="square" lIns="0" rIns="0" tIns="0" bIns="0" anchor="ctr">
+            <a:spAutoFit/>
+            <a:noAutofit/>
+          </a:bodyPr>
+          <a:lstStyle/>
+          <a:p>
+            <a:pPr algn="r" rtl="1"/>
+            <a:r>
+              <a:rPr lang="ar-SA" sz="900" b="0" dirty="0">
+                <a:solidFill>
+                  <a:srgbClr val="6E6E86"/>
+                </a:solidFill>
+                <a:latin typeface="DiodrumArabic-Regular" pitchFamily="2" charset="-78"/>
+                <a:cs typeface="DiodrumArabic-Regular" pitchFamily="2" charset="-78"/>
+              </a:rPr>
+              <a:t>برنامج القدرات الرقمية «قدراتك»   |   تقرير سير الأعمال الربعي – يونيو – أغسطس 2026</a:t>
+            </a:r>
+          </a:p>
+        </p:txBody>
+      </p:sp>
+      <p:sp>
+        <p:nvSpPr>
+          <p:cNvPr id="82" name="TextBox 81"/>
           <p:cNvSpPr txBox="1"/>
           <p:nvPr/>
         </p:nvSpPr>
@@ -21094,17 +21396,17 @@
         </p:nvSpPr>
         <p:spPr>
           <a:xfrm>
-            <a:off x="411480" y="155448"/>
-            <a:ext cx="822960" cy="548640"/>
-          </a:xfrm>
-        </p:spPr>
-        <p:txBody>
-          <a:bodyPr anchor="ctr" lIns="0"/>
+            <a:off x="384048" y="6455664"/>
+            <a:ext cx="731520" cy="237744"/>
+          </a:xfrm>
+        </p:spPr>
+        <p:txBody>
+          <a:bodyPr anchor="ctr" lIns="0" tIns="0" bIns="0"/>
           <a:lstStyle/>
           <a:p>
             <a:pPr algn="l"/>
             <a:fld id="{679EF615-E246-4FA6-9E75-123AAEB83405}" type="slidenum">
-              <a:rPr lang="en-US" smtClean="0" sz="1200" b="1">
+              <a:rPr lang="en-US" smtClean="0" sz="1050" b="1">
                 <a:solidFill>
                   <a:srgbClr val="2A206A"/>
                 </a:solidFill>
@@ -21126,8 +21428,8 @@
         </p:nvSpPr>
         <p:spPr>
           <a:xfrm>
-            <a:off x="1234440" y="155448"/>
-            <a:ext cx="10561320" cy="548640"/>
+            <a:off x="411480" y="155448"/>
+            <a:ext cx="11384280" cy="548640"/>
           </a:xfrm>
           <a:prstGeom prst="rect">
             <a:avLst/>
@@ -21165,9 +21467,46 @@
           </a:p>
         </p:txBody>
       </p:sp>
+      <p:sp>
+        <p:nvSpPr>
+          <p:cNvPr id="4" name="TextBox 3"/>
+          <p:cNvSpPr txBox="1"/>
+          <p:nvPr/>
+        </p:nvSpPr>
+        <p:spPr>
+          <a:xfrm>
+            <a:off x="6583680" y="6254496"/>
+            <a:ext cx="5120640" cy="237744"/>
+          </a:xfrm>
+          <a:prstGeom prst="rect">
+            <a:avLst/>
+          </a:prstGeom>
+          <a:noFill/>
+        </p:spPr>
+        <p:txBody>
+          <a:bodyPr wrap="square" lIns="0" rIns="0" tIns="0" bIns="0" anchor="ctr">
+            <a:spAutoFit/>
+            <a:noAutofit/>
+          </a:bodyPr>
+          <a:lstStyle/>
+          <a:p>
+            <a:pPr algn="r" rtl="1"/>
+            <a:r>
+              <a:rPr lang="ar-SA" sz="900" b="0" dirty="0">
+                <a:solidFill>
+                  <a:srgbClr val="6E6E86"/>
+                </a:solidFill>
+                <a:latin typeface="DiodrumArabic-Regular" pitchFamily="2" charset="-78"/>
+                <a:cs typeface="DiodrumArabic-Regular" pitchFamily="2" charset="-78"/>
+              </a:rPr>
+              <a:t>برنامج القدرات الرقمية «قدراتك»   |   تقرير سير الأعمال الربعي – يونيو – أغسطس 2026</a:t>
+            </a:r>
+          </a:p>
+        </p:txBody>
+      </p:sp>
       <p:cxnSp>
         <p:nvCxnSpPr>
-          <p:cNvPr id="4" name="Connector 3"/>
+          <p:cNvPr id="5" name="Connector 4"/>
           <p:cNvCxnSpPr/>
           <p:nvPr/>
         </p:nvCxnSpPr>
@@ -21196,7 +21535,7 @@
       </p:cxnSp>
       <p:sp>
         <p:nvSpPr>
-          <p:cNvPr id="5" name="TextBox 4"/>
+          <p:cNvPr id="6" name="TextBox 5"/>
           <p:cNvSpPr txBox="1"/>
           <p:nvPr/>
         </p:nvSpPr>
@@ -21233,7 +21572,7 @@
       </p:sp>
       <p:graphicFrame>
         <p:nvGraphicFramePr>
-          <p:cNvPr id="6" name="Table 5"/>
+          <p:cNvPr id="7" name="Table 6"/>
           <p:cNvGraphicFramePr>
             <a:graphicFrameLocks noGrp="1"/>
           </p:cNvGraphicFramePr>
@@ -22228,7 +22567,7 @@
       </p:graphicFrame>
       <p:sp>
         <p:nvSpPr>
-          <p:cNvPr id="7" name="Oval 6"/>
+          <p:cNvPr id="8" name="Oval 7"/>
           <p:cNvSpPr/>
           <p:nvPr/>
         </p:nvSpPr>
@@ -22257,7 +22596,7 @@
       </p:sp>
       <p:sp>
         <p:nvSpPr>
-          <p:cNvPr id="8" name="Oval 7"/>
+          <p:cNvPr id="9" name="Oval 8"/>
           <p:cNvSpPr/>
           <p:nvPr/>
         </p:nvSpPr>
@@ -22286,7 +22625,7 @@
       </p:sp>
       <p:sp>
         <p:nvSpPr>
-          <p:cNvPr id="9" name="Oval 8"/>
+          <p:cNvPr id="10" name="Oval 9"/>
           <p:cNvSpPr/>
           <p:nvPr/>
         </p:nvSpPr>
@@ -22315,7 +22654,7 @@
       </p:sp>
       <p:sp>
         <p:nvSpPr>
-          <p:cNvPr id="10" name="Rounded Rectangle 9"/>
+          <p:cNvPr id="11" name="Rounded Rectangle 10"/>
           <p:cNvSpPr/>
           <p:nvPr/>
         </p:nvSpPr>
@@ -22359,7 +22698,7 @@
       </p:sp>
       <p:sp>
         <p:nvSpPr>
-          <p:cNvPr id="11" name="TextBox 10"/>
+          <p:cNvPr id="12" name="TextBox 11"/>
           <p:cNvSpPr txBox="1"/>
           <p:nvPr/>
         </p:nvSpPr>
@@ -22396,7 +22735,7 @@
       </p:sp>
       <p:sp>
         <p:nvSpPr>
-          <p:cNvPr id="12" name="TextBox 11"/>
+          <p:cNvPr id="13" name="TextBox 12"/>
           <p:cNvSpPr txBox="1"/>
           <p:nvPr/>
         </p:nvSpPr>
@@ -23638,17 +23977,17 @@
         </p:nvSpPr>
         <p:spPr>
           <a:xfrm>
-            <a:off x="411480" y="402336"/>
-            <a:ext cx="822960" cy="640080"/>
-          </a:xfrm>
-        </p:spPr>
-        <p:txBody>
-          <a:bodyPr anchor="ctr" lIns="0"/>
+            <a:off x="384048" y="6455664"/>
+            <a:ext cx="731520" cy="237744"/>
+          </a:xfrm>
+        </p:spPr>
+        <p:txBody>
+          <a:bodyPr anchor="ctr" lIns="0" tIns="0" bIns="0"/>
           <a:lstStyle/>
           <a:p>
             <a:pPr algn="l"/>
             <a:fld id="{679EF615-E246-4FA6-9E75-123AAEB83405}" type="slidenum">
-              <a:rPr lang="en-US" smtClean="0" sz="1200" b="1">
+              <a:rPr lang="en-US" smtClean="0" sz="1050" b="1">
                 <a:solidFill>
                   <a:srgbClr val="2A206A"/>
                 </a:solidFill>
@@ -23665,6 +24004,43 @@
       <p:sp>
         <p:nvSpPr>
           <p:cNvPr id="81" name="TextBox 80"/>
+          <p:cNvSpPr txBox="1"/>
+          <p:nvPr/>
+        </p:nvSpPr>
+        <p:spPr>
+          <a:xfrm>
+            <a:off x="6583680" y="6254496"/>
+            <a:ext cx="5120640" cy="237744"/>
+          </a:xfrm>
+          <a:prstGeom prst="rect">
+            <a:avLst/>
+          </a:prstGeom>
+          <a:noFill/>
+        </p:spPr>
+        <p:txBody>
+          <a:bodyPr wrap="square" lIns="0" rIns="0" tIns="0" bIns="0" anchor="ctr">
+            <a:spAutoFit/>
+            <a:noAutofit/>
+          </a:bodyPr>
+          <a:lstStyle/>
+          <a:p>
+            <a:pPr algn="r" rtl="1"/>
+            <a:r>
+              <a:rPr lang="ar-SA" sz="900" b="0" dirty="0">
+                <a:solidFill>
+                  <a:srgbClr val="6E6E86"/>
+                </a:solidFill>
+                <a:latin typeface="DiodrumArabic-Regular" pitchFamily="2" charset="-78"/>
+                <a:cs typeface="DiodrumArabic-Regular" pitchFamily="2" charset="-78"/>
+              </a:rPr>
+              <a:t>برنامج القدرات الرقمية «قدراتك»   |   تقرير سير الأعمال الربعي – يونيو – أغسطس 2026</a:t>
+            </a:r>
+          </a:p>
+        </p:txBody>
+      </p:sp>
+      <p:sp>
+        <p:nvSpPr>
+          <p:cNvPr id="82" name="TextBox 81"/>
           <p:cNvSpPr txBox="1"/>
           <p:nvPr/>
         </p:nvSpPr>
@@ -23759,17 +24135,17 @@
         </p:nvSpPr>
         <p:spPr>
           <a:xfrm>
-            <a:off x="411480" y="155448"/>
-            <a:ext cx="822960" cy="548640"/>
-          </a:xfrm>
-        </p:spPr>
-        <p:txBody>
-          <a:bodyPr anchor="ctr" lIns="0"/>
+            <a:off x="384048" y="6455664"/>
+            <a:ext cx="731520" cy="237744"/>
+          </a:xfrm>
+        </p:spPr>
+        <p:txBody>
+          <a:bodyPr anchor="ctr" lIns="0" tIns="0" bIns="0"/>
           <a:lstStyle/>
           <a:p>
             <a:pPr algn="l"/>
             <a:fld id="{679EF615-E246-4FA6-9E75-123AAEB83405}" type="slidenum">
-              <a:rPr lang="en-US" smtClean="0" sz="1200" b="1">
+              <a:rPr lang="en-US" smtClean="0" sz="1050" b="1">
                 <a:solidFill>
                   <a:srgbClr val="2A206A"/>
                 </a:solidFill>
@@ -23791,8 +24167,8 @@
         </p:nvSpPr>
         <p:spPr>
           <a:xfrm>
-            <a:off x="1234440" y="155448"/>
-            <a:ext cx="10561320" cy="548640"/>
+            <a:off x="411480" y="155448"/>
+            <a:ext cx="11384280" cy="548640"/>
           </a:xfrm>
           <a:prstGeom prst="rect">
             <a:avLst/>
@@ -23830,9 +24206,46 @@
           </a:p>
         </p:txBody>
       </p:sp>
+      <p:sp>
+        <p:nvSpPr>
+          <p:cNvPr id="4" name="TextBox 3"/>
+          <p:cNvSpPr txBox="1"/>
+          <p:nvPr/>
+        </p:nvSpPr>
+        <p:spPr>
+          <a:xfrm>
+            <a:off x="6583680" y="6254496"/>
+            <a:ext cx="5120640" cy="237744"/>
+          </a:xfrm>
+          <a:prstGeom prst="rect">
+            <a:avLst/>
+          </a:prstGeom>
+          <a:noFill/>
+        </p:spPr>
+        <p:txBody>
+          <a:bodyPr wrap="square" lIns="0" rIns="0" tIns="0" bIns="0" anchor="ctr">
+            <a:spAutoFit/>
+            <a:noAutofit/>
+          </a:bodyPr>
+          <a:lstStyle/>
+          <a:p>
+            <a:pPr algn="r" rtl="1"/>
+            <a:r>
+              <a:rPr lang="ar-SA" sz="900" b="0" dirty="0">
+                <a:solidFill>
+                  <a:srgbClr val="6E6E86"/>
+                </a:solidFill>
+                <a:latin typeface="DiodrumArabic-Regular" pitchFamily="2" charset="-78"/>
+                <a:cs typeface="DiodrumArabic-Regular" pitchFamily="2" charset="-78"/>
+              </a:rPr>
+              <a:t>برنامج القدرات الرقمية «قدراتك»   |   تقرير سير الأعمال الربعي – يونيو – أغسطس 2026</a:t>
+            </a:r>
+          </a:p>
+        </p:txBody>
+      </p:sp>
       <p:cxnSp>
         <p:nvCxnSpPr>
-          <p:cNvPr id="4" name="Connector 3"/>
+          <p:cNvPr id="5" name="Connector 4"/>
           <p:cNvCxnSpPr/>
           <p:nvPr/>
         </p:nvCxnSpPr>
@@ -23861,7 +24274,7 @@
       </p:cxnSp>
       <p:sp>
         <p:nvSpPr>
-          <p:cNvPr id="5" name="TextBox 4"/>
+          <p:cNvPr id="6" name="TextBox 5"/>
           <p:cNvSpPr txBox="1"/>
           <p:nvPr/>
         </p:nvSpPr>
@@ -23898,7 +24311,7 @@
       </p:sp>
       <p:sp>
         <p:nvSpPr>
-          <p:cNvPr id="6" name="Rounded Rectangle 5"/>
+          <p:cNvPr id="7" name="Rounded Rectangle 6"/>
           <p:cNvSpPr/>
           <p:nvPr/>
         </p:nvSpPr>
@@ -23936,7 +24349,7 @@
       </p:sp>
       <p:sp>
         <p:nvSpPr>
-          <p:cNvPr id="7" name="TextBox 6"/>
+          <p:cNvPr id="8" name="TextBox 7"/>
           <p:cNvSpPr txBox="1"/>
           <p:nvPr/>
         </p:nvSpPr>
@@ -23973,7 +24386,7 @@
       </p:sp>
       <p:cxnSp>
         <p:nvCxnSpPr>
-          <p:cNvPr id="8" name="Connector 7"/>
+          <p:cNvPr id="9" name="Connector 8"/>
           <p:cNvCxnSpPr/>
           <p:nvPr/>
         </p:nvCxnSpPr>
@@ -23994,7 +24407,7 @@
       </p:cxnSp>
       <p:sp>
         <p:nvSpPr>
-          <p:cNvPr id="9" name="TextBox 8"/>
+          <p:cNvPr id="10" name="TextBox 9"/>
           <p:cNvSpPr txBox="1"/>
           <p:nvPr/>
         </p:nvSpPr>
@@ -24093,7 +24506,7 @@
       </p:sp>
       <p:sp>
         <p:nvSpPr>
-          <p:cNvPr id="10" name="Rounded Rectangle 9"/>
+          <p:cNvPr id="11" name="Rounded Rectangle 10"/>
           <p:cNvSpPr/>
           <p:nvPr/>
         </p:nvSpPr>
@@ -24124,7 +24537,7 @@
       </p:sp>
       <p:sp>
         <p:nvSpPr>
-          <p:cNvPr id="11" name="TextBox 10"/>
+          <p:cNvPr id="12" name="TextBox 11"/>
           <p:cNvSpPr txBox="1"/>
           <p:nvPr/>
         </p:nvSpPr>
@@ -24175,7 +24588,7 @@
       </p:sp>
       <p:sp>
         <p:nvSpPr>
-          <p:cNvPr id="12" name="Rounded Rectangle 11"/>
+          <p:cNvPr id="13" name="Rounded Rectangle 12"/>
           <p:cNvSpPr/>
           <p:nvPr/>
         </p:nvSpPr>
@@ -24213,7 +24626,7 @@
       </p:sp>
       <p:sp>
         <p:nvSpPr>
-          <p:cNvPr id="13" name="TextBox 12"/>
+          <p:cNvPr id="14" name="TextBox 13"/>
           <p:cNvSpPr txBox="1"/>
           <p:nvPr/>
         </p:nvSpPr>
@@ -24250,7 +24663,7 @@
       </p:sp>
       <p:cxnSp>
         <p:nvCxnSpPr>
-          <p:cNvPr id="14" name="Connector 13"/>
+          <p:cNvPr id="15" name="Connector 14"/>
           <p:cNvCxnSpPr/>
           <p:nvPr/>
         </p:nvCxnSpPr>
@@ -24271,7 +24684,7 @@
       </p:cxnSp>
       <p:sp>
         <p:nvSpPr>
-          <p:cNvPr id="15" name="TextBox 14"/>
+          <p:cNvPr id="16" name="TextBox 15"/>
           <p:cNvSpPr txBox="1"/>
           <p:nvPr/>
         </p:nvSpPr>
@@ -24345,7 +24758,7 @@
       </p:sp>
       <p:sp>
         <p:nvSpPr>
-          <p:cNvPr id="16" name="Rounded Rectangle 15"/>
+          <p:cNvPr id="17" name="Rounded Rectangle 16"/>
           <p:cNvSpPr/>
           <p:nvPr/>
         </p:nvSpPr>
@@ -24376,7 +24789,7 @@
       </p:sp>
       <p:sp>
         <p:nvSpPr>
-          <p:cNvPr id="17" name="TextBox 16"/>
+          <p:cNvPr id="18" name="TextBox 17"/>
           <p:cNvSpPr txBox="1"/>
           <p:nvPr/>
         </p:nvSpPr>
@@ -24427,7 +24840,7 @@
       </p:sp>
       <p:sp>
         <p:nvSpPr>
-          <p:cNvPr id="18" name="Rounded Rectangle 17"/>
+          <p:cNvPr id="19" name="Rounded Rectangle 18"/>
           <p:cNvSpPr/>
           <p:nvPr/>
         </p:nvSpPr>
@@ -24465,7 +24878,7 @@
       </p:sp>
       <p:sp>
         <p:nvSpPr>
-          <p:cNvPr id="19" name="TextBox 18"/>
+          <p:cNvPr id="20" name="TextBox 19"/>
           <p:cNvSpPr txBox="1"/>
           <p:nvPr/>
         </p:nvSpPr>
@@ -24502,7 +24915,7 @@
       </p:sp>
       <p:cxnSp>
         <p:nvCxnSpPr>
-          <p:cNvPr id="20" name="Connector 19"/>
+          <p:cNvPr id="21" name="Connector 20"/>
           <p:cNvCxnSpPr/>
           <p:nvPr/>
         </p:nvCxnSpPr>
@@ -24523,7 +24936,7 @@
       </p:cxnSp>
       <p:sp>
         <p:nvSpPr>
-          <p:cNvPr id="21" name="TextBox 20"/>
+          <p:cNvPr id="22" name="TextBox 21"/>
           <p:cNvSpPr txBox="1"/>
           <p:nvPr/>
         </p:nvSpPr>
@@ -24597,7 +25010,7 @@
       </p:sp>
       <p:sp>
         <p:nvSpPr>
-          <p:cNvPr id="22" name="Rounded Rectangle 21"/>
+          <p:cNvPr id="23" name="Rounded Rectangle 22"/>
           <p:cNvSpPr/>
           <p:nvPr/>
         </p:nvSpPr>
@@ -24628,7 +25041,7 @@
       </p:sp>
       <p:sp>
         <p:nvSpPr>
-          <p:cNvPr id="23" name="TextBox 22"/>
+          <p:cNvPr id="24" name="TextBox 23"/>
           <p:cNvSpPr txBox="1"/>
           <p:nvPr/>
         </p:nvSpPr>
@@ -24679,7 +25092,7 @@
       </p:sp>
       <p:sp>
         <p:nvSpPr>
-          <p:cNvPr id="24" name="Rounded Rectangle 23"/>
+          <p:cNvPr id="25" name="Rounded Rectangle 24"/>
           <p:cNvSpPr/>
           <p:nvPr/>
         </p:nvSpPr>
@@ -24717,7 +25130,7 @@
       </p:sp>
       <p:sp>
         <p:nvSpPr>
-          <p:cNvPr id="25" name="TextBox 24"/>
+          <p:cNvPr id="26" name="TextBox 25"/>
           <p:cNvSpPr txBox="1"/>
           <p:nvPr/>
         </p:nvSpPr>
@@ -24754,7 +25167,7 @@
       </p:sp>
       <p:cxnSp>
         <p:nvCxnSpPr>
-          <p:cNvPr id="26" name="Connector 25"/>
+          <p:cNvPr id="27" name="Connector 26"/>
           <p:cNvCxnSpPr/>
           <p:nvPr/>
         </p:nvCxnSpPr>
@@ -24775,7 +25188,7 @@
       </p:cxnSp>
       <p:sp>
         <p:nvSpPr>
-          <p:cNvPr id="27" name="TextBox 26"/>
+          <p:cNvPr id="28" name="TextBox 27"/>
           <p:cNvSpPr txBox="1"/>
           <p:nvPr/>
         </p:nvSpPr>
@@ -24874,7 +25287,7 @@
       </p:sp>
       <p:sp>
         <p:nvSpPr>
-          <p:cNvPr id="28" name="Rounded Rectangle 27"/>
+          <p:cNvPr id="29" name="Rounded Rectangle 28"/>
           <p:cNvSpPr/>
           <p:nvPr/>
         </p:nvSpPr>
@@ -24905,7 +25318,7 @@
       </p:sp>
       <p:sp>
         <p:nvSpPr>
-          <p:cNvPr id="29" name="TextBox 28"/>
+          <p:cNvPr id="30" name="TextBox 29"/>
           <p:cNvSpPr txBox="1"/>
           <p:nvPr/>
         </p:nvSpPr>
@@ -24956,7 +25369,7 @@
       </p:sp>
       <p:sp>
         <p:nvSpPr>
-          <p:cNvPr id="30" name="TextBox 29"/>
+          <p:cNvPr id="31" name="TextBox 30"/>
           <p:cNvSpPr txBox="1"/>
           <p:nvPr/>
         </p:nvSpPr>
@@ -24993,7 +25406,7 @@
       </p:sp>
       <p:sp>
         <p:nvSpPr>
-          <p:cNvPr id="31" name="Rounded Rectangle 30"/>
+          <p:cNvPr id="32" name="Rounded Rectangle 31"/>
           <p:cNvSpPr/>
           <p:nvPr/>
         </p:nvSpPr>
@@ -25024,7 +25437,7 @@
       </p:sp>
       <p:sp>
         <p:nvSpPr>
-          <p:cNvPr id="32" name="TextBox 31"/>
+          <p:cNvPr id="33" name="TextBox 32"/>
           <p:cNvSpPr txBox="1"/>
           <p:nvPr/>
         </p:nvSpPr>
@@ -25061,7 +25474,7 @@
       </p:sp>
       <p:sp>
         <p:nvSpPr>
-          <p:cNvPr id="33" name="TextBox 32"/>
+          <p:cNvPr id="34" name="TextBox 33"/>
           <p:cNvSpPr txBox="1"/>
           <p:nvPr/>
         </p:nvSpPr>
@@ -25102,7 +25515,7 @@
       </p:sp>
       <p:sp>
         <p:nvSpPr>
-          <p:cNvPr id="34" name="Rounded Rectangle 33"/>
+          <p:cNvPr id="35" name="Rounded Rectangle 34"/>
           <p:cNvSpPr/>
           <p:nvPr/>
         </p:nvSpPr>
@@ -25133,7 +25546,7 @@
       </p:sp>
       <p:sp>
         <p:nvSpPr>
-          <p:cNvPr id="35" name="TextBox 34"/>
+          <p:cNvPr id="36" name="TextBox 35"/>
           <p:cNvSpPr txBox="1"/>
           <p:nvPr/>
         </p:nvSpPr>
@@ -25170,7 +25583,7 @@
       </p:sp>
       <p:sp>
         <p:nvSpPr>
-          <p:cNvPr id="36" name="TextBox 35"/>
+          <p:cNvPr id="37" name="TextBox 36"/>
           <p:cNvSpPr txBox="1"/>
           <p:nvPr/>
         </p:nvSpPr>
@@ -25211,7 +25624,7 @@
       </p:sp>
       <p:sp>
         <p:nvSpPr>
-          <p:cNvPr id="37" name="Rounded Rectangle 36"/>
+          <p:cNvPr id="38" name="Rounded Rectangle 37"/>
           <p:cNvSpPr/>
           <p:nvPr/>
         </p:nvSpPr>
@@ -25242,7 +25655,7 @@
       </p:sp>
       <p:sp>
         <p:nvSpPr>
-          <p:cNvPr id="38" name="TextBox 37"/>
+          <p:cNvPr id="39" name="TextBox 38"/>
           <p:cNvSpPr txBox="1"/>
           <p:nvPr/>
         </p:nvSpPr>
@@ -25279,7 +25692,7 @@
       </p:sp>
       <p:sp>
         <p:nvSpPr>
-          <p:cNvPr id="39" name="TextBox 38"/>
+          <p:cNvPr id="40" name="TextBox 39"/>
           <p:cNvSpPr txBox="1"/>
           <p:nvPr/>
         </p:nvSpPr>
@@ -25320,7 +25733,7 @@
       </p:sp>
       <p:sp>
         <p:nvSpPr>
-          <p:cNvPr id="40" name="Rounded Rectangle 39"/>
+          <p:cNvPr id="41" name="Rounded Rectangle 40"/>
           <p:cNvSpPr/>
           <p:nvPr/>
         </p:nvSpPr>
@@ -25351,7 +25764,7 @@
       </p:sp>
       <p:sp>
         <p:nvSpPr>
-          <p:cNvPr id="41" name="TextBox 40"/>
+          <p:cNvPr id="42" name="TextBox 41"/>
           <p:cNvSpPr txBox="1"/>
           <p:nvPr/>
         </p:nvSpPr>
@@ -25388,7 +25801,7 @@
       </p:sp>
       <p:sp>
         <p:nvSpPr>
-          <p:cNvPr id="42" name="TextBox 41"/>
+          <p:cNvPr id="43" name="TextBox 42"/>
           <p:cNvSpPr txBox="1"/>
           <p:nvPr/>
         </p:nvSpPr>
@@ -25562,17 +25975,17 @@
         </p:nvSpPr>
         <p:spPr>
           <a:xfrm>
-            <a:off x="411480" y="155448"/>
-            <a:ext cx="822960" cy="548640"/>
-          </a:xfrm>
-        </p:spPr>
-        <p:txBody>
-          <a:bodyPr anchor="ctr" lIns="0"/>
+            <a:off x="384048" y="6455664"/>
+            <a:ext cx="731520" cy="237744"/>
+          </a:xfrm>
+        </p:spPr>
+        <p:txBody>
+          <a:bodyPr anchor="ctr" lIns="0" tIns="0" bIns="0"/>
           <a:lstStyle/>
           <a:p>
             <a:pPr algn="l"/>
             <a:fld id="{679EF615-E246-4FA6-9E75-123AAEB83405}" type="slidenum">
-              <a:rPr lang="en-US" smtClean="0" sz="1200" b="1">
+              <a:rPr lang="en-US" smtClean="0" sz="1050" b="1">
                 <a:solidFill>
                   <a:srgbClr val="2A206A"/>
                 </a:solidFill>
@@ -25594,8 +26007,8 @@
         </p:nvSpPr>
         <p:spPr>
           <a:xfrm>
-            <a:off x="1234440" y="155448"/>
-            <a:ext cx="10561320" cy="548640"/>
+            <a:off x="411480" y="155448"/>
+            <a:ext cx="11384280" cy="548640"/>
           </a:xfrm>
           <a:prstGeom prst="rect">
             <a:avLst/>
@@ -25623,9 +26036,46 @@
           </a:p>
         </p:txBody>
       </p:sp>
+      <p:sp>
+        <p:nvSpPr>
+          <p:cNvPr id="4" name="TextBox 3"/>
+          <p:cNvSpPr txBox="1"/>
+          <p:nvPr/>
+        </p:nvSpPr>
+        <p:spPr>
+          <a:xfrm>
+            <a:off x="6583680" y="6254496"/>
+            <a:ext cx="5120640" cy="237744"/>
+          </a:xfrm>
+          <a:prstGeom prst="rect">
+            <a:avLst/>
+          </a:prstGeom>
+          <a:noFill/>
+        </p:spPr>
+        <p:txBody>
+          <a:bodyPr wrap="square" lIns="0" rIns="0" tIns="0" bIns="0" anchor="ctr">
+            <a:spAutoFit/>
+            <a:noAutofit/>
+          </a:bodyPr>
+          <a:lstStyle/>
+          <a:p>
+            <a:pPr algn="r" rtl="1"/>
+            <a:r>
+              <a:rPr lang="ar-SA" sz="900" b="0" dirty="0">
+                <a:solidFill>
+                  <a:srgbClr val="6E6E86"/>
+                </a:solidFill>
+                <a:latin typeface="DiodrumArabic-Regular" pitchFamily="2" charset="-78"/>
+                <a:cs typeface="DiodrumArabic-Regular" pitchFamily="2" charset="-78"/>
+              </a:rPr>
+              <a:t>برنامج القدرات الرقمية «قدراتك»   |   تقرير سير الأعمال الربعي – يونيو – أغسطس 2026</a:t>
+            </a:r>
+          </a:p>
+        </p:txBody>
+      </p:sp>
       <p:cxnSp>
         <p:nvCxnSpPr>
-          <p:cNvPr id="4" name="Connector 3"/>
+          <p:cNvPr id="5" name="Connector 4"/>
           <p:cNvCxnSpPr/>
           <p:nvPr/>
         </p:nvCxnSpPr>
@@ -25654,7 +26104,7 @@
       </p:cxnSp>
       <p:sp>
         <p:nvSpPr>
-          <p:cNvPr id="5" name="TextBox 4"/>
+          <p:cNvPr id="6" name="TextBox 5"/>
           <p:cNvSpPr txBox="1"/>
           <p:nvPr/>
         </p:nvSpPr>
@@ -25691,7 +26141,7 @@
       </p:sp>
       <p:sp>
         <p:nvSpPr>
-          <p:cNvPr id="6" name="Rounded Rectangle 5"/>
+          <p:cNvPr id="7" name="Rounded Rectangle 6"/>
           <p:cNvSpPr/>
           <p:nvPr/>
         </p:nvSpPr>
@@ -25729,7 +26179,7 @@
       </p:sp>
       <p:sp>
         <p:nvSpPr>
-          <p:cNvPr id="7" name="TextBox 6"/>
+          <p:cNvPr id="8" name="TextBox 7"/>
           <p:cNvSpPr txBox="1"/>
           <p:nvPr/>
         </p:nvSpPr>
@@ -25766,7 +26216,7 @@
       </p:sp>
       <p:sp>
         <p:nvSpPr>
-          <p:cNvPr id="8" name="TextBox 7"/>
+          <p:cNvPr id="9" name="TextBox 8"/>
           <p:cNvSpPr txBox="1"/>
           <p:nvPr/>
         </p:nvSpPr>
@@ -25803,7 +26253,7 @@
       </p:sp>
       <p:sp>
         <p:nvSpPr>
-          <p:cNvPr id="9" name="TextBox 8"/>
+          <p:cNvPr id="10" name="TextBox 9"/>
           <p:cNvSpPr txBox="1"/>
           <p:nvPr/>
         </p:nvSpPr>
@@ -25840,7 +26290,7 @@
       </p:sp>
       <p:sp>
         <p:nvSpPr>
-          <p:cNvPr id="10" name="Rounded Rectangle 9"/>
+          <p:cNvPr id="11" name="Rounded Rectangle 10"/>
           <p:cNvSpPr/>
           <p:nvPr/>
         </p:nvSpPr>
@@ -25878,7 +26328,7 @@
       </p:sp>
       <p:sp>
         <p:nvSpPr>
-          <p:cNvPr id="11" name="TextBox 10"/>
+          <p:cNvPr id="12" name="TextBox 11"/>
           <p:cNvSpPr txBox="1"/>
           <p:nvPr/>
         </p:nvSpPr>
@@ -25915,7 +26365,7 @@
       </p:sp>
       <p:sp>
         <p:nvSpPr>
-          <p:cNvPr id="12" name="TextBox 11"/>
+          <p:cNvPr id="13" name="TextBox 12"/>
           <p:cNvSpPr txBox="1"/>
           <p:nvPr/>
         </p:nvSpPr>
@@ -25952,7 +26402,7 @@
       </p:sp>
       <p:sp>
         <p:nvSpPr>
-          <p:cNvPr id="13" name="TextBox 12"/>
+          <p:cNvPr id="14" name="TextBox 13"/>
           <p:cNvSpPr txBox="1"/>
           <p:nvPr/>
         </p:nvSpPr>
@@ -25989,7 +26439,7 @@
       </p:sp>
       <p:sp>
         <p:nvSpPr>
-          <p:cNvPr id="14" name="Rounded Rectangle 13"/>
+          <p:cNvPr id="15" name="Rounded Rectangle 14"/>
           <p:cNvSpPr/>
           <p:nvPr/>
         </p:nvSpPr>
@@ -26027,7 +26477,7 @@
       </p:sp>
       <p:sp>
         <p:nvSpPr>
-          <p:cNvPr id="15" name="TextBox 14"/>
+          <p:cNvPr id="16" name="TextBox 15"/>
           <p:cNvSpPr txBox="1"/>
           <p:nvPr/>
         </p:nvSpPr>
@@ -26064,7 +26514,7 @@
       </p:sp>
       <p:sp>
         <p:nvSpPr>
-          <p:cNvPr id="16" name="TextBox 15"/>
+          <p:cNvPr id="17" name="TextBox 16"/>
           <p:cNvSpPr txBox="1"/>
           <p:nvPr/>
         </p:nvSpPr>
@@ -26101,7 +26551,7 @@
       </p:sp>
       <p:sp>
         <p:nvSpPr>
-          <p:cNvPr id="17" name="TextBox 16"/>
+          <p:cNvPr id="18" name="TextBox 17"/>
           <p:cNvSpPr txBox="1"/>
           <p:nvPr/>
         </p:nvSpPr>
@@ -26138,7 +26588,7 @@
       </p:sp>
       <p:sp>
         <p:nvSpPr>
-          <p:cNvPr id="18" name="Rounded Rectangle 17"/>
+          <p:cNvPr id="19" name="Rounded Rectangle 18"/>
           <p:cNvSpPr/>
           <p:nvPr/>
         </p:nvSpPr>
@@ -26176,7 +26626,7 @@
       </p:sp>
       <p:sp>
         <p:nvSpPr>
-          <p:cNvPr id="19" name="TextBox 18"/>
+          <p:cNvPr id="20" name="TextBox 19"/>
           <p:cNvSpPr txBox="1"/>
           <p:nvPr/>
         </p:nvSpPr>
@@ -26213,7 +26663,7 @@
       </p:sp>
       <p:sp>
         <p:nvSpPr>
-          <p:cNvPr id="20" name="TextBox 19"/>
+          <p:cNvPr id="21" name="TextBox 20"/>
           <p:cNvSpPr txBox="1"/>
           <p:nvPr/>
         </p:nvSpPr>
@@ -26250,7 +26700,7 @@
       </p:sp>
       <p:sp>
         <p:nvSpPr>
-          <p:cNvPr id="21" name="TextBox 20"/>
+          <p:cNvPr id="22" name="TextBox 21"/>
           <p:cNvSpPr txBox="1"/>
           <p:nvPr/>
         </p:nvSpPr>
@@ -26287,7 +26737,7 @@
       </p:sp>
       <p:sp>
         <p:nvSpPr>
-          <p:cNvPr id="22" name="Rounded Rectangle 21"/>
+          <p:cNvPr id="23" name="Rounded Rectangle 22"/>
           <p:cNvSpPr/>
           <p:nvPr/>
         </p:nvSpPr>
@@ -26331,7 +26781,7 @@
       </p:sp>
       <p:sp>
         <p:nvSpPr>
-          <p:cNvPr id="23" name="TextBox 22"/>
+          <p:cNvPr id="24" name="TextBox 23"/>
           <p:cNvSpPr txBox="1"/>
           <p:nvPr/>
         </p:nvSpPr>
@@ -26368,7 +26818,7 @@
       </p:sp>
       <p:sp>
         <p:nvSpPr>
-          <p:cNvPr id="24" name="TextBox 23"/>
+          <p:cNvPr id="25" name="TextBox 24"/>
           <p:cNvSpPr txBox="1"/>
           <p:nvPr/>
         </p:nvSpPr>
@@ -26432,7 +26882,7 @@
       </p:sp>
       <p:sp>
         <p:nvSpPr>
-          <p:cNvPr id="25" name="TextBox 24"/>
+          <p:cNvPr id="26" name="TextBox 25"/>
           <p:cNvSpPr txBox="1"/>
           <p:nvPr/>
         </p:nvSpPr>
@@ -26469,7 +26919,7 @@
       </p:sp>
       <p:graphicFrame>
         <p:nvGraphicFramePr>
-          <p:cNvPr id="26" name="Table 25"/>
+          <p:cNvPr id="27" name="Table 26"/>
           <p:cNvGraphicFramePr>
             <a:graphicFrameLocks noGrp="1"/>
           </p:cNvGraphicFramePr>
@@ -27271,7 +27721,7 @@
       </p:graphicFrame>
       <p:sp>
         <p:nvSpPr>
-          <p:cNvPr id="27" name="Oval 26"/>
+          <p:cNvPr id="28" name="Oval 27"/>
           <p:cNvSpPr/>
           <p:nvPr/>
         </p:nvSpPr>
@@ -27300,7 +27750,7 @@
       </p:sp>
       <p:sp>
         <p:nvSpPr>
-          <p:cNvPr id="28" name="Oval 27"/>
+          <p:cNvPr id="29" name="Oval 28"/>
           <p:cNvSpPr/>
           <p:nvPr/>
         </p:nvSpPr>
@@ -27329,7 +27779,7 @@
       </p:sp>
       <p:sp>
         <p:nvSpPr>
-          <p:cNvPr id="29" name="Oval 28"/>
+          <p:cNvPr id="30" name="Oval 29"/>
           <p:cNvSpPr/>
           <p:nvPr/>
         </p:nvSpPr>
@@ -27971,17 +28421,17 @@
         </p:nvSpPr>
         <p:spPr>
           <a:xfrm>
-            <a:off x="411480" y="402336"/>
-            <a:ext cx="822960" cy="640080"/>
-          </a:xfrm>
-        </p:spPr>
-        <p:txBody>
-          <a:bodyPr anchor="ctr" lIns="0"/>
+            <a:off x="384048" y="6455664"/>
+            <a:ext cx="731520" cy="237744"/>
+          </a:xfrm>
+        </p:spPr>
+        <p:txBody>
+          <a:bodyPr anchor="ctr" lIns="0" tIns="0" bIns="0"/>
           <a:lstStyle/>
           <a:p>
             <a:pPr algn="l"/>
             <a:fld id="{679EF615-E246-4FA6-9E75-123AAEB83405}" type="slidenum">
-              <a:rPr lang="en-US" smtClean="0" sz="1200" b="1">
+              <a:rPr lang="en-US" smtClean="0" sz="1050" b="1">
                 <a:solidFill>
                   <a:srgbClr val="2A206A"/>
                 </a:solidFill>
@@ -27998,6 +28448,43 @@
       <p:sp>
         <p:nvSpPr>
           <p:cNvPr id="81" name="TextBox 80"/>
+          <p:cNvSpPr txBox="1"/>
+          <p:nvPr/>
+        </p:nvSpPr>
+        <p:spPr>
+          <a:xfrm>
+            <a:off x="6583680" y="6254496"/>
+            <a:ext cx="5120640" cy="237744"/>
+          </a:xfrm>
+          <a:prstGeom prst="rect">
+            <a:avLst/>
+          </a:prstGeom>
+          <a:noFill/>
+        </p:spPr>
+        <p:txBody>
+          <a:bodyPr wrap="square" lIns="0" rIns="0" tIns="0" bIns="0" anchor="ctr">
+            <a:spAutoFit/>
+            <a:noAutofit/>
+          </a:bodyPr>
+          <a:lstStyle/>
+          <a:p>
+            <a:pPr algn="r" rtl="1"/>
+            <a:r>
+              <a:rPr lang="ar-SA" sz="900" b="0" dirty="0">
+                <a:solidFill>
+                  <a:srgbClr val="6E6E86"/>
+                </a:solidFill>
+                <a:latin typeface="DiodrumArabic-Regular" pitchFamily="2" charset="-78"/>
+                <a:cs typeface="DiodrumArabic-Regular" pitchFamily="2" charset="-78"/>
+              </a:rPr>
+              <a:t>برنامج القدرات الرقمية «قدراتك»   |   تقرير سير الأعمال الربعي – يونيو – أغسطس 2026</a:t>
+            </a:r>
+          </a:p>
+        </p:txBody>
+      </p:sp>
+      <p:sp>
+        <p:nvSpPr>
+          <p:cNvPr id="82" name="TextBox 81"/>
           <p:cNvSpPr txBox="1"/>
           <p:nvPr/>
         </p:nvSpPr>
@@ -28092,17 +28579,17 @@
         </p:nvSpPr>
         <p:spPr>
           <a:xfrm>
-            <a:off x="411480" y="155448"/>
-            <a:ext cx="822960" cy="548640"/>
-          </a:xfrm>
-        </p:spPr>
-        <p:txBody>
-          <a:bodyPr anchor="ctr" lIns="0"/>
+            <a:off x="384048" y="6455664"/>
+            <a:ext cx="731520" cy="237744"/>
+          </a:xfrm>
+        </p:spPr>
+        <p:txBody>
+          <a:bodyPr anchor="ctr" lIns="0" tIns="0" bIns="0"/>
           <a:lstStyle/>
           <a:p>
             <a:pPr algn="l"/>
             <a:fld id="{679EF615-E246-4FA6-9E75-123AAEB83405}" type="slidenum">
-              <a:rPr lang="en-US" smtClean="0" sz="1200" b="1">
+              <a:rPr lang="en-US" smtClean="0" sz="1050" b="1">
                 <a:solidFill>
                   <a:srgbClr val="2A206A"/>
                 </a:solidFill>
@@ -28124,8 +28611,8 @@
         </p:nvSpPr>
         <p:spPr>
           <a:xfrm>
-            <a:off x="1234440" y="155448"/>
-            <a:ext cx="10561320" cy="548640"/>
+            <a:off x="411480" y="155448"/>
+            <a:ext cx="11384280" cy="548640"/>
           </a:xfrm>
           <a:prstGeom prst="rect">
             <a:avLst/>
@@ -28163,9 +28650,46 @@
           </a:p>
         </p:txBody>
       </p:sp>
+      <p:sp>
+        <p:nvSpPr>
+          <p:cNvPr id="4" name="TextBox 3"/>
+          <p:cNvSpPr txBox="1"/>
+          <p:nvPr/>
+        </p:nvSpPr>
+        <p:spPr>
+          <a:xfrm>
+            <a:off x="6583680" y="6254496"/>
+            <a:ext cx="5120640" cy="237744"/>
+          </a:xfrm>
+          <a:prstGeom prst="rect">
+            <a:avLst/>
+          </a:prstGeom>
+          <a:noFill/>
+        </p:spPr>
+        <p:txBody>
+          <a:bodyPr wrap="square" lIns="0" rIns="0" tIns="0" bIns="0" anchor="ctr">
+            <a:spAutoFit/>
+            <a:noAutofit/>
+          </a:bodyPr>
+          <a:lstStyle/>
+          <a:p>
+            <a:pPr algn="r" rtl="1"/>
+            <a:r>
+              <a:rPr lang="ar-SA" sz="900" b="0" dirty="0">
+                <a:solidFill>
+                  <a:srgbClr val="6E6E86"/>
+                </a:solidFill>
+                <a:latin typeface="DiodrumArabic-Regular" pitchFamily="2" charset="-78"/>
+                <a:cs typeface="DiodrumArabic-Regular" pitchFamily="2" charset="-78"/>
+              </a:rPr>
+              <a:t>برنامج القدرات الرقمية «قدراتك»   |   تقرير سير الأعمال الربعي – يونيو – أغسطس 2026</a:t>
+            </a:r>
+          </a:p>
+        </p:txBody>
+      </p:sp>
       <p:cxnSp>
         <p:nvCxnSpPr>
-          <p:cNvPr id="4" name="Connector 3"/>
+          <p:cNvPr id="5" name="Connector 4"/>
           <p:cNvCxnSpPr/>
           <p:nvPr/>
         </p:nvCxnSpPr>
@@ -28194,7 +28718,7 @@
       </p:cxnSp>
       <p:sp>
         <p:nvSpPr>
-          <p:cNvPr id="5" name="TextBox 4"/>
+          <p:cNvPr id="6" name="TextBox 5"/>
           <p:cNvSpPr txBox="1"/>
           <p:nvPr/>
         </p:nvSpPr>
@@ -28231,7 +28755,7 @@
       </p:sp>
       <p:sp>
         <p:nvSpPr>
-          <p:cNvPr id="6" name="Rounded Rectangle 5"/>
+          <p:cNvPr id="7" name="Rounded Rectangle 6"/>
           <p:cNvSpPr/>
           <p:nvPr/>
         </p:nvSpPr>
@@ -28275,7 +28799,7 @@
       </p:sp>
       <p:sp>
         <p:nvSpPr>
-          <p:cNvPr id="7" name="TextBox 6"/>
+          <p:cNvPr id="8" name="TextBox 7"/>
           <p:cNvSpPr txBox="1"/>
           <p:nvPr/>
         </p:nvSpPr>
@@ -28312,7 +28836,7 @@
       </p:sp>
       <p:sp>
         <p:nvSpPr>
-          <p:cNvPr id="8" name="TextBox 7"/>
+          <p:cNvPr id="9" name="TextBox 8"/>
           <p:cNvSpPr txBox="1"/>
           <p:nvPr/>
         </p:nvSpPr>
@@ -28349,7 +28873,7 @@
       </p:sp>
       <p:sp>
         <p:nvSpPr>
-          <p:cNvPr id="9" name="TextBox 8"/>
+          <p:cNvPr id="10" name="TextBox 9"/>
           <p:cNvSpPr txBox="1"/>
           <p:nvPr/>
         </p:nvSpPr>
@@ -28407,7 +28931,7 @@
       </p:sp>
       <p:sp>
         <p:nvSpPr>
-          <p:cNvPr id="10" name="Rounded Rectangle 9"/>
+          <p:cNvPr id="11" name="Rounded Rectangle 10"/>
           <p:cNvSpPr/>
           <p:nvPr/>
         </p:nvSpPr>
@@ -28438,7 +28962,7 @@
       </p:sp>
       <p:sp>
         <p:nvSpPr>
-          <p:cNvPr id="11" name="Rounded Rectangle 10"/>
+          <p:cNvPr id="12" name="Rounded Rectangle 11"/>
           <p:cNvSpPr/>
           <p:nvPr/>
         </p:nvSpPr>
@@ -28467,7 +28991,7 @@
       </p:sp>
       <p:sp>
         <p:nvSpPr>
-          <p:cNvPr id="12" name="TextBox 11"/>
+          <p:cNvPr id="13" name="TextBox 12"/>
           <p:cNvSpPr txBox="1"/>
           <p:nvPr/>
         </p:nvSpPr>
@@ -28504,7 +29028,7 @@
       </p:sp>
       <p:cxnSp>
         <p:nvCxnSpPr>
-          <p:cNvPr id="13" name="Connector 12"/>
+          <p:cNvPr id="14" name="Connector 13"/>
           <p:cNvCxnSpPr/>
           <p:nvPr/>
         </p:nvCxnSpPr>
@@ -28525,7 +29049,7 @@
       </p:cxnSp>
       <p:sp>
         <p:nvSpPr>
-          <p:cNvPr id="14" name="TextBox 13"/>
+          <p:cNvPr id="15" name="TextBox 14"/>
           <p:cNvSpPr txBox="1"/>
           <p:nvPr/>
         </p:nvSpPr>
@@ -28562,7 +29086,7 @@
       </p:sp>
       <p:sp>
         <p:nvSpPr>
-          <p:cNvPr id="15" name="TextBox 14"/>
+          <p:cNvPr id="16" name="TextBox 15"/>
           <p:cNvSpPr txBox="1"/>
           <p:nvPr/>
         </p:nvSpPr>
@@ -28599,7 +29123,7 @@
       </p:sp>
       <p:sp>
         <p:nvSpPr>
-          <p:cNvPr id="16" name="TextBox 15"/>
+          <p:cNvPr id="17" name="TextBox 16"/>
           <p:cNvSpPr txBox="1"/>
           <p:nvPr/>
         </p:nvSpPr>
@@ -28657,7 +29181,7 @@
       </p:sp>
       <p:sp>
         <p:nvSpPr>
-          <p:cNvPr id="17" name="Rounded Rectangle 16"/>
+          <p:cNvPr id="18" name="Rounded Rectangle 17"/>
           <p:cNvSpPr/>
           <p:nvPr/>
         </p:nvSpPr>
@@ -28700,7 +29224,7 @@
       </p:sp>
       <p:sp>
         <p:nvSpPr>
-          <p:cNvPr id="18" name="Rounded Rectangle 17"/>
+          <p:cNvPr id="19" name="Rounded Rectangle 18"/>
           <p:cNvSpPr/>
           <p:nvPr/>
         </p:nvSpPr>
@@ -28743,7 +29267,7 @@
       </p:sp>
       <p:cxnSp>
         <p:nvCxnSpPr>
-          <p:cNvPr id="19" name="Connector 18"/>
+          <p:cNvPr id="20" name="Connector 19"/>
           <p:cNvCxnSpPr/>
           <p:nvPr/>
         </p:nvCxnSpPr>
@@ -28764,7 +29288,7 @@
       </p:cxnSp>
       <p:sp>
         <p:nvSpPr>
-          <p:cNvPr id="20" name="TextBox 19"/>
+          <p:cNvPr id="21" name="TextBox 20"/>
           <p:cNvSpPr txBox="1"/>
           <p:nvPr/>
         </p:nvSpPr>
@@ -28801,7 +29325,7 @@
       </p:sp>
       <p:sp>
         <p:nvSpPr>
-          <p:cNvPr id="21" name="TextBox 20"/>
+          <p:cNvPr id="22" name="TextBox 21"/>
           <p:cNvSpPr txBox="1"/>
           <p:nvPr/>
         </p:nvSpPr>
@@ -28838,7 +29362,7 @@
       </p:sp>
       <p:sp>
         <p:nvSpPr>
-          <p:cNvPr id="22" name="TextBox 21"/>
+          <p:cNvPr id="23" name="TextBox 22"/>
           <p:cNvSpPr txBox="1"/>
           <p:nvPr/>
         </p:nvSpPr>
@@ -28896,7 +29420,7 @@
       </p:sp>
       <p:sp>
         <p:nvSpPr>
-          <p:cNvPr id="23" name="Rounded Rectangle 22"/>
+          <p:cNvPr id="24" name="Rounded Rectangle 23"/>
           <p:cNvSpPr/>
           <p:nvPr/>
         </p:nvSpPr>
@@ -28939,7 +29463,7 @@
       </p:sp>
       <p:sp>
         <p:nvSpPr>
-          <p:cNvPr id="24" name="TextBox 23"/>
+          <p:cNvPr id="25" name="TextBox 24"/>
           <p:cNvSpPr txBox="1"/>
           <p:nvPr/>
         </p:nvSpPr>
@@ -28976,7 +29500,7 @@
       </p:sp>
       <p:sp>
         <p:nvSpPr>
-          <p:cNvPr id="25" name="Rounded Rectangle 24"/>
+          <p:cNvPr id="26" name="Rounded Rectangle 25"/>
           <p:cNvSpPr/>
           <p:nvPr/>
         </p:nvSpPr>
@@ -29014,7 +29538,7 @@
       </p:sp>
       <p:sp>
         <p:nvSpPr>
-          <p:cNvPr id="26" name="TextBox 25"/>
+          <p:cNvPr id="27" name="TextBox 26"/>
           <p:cNvSpPr txBox="1"/>
           <p:nvPr/>
         </p:nvSpPr>
@@ -29051,7 +29575,7 @@
       </p:sp>
       <p:cxnSp>
         <p:nvCxnSpPr>
-          <p:cNvPr id="27" name="Connector 26"/>
+          <p:cNvPr id="28" name="Connector 27"/>
           <p:cNvCxnSpPr/>
           <p:nvPr/>
         </p:nvCxnSpPr>
@@ -29072,7 +29596,7 @@
       </p:cxnSp>
       <p:sp>
         <p:nvSpPr>
-          <p:cNvPr id="28" name="TextBox 27"/>
+          <p:cNvPr id="29" name="TextBox 28"/>
           <p:cNvSpPr txBox="1"/>
           <p:nvPr/>
         </p:nvSpPr>
@@ -29119,7 +29643,7 @@
       </p:sp>
       <p:sp>
         <p:nvSpPr>
-          <p:cNvPr id="29" name="TextBox 28"/>
+          <p:cNvPr id="30" name="TextBox 29"/>
           <p:cNvSpPr txBox="1"/>
           <p:nvPr/>
         </p:nvSpPr>
@@ -29160,7 +29684,7 @@
       </p:sp>
       <p:sp>
         <p:nvSpPr>
-          <p:cNvPr id="30" name="Rounded Rectangle 29"/>
+          <p:cNvPr id="31" name="Rounded Rectangle 30"/>
           <p:cNvSpPr/>
           <p:nvPr/>
         </p:nvSpPr>
@@ -29198,7 +29722,7 @@
       </p:sp>
       <p:sp>
         <p:nvSpPr>
-          <p:cNvPr id="31" name="TextBox 30"/>
+          <p:cNvPr id="32" name="TextBox 31"/>
           <p:cNvSpPr txBox="1"/>
           <p:nvPr/>
         </p:nvSpPr>
@@ -29235,7 +29759,7 @@
       </p:sp>
       <p:cxnSp>
         <p:nvCxnSpPr>
-          <p:cNvPr id="32" name="Connector 31"/>
+          <p:cNvPr id="33" name="Connector 32"/>
           <p:cNvCxnSpPr/>
           <p:nvPr/>
         </p:nvCxnSpPr>
@@ -29256,7 +29780,7 @@
       </p:cxnSp>
       <p:sp>
         <p:nvSpPr>
-          <p:cNvPr id="33" name="TextBox 32"/>
+          <p:cNvPr id="34" name="TextBox 33"/>
           <p:cNvSpPr txBox="1"/>
           <p:nvPr/>
         </p:nvSpPr>
@@ -29303,7 +29827,7 @@
       </p:sp>
       <p:sp>
         <p:nvSpPr>
-          <p:cNvPr id="34" name="TextBox 33"/>
+          <p:cNvPr id="35" name="TextBox 34"/>
           <p:cNvSpPr txBox="1"/>
           <p:nvPr/>
         </p:nvSpPr>
@@ -29344,7 +29868,7 @@
       </p:sp>
       <p:sp>
         <p:nvSpPr>
-          <p:cNvPr id="35" name="Rounded Rectangle 34"/>
+          <p:cNvPr id="36" name="Rounded Rectangle 35"/>
           <p:cNvSpPr/>
           <p:nvPr/>
         </p:nvSpPr>
@@ -29382,7 +29906,7 @@
       </p:sp>
       <p:sp>
         <p:nvSpPr>
-          <p:cNvPr id="36" name="TextBox 35"/>
+          <p:cNvPr id="37" name="TextBox 36"/>
           <p:cNvSpPr txBox="1"/>
           <p:nvPr/>
         </p:nvSpPr>
@@ -29419,7 +29943,7 @@
       </p:sp>
       <p:cxnSp>
         <p:nvCxnSpPr>
-          <p:cNvPr id="37" name="Connector 36"/>
+          <p:cNvPr id="38" name="Connector 37"/>
           <p:cNvCxnSpPr/>
           <p:nvPr/>
         </p:nvCxnSpPr>
@@ -29440,7 +29964,7 @@
       </p:cxnSp>
       <p:sp>
         <p:nvSpPr>
-          <p:cNvPr id="38" name="TextBox 37"/>
+          <p:cNvPr id="39" name="TextBox 38"/>
           <p:cNvSpPr txBox="1"/>
           <p:nvPr/>
         </p:nvSpPr>
@@ -29487,7 +30011,7 @@
       </p:sp>
       <p:sp>
         <p:nvSpPr>
-          <p:cNvPr id="39" name="TextBox 38"/>
+          <p:cNvPr id="40" name="TextBox 39"/>
           <p:cNvSpPr txBox="1"/>
           <p:nvPr/>
         </p:nvSpPr>
@@ -29528,7 +30052,7 @@
       </p:sp>
       <p:sp>
         <p:nvSpPr>
-          <p:cNvPr id="40" name="TextBox 39"/>
+          <p:cNvPr id="41" name="TextBox 40"/>
           <p:cNvSpPr txBox="1"/>
           <p:nvPr/>
         </p:nvSpPr>
@@ -29623,17 +30147,17 @@
         </p:nvSpPr>
         <p:spPr>
           <a:xfrm>
-            <a:off x="411480" y="155448"/>
-            <a:ext cx="822960" cy="548640"/>
-          </a:xfrm>
-        </p:spPr>
-        <p:txBody>
-          <a:bodyPr anchor="ctr" lIns="0"/>
+            <a:off x="384048" y="6455664"/>
+            <a:ext cx="731520" cy="237744"/>
+          </a:xfrm>
+        </p:spPr>
+        <p:txBody>
+          <a:bodyPr anchor="ctr" lIns="0" tIns="0" bIns="0"/>
           <a:lstStyle/>
           <a:p>
             <a:pPr algn="l"/>
             <a:fld id="{679EF615-E246-4FA6-9E75-123AAEB83405}" type="slidenum">
-              <a:rPr lang="en-US" smtClean="0" sz="1200" b="1">
+              <a:rPr lang="en-US" smtClean="0" sz="1050" b="1">
                 <a:solidFill>
                   <a:srgbClr val="2A206A"/>
                 </a:solidFill>
@@ -29655,8 +30179,8 @@
         </p:nvSpPr>
         <p:spPr>
           <a:xfrm>
-            <a:off x="1234440" y="155448"/>
-            <a:ext cx="10561320" cy="548640"/>
+            <a:off x="411480" y="155448"/>
+            <a:ext cx="11384280" cy="548640"/>
           </a:xfrm>
           <a:prstGeom prst="rect">
             <a:avLst/>
@@ -29694,9 +30218,46 @@
           </a:p>
         </p:txBody>
       </p:sp>
+      <p:sp>
+        <p:nvSpPr>
+          <p:cNvPr id="4" name="TextBox 3"/>
+          <p:cNvSpPr txBox="1"/>
+          <p:nvPr/>
+        </p:nvSpPr>
+        <p:spPr>
+          <a:xfrm>
+            <a:off x="6583680" y="6254496"/>
+            <a:ext cx="5120640" cy="237744"/>
+          </a:xfrm>
+          <a:prstGeom prst="rect">
+            <a:avLst/>
+          </a:prstGeom>
+          <a:noFill/>
+        </p:spPr>
+        <p:txBody>
+          <a:bodyPr wrap="square" lIns="0" rIns="0" tIns="0" bIns="0" anchor="ctr">
+            <a:spAutoFit/>
+            <a:noAutofit/>
+          </a:bodyPr>
+          <a:lstStyle/>
+          <a:p>
+            <a:pPr algn="r" rtl="1"/>
+            <a:r>
+              <a:rPr lang="ar-SA" sz="900" b="0" dirty="0">
+                <a:solidFill>
+                  <a:srgbClr val="6E6E86"/>
+                </a:solidFill>
+                <a:latin typeface="DiodrumArabic-Regular" pitchFamily="2" charset="-78"/>
+                <a:cs typeface="DiodrumArabic-Regular" pitchFamily="2" charset="-78"/>
+              </a:rPr>
+              <a:t>برنامج القدرات الرقمية «قدراتك»   |   تقرير سير الأعمال الربعي – يونيو – أغسطس 2026</a:t>
+            </a:r>
+          </a:p>
+        </p:txBody>
+      </p:sp>
       <p:cxnSp>
         <p:nvCxnSpPr>
-          <p:cNvPr id="4" name="Connector 3"/>
+          <p:cNvPr id="5" name="Connector 4"/>
           <p:cNvCxnSpPr/>
           <p:nvPr/>
         </p:nvCxnSpPr>
@@ -29725,7 +30286,7 @@
       </p:cxnSp>
       <p:sp>
         <p:nvSpPr>
-          <p:cNvPr id="5" name="TextBox 4"/>
+          <p:cNvPr id="6" name="TextBox 5"/>
           <p:cNvSpPr txBox="1"/>
           <p:nvPr/>
         </p:nvSpPr>
@@ -29762,7 +30323,7 @@
       </p:sp>
       <p:sp>
         <p:nvSpPr>
-          <p:cNvPr id="6" name="Rounded Rectangle 5"/>
+          <p:cNvPr id="7" name="Rounded Rectangle 6"/>
           <p:cNvSpPr/>
           <p:nvPr/>
         </p:nvSpPr>
@@ -29806,7 +30367,7 @@
       </p:sp>
       <p:sp>
         <p:nvSpPr>
-          <p:cNvPr id="7" name="TextBox 6"/>
+          <p:cNvPr id="8" name="TextBox 7"/>
           <p:cNvSpPr txBox="1"/>
           <p:nvPr/>
         </p:nvSpPr>
@@ -29843,7 +30404,7 @@
       </p:sp>
       <p:sp>
         <p:nvSpPr>
-          <p:cNvPr id="8" name="TextBox 7"/>
+          <p:cNvPr id="9" name="TextBox 8"/>
           <p:cNvSpPr txBox="1"/>
           <p:nvPr/>
         </p:nvSpPr>
@@ -29901,7 +30462,7 @@
       </p:sp>
       <p:cxnSp>
         <p:nvCxnSpPr>
-          <p:cNvPr id="9" name="Connector 8"/>
+          <p:cNvPr id="10" name="Connector 9"/>
           <p:cNvCxnSpPr/>
           <p:nvPr/>
         </p:nvCxnSpPr>
@@ -29922,7 +30483,7 @@
       </p:cxnSp>
       <p:sp>
         <p:nvSpPr>
-          <p:cNvPr id="10" name="Rounded Rectangle 9"/>
+          <p:cNvPr id="11" name="Rounded Rectangle 10"/>
           <p:cNvSpPr/>
           <p:nvPr/>
         </p:nvSpPr>
@@ -29965,7 +30526,7 @@
       </p:sp>
       <p:sp>
         <p:nvSpPr>
-          <p:cNvPr id="11" name="Rounded Rectangle 10"/>
+          <p:cNvPr id="12" name="Rounded Rectangle 11"/>
           <p:cNvSpPr/>
           <p:nvPr/>
         </p:nvSpPr>
@@ -30008,7 +30569,7 @@
       </p:sp>
       <p:sp>
         <p:nvSpPr>
-          <p:cNvPr id="12" name="Rounded Rectangle 11"/>
+          <p:cNvPr id="13" name="Rounded Rectangle 12"/>
           <p:cNvSpPr/>
           <p:nvPr/>
         </p:nvSpPr>
@@ -30051,7 +30612,7 @@
       </p:sp>
       <p:sp>
         <p:nvSpPr>
-          <p:cNvPr id="13" name="Rounded Rectangle 12"/>
+          <p:cNvPr id="14" name="Rounded Rectangle 13"/>
           <p:cNvSpPr/>
           <p:nvPr/>
         </p:nvSpPr>
@@ -30089,7 +30650,7 @@
       </p:sp>
       <p:sp>
         <p:nvSpPr>
-          <p:cNvPr id="14" name="TextBox 13"/>
+          <p:cNvPr id="15" name="TextBox 14"/>
           <p:cNvSpPr txBox="1"/>
           <p:nvPr/>
         </p:nvSpPr>
@@ -30126,7 +30687,7 @@
       </p:sp>
       <p:cxnSp>
         <p:nvCxnSpPr>
-          <p:cNvPr id="15" name="Connector 14"/>
+          <p:cNvPr id="16" name="Connector 15"/>
           <p:cNvCxnSpPr/>
           <p:nvPr/>
         </p:nvCxnSpPr>
@@ -30147,7 +30708,7 @@
       </p:cxnSp>
       <p:sp>
         <p:nvSpPr>
-          <p:cNvPr id="16" name="TextBox 15"/>
+          <p:cNvPr id="17" name="TextBox 16"/>
           <p:cNvSpPr txBox="1"/>
           <p:nvPr/>
         </p:nvSpPr>
@@ -30194,7 +30755,7 @@
       </p:sp>
       <p:sp>
         <p:nvSpPr>
-          <p:cNvPr id="17" name="TextBox 16"/>
+          <p:cNvPr id="18" name="TextBox 17"/>
           <p:cNvSpPr txBox="1"/>
           <p:nvPr/>
         </p:nvSpPr>
@@ -30231,7 +30792,7 @@
       </p:sp>
       <p:sp>
         <p:nvSpPr>
-          <p:cNvPr id="18" name="Rounded Rectangle 17"/>
+          <p:cNvPr id="19" name="Rounded Rectangle 18"/>
           <p:cNvSpPr/>
           <p:nvPr/>
         </p:nvSpPr>
@@ -30274,7 +30835,7 @@
       </p:sp>
       <p:sp>
         <p:nvSpPr>
-          <p:cNvPr id="19" name="Rounded Rectangle 18"/>
+          <p:cNvPr id="20" name="Rounded Rectangle 19"/>
           <p:cNvSpPr/>
           <p:nvPr/>
         </p:nvSpPr>
@@ -30317,7 +30878,7 @@
       </p:sp>
       <p:sp>
         <p:nvSpPr>
-          <p:cNvPr id="20" name="Rounded Rectangle 19"/>
+          <p:cNvPr id="21" name="Rounded Rectangle 20"/>
           <p:cNvSpPr/>
           <p:nvPr/>
         </p:nvSpPr>
@@ -30355,7 +30916,7 @@
       </p:sp>
       <p:sp>
         <p:nvSpPr>
-          <p:cNvPr id="21" name="TextBox 20"/>
+          <p:cNvPr id="22" name="TextBox 21"/>
           <p:cNvSpPr txBox="1"/>
           <p:nvPr/>
         </p:nvSpPr>
@@ -30392,7 +30953,7 @@
       </p:sp>
       <p:cxnSp>
         <p:nvCxnSpPr>
-          <p:cNvPr id="22" name="Connector 21"/>
+          <p:cNvPr id="23" name="Connector 22"/>
           <p:cNvCxnSpPr/>
           <p:nvPr/>
         </p:nvCxnSpPr>
@@ -30413,7 +30974,7 @@
       </p:cxnSp>
       <p:sp>
         <p:nvSpPr>
-          <p:cNvPr id="23" name="TextBox 22"/>
+          <p:cNvPr id="24" name="TextBox 23"/>
           <p:cNvSpPr txBox="1"/>
           <p:nvPr/>
         </p:nvSpPr>
@@ -30460,7 +31021,7 @@
       </p:sp>
       <p:sp>
         <p:nvSpPr>
-          <p:cNvPr id="24" name="TextBox 23"/>
+          <p:cNvPr id="25" name="TextBox 24"/>
           <p:cNvSpPr txBox="1"/>
           <p:nvPr/>
         </p:nvSpPr>
@@ -30497,7 +31058,7 @@
       </p:sp>
       <p:sp>
         <p:nvSpPr>
-          <p:cNvPr id="25" name="Rounded Rectangle 24"/>
+          <p:cNvPr id="26" name="Rounded Rectangle 25"/>
           <p:cNvSpPr/>
           <p:nvPr/>
         </p:nvSpPr>
@@ -30540,7 +31101,7 @@
       </p:sp>
       <p:sp>
         <p:nvSpPr>
-          <p:cNvPr id="26" name="Rounded Rectangle 25"/>
+          <p:cNvPr id="27" name="Rounded Rectangle 26"/>
           <p:cNvSpPr/>
           <p:nvPr/>
         </p:nvSpPr>
@@ -30583,7 +31144,7 @@
       </p:sp>
       <p:sp>
         <p:nvSpPr>
-          <p:cNvPr id="27" name="TextBox 26"/>
+          <p:cNvPr id="28" name="TextBox 27"/>
           <p:cNvSpPr txBox="1"/>
           <p:nvPr/>
         </p:nvSpPr>
@@ -30620,7 +31181,7 @@
       </p:sp>
       <p:sp>
         <p:nvSpPr>
-          <p:cNvPr id="28" name="Rounded Rectangle 27"/>
+          <p:cNvPr id="29" name="Rounded Rectangle 28"/>
           <p:cNvSpPr/>
           <p:nvPr/>
         </p:nvSpPr>
@@ -30658,7 +31219,7 @@
       </p:sp>
       <p:sp>
         <p:nvSpPr>
-          <p:cNvPr id="29" name="TextBox 28"/>
+          <p:cNvPr id="30" name="TextBox 29"/>
           <p:cNvSpPr txBox="1"/>
           <p:nvPr/>
         </p:nvSpPr>
@@ -30695,7 +31256,7 @@
       </p:sp>
       <p:cxnSp>
         <p:nvCxnSpPr>
-          <p:cNvPr id="30" name="Connector 29"/>
+          <p:cNvPr id="31" name="Connector 30"/>
           <p:cNvCxnSpPr/>
           <p:nvPr/>
         </p:nvCxnSpPr>
@@ -30716,7 +31277,7 @@
       </p:cxnSp>
       <p:sp>
         <p:nvSpPr>
-          <p:cNvPr id="31" name="TextBox 30"/>
+          <p:cNvPr id="32" name="TextBox 31"/>
           <p:cNvSpPr txBox="1"/>
           <p:nvPr/>
         </p:nvSpPr>
@@ -30763,7 +31324,7 @@
       </p:sp>
       <p:sp>
         <p:nvSpPr>
-          <p:cNvPr id="32" name="TextBox 31"/>
+          <p:cNvPr id="33" name="TextBox 32"/>
           <p:cNvSpPr txBox="1"/>
           <p:nvPr/>
         </p:nvSpPr>
@@ -30800,7 +31361,7 @@
       </p:sp>
       <p:sp>
         <p:nvSpPr>
-          <p:cNvPr id="33" name="Rounded Rectangle 32"/>
+          <p:cNvPr id="34" name="Rounded Rectangle 33"/>
           <p:cNvSpPr/>
           <p:nvPr/>
         </p:nvSpPr>
@@ -30843,7 +31404,7 @@
       </p:sp>
       <p:sp>
         <p:nvSpPr>
-          <p:cNvPr id="34" name="Rounded Rectangle 33"/>
+          <p:cNvPr id="35" name="Rounded Rectangle 34"/>
           <p:cNvSpPr/>
           <p:nvPr/>
         </p:nvSpPr>
@@ -30886,7 +31447,7 @@
       </p:sp>
       <p:sp>
         <p:nvSpPr>
-          <p:cNvPr id="35" name="TextBox 34"/>
+          <p:cNvPr id="36" name="TextBox 35"/>
           <p:cNvSpPr txBox="1"/>
           <p:nvPr/>
         </p:nvSpPr>
@@ -30923,7 +31484,7 @@
       </p:sp>
       <p:sp>
         <p:nvSpPr>
-          <p:cNvPr id="36" name="Rounded Rectangle 35"/>
+          <p:cNvPr id="37" name="Rounded Rectangle 36"/>
           <p:cNvSpPr/>
           <p:nvPr/>
         </p:nvSpPr>
@@ -30961,7 +31522,7 @@
       </p:sp>
       <p:sp>
         <p:nvSpPr>
-          <p:cNvPr id="37" name="TextBox 36"/>
+          <p:cNvPr id="38" name="TextBox 37"/>
           <p:cNvSpPr txBox="1"/>
           <p:nvPr/>
         </p:nvSpPr>
@@ -30998,7 +31559,7 @@
       </p:sp>
       <p:graphicFrame>
         <p:nvGraphicFramePr>
-          <p:cNvPr id="38" name="Chart 37"/>
+          <p:cNvPr id="39" name="Chart 38"/>
           <p:cNvGraphicFramePr>
             <a:graphicFrameLocks noGrp="1"/>
           </p:cNvGraphicFramePr>
@@ -31016,7 +31577,7 @@
       </p:graphicFrame>
       <p:sp>
         <p:nvSpPr>
-          <p:cNvPr id="39" name="TextBox 38"/>
+          <p:cNvPr id="40" name="TextBox 39"/>
           <p:cNvSpPr txBox="1"/>
           <p:nvPr/>
         </p:nvSpPr>
@@ -31436,12 +31997,12 @@
         </p:nvSpPr>
         <p:spPr>
           <a:xfrm>
-            <a:off x="411480" y="402336"/>
-            <a:ext cx="822960" cy="640080"/>
-          </a:xfrm>
-        </p:spPr>
-        <p:txBody>
-          <a:bodyPr anchor="ctr" lIns="0"/>
+            <a:off x="384048" y="6455664"/>
+            <a:ext cx="731520" cy="237744"/>
+          </a:xfrm>
+        </p:spPr>
+        <p:txBody>
+          <a:bodyPr anchor="ctr" lIns="0" tIns="0" bIns="0"/>
           <a:lstStyle/>
           <a:p>
             <a:pPr marL="0" marR="0" lvl="0" indent="0" algn="l" defTabSz="914400" rtl="0" eaLnBrk="1" fontAlgn="auto" latinLnBrk="0" hangingPunct="1">
@@ -31464,7 +32025,7 @@
               <a:defRPr/>
             </a:pPr>
             <a:fld id="{679EF615-E246-4FA6-9E75-123AAEB83405}" type="slidenum">
-              <a:rPr kumimoji="0" lang="en-US" sz="1200" b="1" i="0" u="none" strike="noStrike" kern="0" cap="none" spc="0" normalizeH="0" baseline="0" noProof="0" smtClean="0">
+              <a:rPr kumimoji="0" lang="en-US" sz="1050" b="1" i="0" u="none" strike="noStrike" kern="0" cap="none" spc="0" normalizeH="0" baseline="0" noProof="0" smtClean="0">
                 <a:solidFill>
                   <a:srgbClr val="2A206A"/>
                 </a:solidFill>
@@ -31514,6 +32075,43 @@
       <p:sp>
         <p:nvSpPr>
           <p:cNvPr id="81" name="TextBox 80"/>
+          <p:cNvSpPr txBox="1"/>
+          <p:nvPr/>
+        </p:nvSpPr>
+        <p:spPr>
+          <a:xfrm>
+            <a:off x="6583680" y="6254496"/>
+            <a:ext cx="5120640" cy="237744"/>
+          </a:xfrm>
+          <a:prstGeom prst="rect">
+            <a:avLst/>
+          </a:prstGeom>
+          <a:noFill/>
+        </p:spPr>
+        <p:txBody>
+          <a:bodyPr wrap="square" lIns="0" rIns="0" tIns="0" bIns="0" anchor="ctr">
+            <a:spAutoFit/>
+            <a:noAutofit/>
+          </a:bodyPr>
+          <a:lstStyle/>
+          <a:p>
+            <a:pPr algn="r" rtl="1"/>
+            <a:r>
+              <a:rPr lang="ar-SA" sz="900" b="0" dirty="0">
+                <a:solidFill>
+                  <a:srgbClr val="6E6E86"/>
+                </a:solidFill>
+                <a:latin typeface="DiodrumArabic-Regular" pitchFamily="2" charset="-78"/>
+                <a:cs typeface="DiodrumArabic-Regular" pitchFamily="2" charset="-78"/>
+              </a:rPr>
+              <a:t>برنامج القدرات الرقمية «قدراتك»   |   تقرير سير الأعمال الربعي – يونيو – أغسطس 2026</a:t>
+            </a:r>
+          </a:p>
+        </p:txBody>
+      </p:sp>
+      <p:sp>
+        <p:nvSpPr>
+          <p:cNvPr id="82" name="TextBox 81"/>
           <p:cNvSpPr txBox="1"/>
           <p:nvPr/>
         </p:nvSpPr>
@@ -31608,12 +32206,12 @@
         </p:nvSpPr>
         <p:spPr>
           <a:xfrm>
-            <a:off x="411480" y="155448"/>
-            <a:ext cx="822960" cy="548640"/>
-          </a:xfrm>
-        </p:spPr>
-        <p:txBody>
-          <a:bodyPr anchor="ctr" lIns="0"/>
+            <a:off x="384048" y="6455664"/>
+            <a:ext cx="731520" cy="237744"/>
+          </a:xfrm>
+        </p:spPr>
+        <p:txBody>
+          <a:bodyPr anchor="ctr" lIns="0" tIns="0" bIns="0"/>
           <a:lstStyle/>
           <a:p>
             <a:pPr marL="0" marR="0" lvl="0" indent="0" algn="l" defTabSz="914400" rtl="0" eaLnBrk="1" fontAlgn="auto" latinLnBrk="0" hangingPunct="1">
@@ -31636,7 +32234,7 @@
               <a:defRPr/>
             </a:pPr>
             <a:fld id="{679EF615-E246-4FA6-9E75-123AAEB83405}" type="slidenum">
-              <a:rPr kumimoji="0" lang="en-US" sz="1200" b="1" i="0" u="none" strike="noStrike" kern="0" cap="none" spc="0" normalizeH="0" baseline="0" noProof="0" smtClean="0">
+              <a:rPr kumimoji="0" lang="en-US" sz="1050" b="1" i="0" u="none" strike="noStrike" kern="0" cap="none" spc="0" normalizeH="0" baseline="0" noProof="0" smtClean="0">
                 <a:solidFill>
                   <a:srgbClr val="2A206A"/>
                 </a:solidFill>
@@ -31691,8 +32289,8 @@
         </p:nvSpPr>
         <p:spPr>
           <a:xfrm>
-            <a:off x="1234440" y="155448"/>
-            <a:ext cx="10561320" cy="548640"/>
+            <a:off x="411480" y="155448"/>
+            <a:ext cx="11384280" cy="548640"/>
           </a:xfrm>
           <a:prstGeom prst="rect">
             <a:avLst/>
@@ -31730,9 +32328,46 @@
           </a:p>
         </p:txBody>
       </p:sp>
+      <p:sp>
+        <p:nvSpPr>
+          <p:cNvPr id="4" name="TextBox 3"/>
+          <p:cNvSpPr txBox="1"/>
+          <p:nvPr/>
+        </p:nvSpPr>
+        <p:spPr>
+          <a:xfrm>
+            <a:off x="6583680" y="6254496"/>
+            <a:ext cx="5120640" cy="237744"/>
+          </a:xfrm>
+          <a:prstGeom prst="rect">
+            <a:avLst/>
+          </a:prstGeom>
+          <a:noFill/>
+        </p:spPr>
+        <p:txBody>
+          <a:bodyPr wrap="square" lIns="0" rIns="0" tIns="0" bIns="0" anchor="ctr">
+            <a:spAutoFit/>
+            <a:noAutofit/>
+          </a:bodyPr>
+          <a:lstStyle/>
+          <a:p>
+            <a:pPr algn="r" rtl="1"/>
+            <a:r>
+              <a:rPr lang="ar-SA" sz="900" b="0" dirty="0">
+                <a:solidFill>
+                  <a:srgbClr val="6E6E86"/>
+                </a:solidFill>
+                <a:latin typeface="DiodrumArabic-Regular" pitchFamily="2" charset="-78"/>
+                <a:cs typeface="DiodrumArabic-Regular" pitchFamily="2" charset="-78"/>
+              </a:rPr>
+              <a:t>برنامج القدرات الرقمية «قدراتك»   |   تقرير سير الأعمال الربعي – يونيو – أغسطس 2026</a:t>
+            </a:r>
+          </a:p>
+        </p:txBody>
+      </p:sp>
       <p:cxnSp>
         <p:nvCxnSpPr>
-          <p:cNvPr id="4" name="Connector 3"/>
+          <p:cNvPr id="5" name="Connector 4"/>
           <p:cNvCxnSpPr/>
           <p:nvPr/>
         </p:nvCxnSpPr>
@@ -31761,7 +32396,7 @@
       </p:cxnSp>
       <p:sp>
         <p:nvSpPr>
-          <p:cNvPr id="5" name="TextBox 4"/>
+          <p:cNvPr id="6" name="TextBox 5"/>
           <p:cNvSpPr txBox="1"/>
           <p:nvPr/>
         </p:nvSpPr>
@@ -31798,7 +32433,7 @@
       </p:sp>
       <p:sp>
         <p:nvSpPr>
-          <p:cNvPr id="6" name="Rounded Rectangle 5"/>
+          <p:cNvPr id="7" name="Rounded Rectangle 6"/>
           <p:cNvSpPr/>
           <p:nvPr/>
         </p:nvSpPr>
@@ -31842,7 +32477,7 @@
       </p:sp>
       <p:sp>
         <p:nvSpPr>
-          <p:cNvPr id="7" name="TextBox 6"/>
+          <p:cNvPr id="8" name="TextBox 7"/>
           <p:cNvSpPr txBox="1"/>
           <p:nvPr/>
         </p:nvSpPr>
@@ -31879,7 +32514,7 @@
       </p:sp>
       <p:sp>
         <p:nvSpPr>
-          <p:cNvPr id="8" name="TextBox 7"/>
+          <p:cNvPr id="9" name="TextBox 8"/>
           <p:cNvSpPr txBox="1"/>
           <p:nvPr/>
         </p:nvSpPr>
@@ -31937,7 +32572,7 @@
       </p:sp>
       <p:cxnSp>
         <p:nvCxnSpPr>
-          <p:cNvPr id="9" name="Connector 8"/>
+          <p:cNvPr id="10" name="Connector 9"/>
           <p:cNvCxnSpPr/>
           <p:nvPr/>
         </p:nvCxnSpPr>
@@ -31958,7 +32593,7 @@
       </p:cxnSp>
       <p:pic>
         <p:nvPicPr>
-          <p:cNvPr id="10" name="Picture 9" descr="image.png"/>
+          <p:cNvPr id="11" name="Picture 10" descr="image.png"/>
           <p:cNvPicPr>
             <a:picLocks noChangeAspect="1"/>
           </p:cNvPicPr>
@@ -31982,7 +32617,7 @@
       </p:pic>
       <p:sp>
         <p:nvSpPr>
-          <p:cNvPr id="11" name="TextBox 10"/>
+          <p:cNvPr id="12" name="TextBox 11"/>
           <p:cNvSpPr txBox="1"/>
           <p:nvPr/>
         </p:nvSpPr>
@@ -32029,7 +32664,7 @@
       </p:sp>
       <p:pic>
         <p:nvPicPr>
-          <p:cNvPr id="12" name="Picture 11" descr="image.png"/>
+          <p:cNvPr id="13" name="Picture 12" descr="image.png"/>
           <p:cNvPicPr>
             <a:picLocks noChangeAspect="1"/>
           </p:cNvPicPr>
@@ -32053,7 +32688,7 @@
       </p:pic>
       <p:sp>
         <p:nvSpPr>
-          <p:cNvPr id="13" name="TextBox 12"/>
+          <p:cNvPr id="14" name="TextBox 13"/>
           <p:cNvSpPr txBox="1"/>
           <p:nvPr/>
         </p:nvSpPr>
@@ -32100,7 +32735,7 @@
       </p:sp>
       <p:sp>
         <p:nvSpPr>
-          <p:cNvPr id="14" name="Rounded Rectangle 13"/>
+          <p:cNvPr id="15" name="Rounded Rectangle 14"/>
           <p:cNvSpPr/>
           <p:nvPr/>
         </p:nvSpPr>
@@ -32131,7 +32766,7 @@
       </p:sp>
       <p:sp>
         <p:nvSpPr>
-          <p:cNvPr id="15" name="TextBox 14"/>
+          <p:cNvPr id="16" name="TextBox 15"/>
           <p:cNvSpPr txBox="1"/>
           <p:nvPr/>
         </p:nvSpPr>
@@ -32182,7 +32817,7 @@
       </p:sp>
       <p:sp>
         <p:nvSpPr>
-          <p:cNvPr id="16" name="TextBox 15"/>
+          <p:cNvPr id="17" name="TextBox 16"/>
           <p:cNvSpPr txBox="1"/>
           <p:nvPr/>
         </p:nvSpPr>
@@ -32219,7 +32854,7 @@
       </p:sp>
       <p:graphicFrame>
         <p:nvGraphicFramePr>
-          <p:cNvPr id="17" name="Table 16"/>
+          <p:cNvPr id="18" name="Table 17"/>
           <p:cNvGraphicFramePr>
             <a:graphicFrameLocks noGrp="1"/>
           </p:cNvGraphicFramePr>
@@ -33409,7 +34044,7 @@
       </p:graphicFrame>
       <p:pic>
         <p:nvPicPr>
-          <p:cNvPr id="18" name="Picture 17" descr="image.png"/>
+          <p:cNvPr id="19" name="Picture 18" descr="image.png"/>
           <p:cNvPicPr>
             <a:picLocks noChangeAspect="1"/>
           </p:cNvPicPr>
@@ -33433,7 +34068,7 @@
       </p:pic>
       <p:pic>
         <p:nvPicPr>
-          <p:cNvPr id="19" name="Picture 18" descr="image.png"/>
+          <p:cNvPr id="20" name="Picture 19" descr="image.png"/>
           <p:cNvPicPr>
             <a:picLocks noChangeAspect="1"/>
           </p:cNvPicPr>
@@ -33457,7 +34092,7 @@
       </p:pic>
       <p:pic>
         <p:nvPicPr>
-          <p:cNvPr id="20" name="Picture 19" descr="image.png"/>
+          <p:cNvPr id="21" name="Picture 20" descr="image.png"/>
           <p:cNvPicPr>
             <a:picLocks noChangeAspect="1"/>
           </p:cNvPicPr>
@@ -33481,7 +34116,7 @@
       </p:pic>
       <p:sp>
         <p:nvSpPr>
-          <p:cNvPr id="21" name="TextBox 20"/>
+          <p:cNvPr id="22" name="TextBox 21"/>
           <p:cNvSpPr txBox="1"/>
           <p:nvPr/>
         </p:nvSpPr>

</xml_diff>